<commit_message>
Clear template authoring notes from all slides
The template-starter.pptx embedded generic layout hints ("Use this as
the cover slide…") in every slide's notes pane. The post-processor now
wipes all <a:t> text from notesSlides/*.xml before repacking the zip.

Co-Authored-By: Claude Sonnet 4.6 <noreply@anthropic.com>
</commit_message>
<xml_diff>
--- a/presentation/output/transfer-learning-meta-analysis-ichi-2026-talk.pptx
+++ b/presentation/output/transfer-learning-meta-analysis-ichi-2026-talk.pptx
@@ -2,24 +2,24 @@
 <file path=ppt/presentation.xml><?xml version="1.0" encoding="utf-8"?>
 <p:presentation xmlns:p="http://schemas.openxmlformats.org/presentationml/2006/main">
   <p:sldMasterIdLst>
-    <p:sldMasterId xmlns:r="http://schemas.openxmlformats.org/officeDocument/2006/relationships" id="2147483648" r:id="R8a6c989738824630"/>
+    <p:sldMasterId xmlns:r="http://schemas.openxmlformats.org/officeDocument/2006/relationships" id="2147483648" r:id="R5e4868bed4954b21"/>
   </p:sldMasterIdLst>
   <p:notesMasterIdLst>
-    <p:notesMasterId xmlns:r="http://schemas.openxmlformats.org/officeDocument/2006/relationships" r:id="R01b881a5b7f84167"/>
+    <p:notesMasterId xmlns:r="http://schemas.openxmlformats.org/officeDocument/2006/relationships" r:id="R7bfcf21c2128479f"/>
   </p:notesMasterIdLst>
   <p:sldIdLst>
-    <p:sldId xmlns:r="http://schemas.openxmlformats.org/officeDocument/2006/relationships" id="256" r:id="R64d0469aa8a0456c"/>
-    <p:sldId xmlns:r="http://schemas.openxmlformats.org/officeDocument/2006/relationships" id="257" r:id="Rabb01aa7c5574bf6"/>
-    <p:sldId xmlns:r="http://schemas.openxmlformats.org/officeDocument/2006/relationships" id="258" r:id="R5dd89594d0f3429d"/>
-    <p:sldId xmlns:r="http://schemas.openxmlformats.org/officeDocument/2006/relationships" id="259" r:id="R91e2d76873f54dba"/>
-    <p:sldId xmlns:r="http://schemas.openxmlformats.org/officeDocument/2006/relationships" id="260" r:id="Rd7cdba0e120148d4"/>
-    <p:sldId xmlns:r="http://schemas.openxmlformats.org/officeDocument/2006/relationships" id="261" r:id="R8ab94302039848a0"/>
-    <p:sldId xmlns:r="http://schemas.openxmlformats.org/officeDocument/2006/relationships" id="262" r:id="Rf9b228ced1814f82"/>
-    <p:sldId xmlns:r="http://schemas.openxmlformats.org/officeDocument/2006/relationships" id="263" r:id="Rf23ba44fff6f4648"/>
-    <p:sldId xmlns:r="http://schemas.openxmlformats.org/officeDocument/2006/relationships" id="264" r:id="R8cdc3f85b2b54ab3"/>
-    <p:sldId xmlns:r="http://schemas.openxmlformats.org/officeDocument/2006/relationships" id="265" r:id="Rb8abf387324947f2"/>
-    <p:sldId xmlns:r="http://schemas.openxmlformats.org/officeDocument/2006/relationships" id="266" r:id="R3327449ffd314ecf"/>
-    <p:sldId xmlns:r="http://schemas.openxmlformats.org/officeDocument/2006/relationships" id="267" r:id="R0561444fc68c4e0f"/>
+    <p:sldId xmlns:r="http://schemas.openxmlformats.org/officeDocument/2006/relationships" id="256" r:id="Rfdb910b9143f4de1"/>
+    <p:sldId xmlns:r="http://schemas.openxmlformats.org/officeDocument/2006/relationships" id="257" r:id="R630ac54669834cc2"/>
+    <p:sldId xmlns:r="http://schemas.openxmlformats.org/officeDocument/2006/relationships" id="258" r:id="R1f06c5cbcf9d41ce"/>
+    <p:sldId xmlns:r="http://schemas.openxmlformats.org/officeDocument/2006/relationships" id="259" r:id="R1ee05e4b13c94e2b"/>
+    <p:sldId xmlns:r="http://schemas.openxmlformats.org/officeDocument/2006/relationships" id="260" r:id="Rc5de09a761304c5b"/>
+    <p:sldId xmlns:r="http://schemas.openxmlformats.org/officeDocument/2006/relationships" id="261" r:id="Rf2c98393b6124e42"/>
+    <p:sldId xmlns:r="http://schemas.openxmlformats.org/officeDocument/2006/relationships" id="262" r:id="R3b0595253c434445"/>
+    <p:sldId xmlns:r="http://schemas.openxmlformats.org/officeDocument/2006/relationships" id="263" r:id="Raddf8334b70b4751"/>
+    <p:sldId xmlns:r="http://schemas.openxmlformats.org/officeDocument/2006/relationships" id="264" r:id="Re3adbc9bb2974e4e"/>
+    <p:sldId xmlns:r="http://schemas.openxmlformats.org/officeDocument/2006/relationships" id="265" r:id="R107aecf8b017436d"/>
+    <p:sldId xmlns:r="http://schemas.openxmlformats.org/officeDocument/2006/relationships" id="266" r:id="Rb4c3a53be8bd455a"/>
+    <p:sldId xmlns:r="http://schemas.openxmlformats.org/officeDocument/2006/relationships" id="267" r:id="R99ac41ae16d9421b"/>
   </p:sldIdLst>
   <p:sldSz cx="12192000" cy="6858000"/>
   <p:notesSz cx="6858000" cy="9144000"/>
@@ -542,7 +542,7 @@
           <a:lstStyle xmlns:a="http://schemas.openxmlformats.org/drawingml/2006/main"/>
           <a:p xmlns:a="http://schemas.openxmlformats.org/drawingml/2006/main">
             <a:r>
-              <a:t>Use this as the cover slide. Keep the title concise and place track/session information in the lower cards.</a:t>
+              <a:t/>
             </a:r>
           </a:p>
         </p:txBody>
@@ -612,7 +612,7 @@
           <a:lstStyle xmlns:a="http://schemas.openxmlformats.org/drawingml/2006/main"/>
           <a:p xmlns:a="http://schemas.openxmlformats.org/drawingml/2006/main">
             <a:r>
-              <a:t>Good default for dense content. Keep the left side as narrative and the right side as structured evidence.</a:t>
+              <a:t/>
             </a:r>
           </a:p>
         </p:txBody>
@@ -682,7 +682,7 @@
           <a:lstStyle xmlns:a="http://schemas.openxmlformats.org/drawingml/2006/main"/>
           <a:p xmlns:a="http://schemas.openxmlformats.org/drawingml/2006/main">
             <a:r>
-              <a:t>Good default for dense content. Keep the left side as narrative and the right side as structured evidence.</a:t>
+              <a:t/>
             </a:r>
           </a:p>
         </p:txBody>
@@ -752,7 +752,7 @@
           <a:lstStyle xmlns:a="http://schemas.openxmlformats.org/drawingml/2006/main"/>
           <a:p xmlns:a="http://schemas.openxmlformats.org/drawingml/2006/main">
             <a:r>
-              <a:t>Use this as the final Q&amp;A slide. Keep contact details short and readable from the back of the room.</a:t>
+              <a:t/>
             </a:r>
           </a:p>
         </p:txBody>
@@ -822,7 +822,7 @@
           <a:lstStyle xmlns:a="http://schemas.openxmlformats.org/drawingml/2006/main"/>
           <a:p xmlns:a="http://schemas.openxmlformats.org/drawingml/2006/main">
             <a:r>
-              <a:t>Good default for dense content. Keep the left side as narrative and the right side as structured evidence.</a:t>
+              <a:t/>
             </a:r>
           </a:p>
         </p:txBody>
@@ -892,7 +892,7 @@
           <a:lstStyle xmlns:a="http://schemas.openxmlformats.org/drawingml/2006/main"/>
           <a:p xmlns:a="http://schemas.openxmlformats.org/drawingml/2006/main">
             <a:r>
-              <a:t>Good default for dense content. Keep the left side as narrative and the right side as structured evidence.</a:t>
+              <a:t/>
             </a:r>
           </a:p>
         </p:txBody>
@@ -962,7 +962,7 @@
           <a:lstStyle xmlns:a="http://schemas.openxmlformats.org/drawingml/2006/main"/>
           <a:p xmlns:a="http://schemas.openxmlformats.org/drawingml/2006/main">
             <a:r>
-              <a:t>Use this layout for pipelines, study design, or workflow overviews. Keep each step short.</a:t>
+              <a:t/>
             </a:r>
           </a:p>
         </p:txBody>
@@ -1032,7 +1032,7 @@
           <a:lstStyle xmlns:a="http://schemas.openxmlformats.org/drawingml/2006/main"/>
           <a:p xmlns:a="http://schemas.openxmlformats.org/drawingml/2006/main">
             <a:r>
-              <a:t>Use this layout for pipelines, study design, or workflow overviews. Keep each step short.</a:t>
+              <a:t/>
             </a:r>
           </a:p>
         </p:txBody>
@@ -1102,7 +1102,7 @@
           <a:lstStyle xmlns:a="http://schemas.openxmlformats.org/drawingml/2006/main"/>
           <a:p xmlns:a="http://schemas.openxmlformats.org/drawingml/2006/main">
             <a:r>
-              <a:t>A simple acknowledgment/disclosure slide works better than dense institutional logos.</a:t>
+              <a:t/>
             </a:r>
           </a:p>
         </p:txBody>
@@ -1172,7 +1172,7 @@
           <a:lstStyle xmlns:a="http://schemas.openxmlformats.org/drawingml/2006/main"/>
           <a:p xmlns:a="http://schemas.openxmlformats.org/drawingml/2006/main">
             <a:r>
-              <a:t>Use this layout for pipelines, study design, or workflow overviews. Keep each step short.</a:t>
+              <a:t/>
             </a:r>
           </a:p>
         </p:txBody>
@@ -1242,7 +1242,7 @@
           <a:lstStyle xmlns:a="http://schemas.openxmlformats.org/drawingml/2006/main"/>
           <a:p xmlns:a="http://schemas.openxmlformats.org/drawingml/2006/main">
             <a:r>
-              <a:t>Good default for dense content. Keep the left side as narrative and the right side as structured evidence.</a:t>
+              <a:t/>
             </a:r>
           </a:p>
         </p:txBody>
@@ -1312,7 +1312,7 @@
           <a:lstStyle xmlns:a="http://schemas.openxmlformats.org/drawingml/2006/main"/>
           <a:p xmlns:a="http://schemas.openxmlformats.org/drawingml/2006/main">
             <a:r>
-              <a:t>Good default for dense content. Keep the left side as narrative and the right side as structured evidence.</a:t>
+              <a:t/>
             </a:r>
           </a:p>
         </p:txBody>
@@ -1577,7 +1577,7 @@
   </p:cSld>
   <p:clrMap bg1="lt1" tx1="dk1" bg2="lt2" tx2="dk2" accent1="accent1" accent2="accent2" accent3="accent3" accent4="accent4" accent5="accent5" accent6="accent6" hlink="hlink" folHlink="folHlink"/>
   <p:sldLayoutIdLst>
-    <p:sldLayoutId xmlns:r="http://schemas.openxmlformats.org/officeDocument/2006/relationships" id="2147483649" r:id="R46c7cb83a7cf40c0"/>
+    <p:sldLayoutId xmlns:r="http://schemas.openxmlformats.org/officeDocument/2006/relationships" id="2147483649" r:id="Ref8733c4b760468b"/>
   </p:sldLayoutIdLst>
   <p:txStyles>
     <p:titleStyle>
@@ -1967,7 +1967,7 @@
           <p:nvPr/>
         </p:nvPicPr>
         <p:blipFill>
-          <a:blip xmlns:r="http://schemas.openxmlformats.org/officeDocument/2006/relationships" xmlns:a="http://schemas.openxmlformats.org/drawingml/2006/main" r:embed="R3984dea0b8204be8"/>
+          <a:blip xmlns:r="http://schemas.openxmlformats.org/officeDocument/2006/relationships" xmlns:a="http://schemas.openxmlformats.org/drawingml/2006/main" r:embed="Red742a7c317b4ea2"/>
           <a:stretch xmlns:a="http://schemas.openxmlformats.org/drawingml/2006/main"/>
         </p:blipFill>
         <p:spPr>
@@ -2502,7 +2502,7 @@
           <p:cNvPr id="19" name="timing-pill">
             <a:extLst xmlns:a="http://schemas.openxmlformats.org/drawingml/2006/main">
               <a:ext uri="{FF2B5EF4-FFF2-40B4-BE49-F238E27FC236}">
-                <a16:creationId xmlns:a16="http://schemas.microsoft.com/office/drawing/2014/main" id="{73FAAA31-FAB1-4E17-9B44-44115921F7A0}"/>
+                <a16:creationId xmlns:a16="http://schemas.microsoft.com/office/drawing/2014/main" id="{BADA5551-6DAA-4A8C-8041-42A565D22FDE}"/>
               </a:ext>
             </a:extLst>
           </p:cNvPr>
@@ -2537,7 +2537,7 @@
           <p:cNvPr id="20" name="timing-label">
             <a:extLst xmlns:a="http://schemas.openxmlformats.org/drawingml/2006/main">
               <a:ext uri="{FF2B5EF4-FFF2-40B4-BE49-F238E27FC236}">
-                <a16:creationId xmlns:a16="http://schemas.microsoft.com/office/drawing/2014/main" id="{D30E623C-8A18-4AB8-AD87-BBC47338212C}"/>
+                <a16:creationId xmlns:a16="http://schemas.microsoft.com/office/drawing/2014/main" id="{83C3FF14-CE86-4CCE-AFE8-27EA83B19B4C}"/>
               </a:ext>
             </a:extLst>
           </p:cNvPr>
@@ -2934,7 +2934,7 @@
           <p:nvPr/>
         </p:nvPicPr>
         <p:blipFill>
-          <a:blip xmlns:r="http://schemas.openxmlformats.org/officeDocument/2006/relationships" xmlns:a="http://schemas.openxmlformats.org/drawingml/2006/main" r:embed="R326ce18f0ba74610"/>
+          <a:blip xmlns:r="http://schemas.openxmlformats.org/officeDocument/2006/relationships" xmlns:a="http://schemas.openxmlformats.org/drawingml/2006/main" r:embed="Rc4101388e36a42e3"/>
           <a:stretch xmlns:a="http://schemas.openxmlformats.org/drawingml/2006/main"/>
         </p:blipFill>
         <p:spPr>
@@ -2952,7 +2952,7 @@
           <p:cNvPr id="15" name="timing-pill">
             <a:extLst xmlns:a="http://schemas.openxmlformats.org/drawingml/2006/main">
               <a:ext uri="{FF2B5EF4-FFF2-40B4-BE49-F238E27FC236}">
-                <a16:creationId xmlns:a16="http://schemas.microsoft.com/office/drawing/2014/main" id="{06165288-E340-4D00-B1FC-5AB2E7B01B8C}"/>
+                <a16:creationId xmlns:a16="http://schemas.microsoft.com/office/drawing/2014/main" id="{F18AADC6-7799-47DA-90FF-7F9C25A41B30}"/>
               </a:ext>
             </a:extLst>
           </p:cNvPr>
@@ -2987,7 +2987,7 @@
           <p:cNvPr id="16" name="timing-label">
             <a:extLst xmlns:a="http://schemas.openxmlformats.org/drawingml/2006/main">
               <a:ext uri="{FF2B5EF4-FFF2-40B4-BE49-F238E27FC236}">
-                <a16:creationId xmlns:a16="http://schemas.microsoft.com/office/drawing/2014/main" id="{CD192D9D-42C2-4876-A335-318E84B8E26D}"/>
+                <a16:creationId xmlns:a16="http://schemas.microsoft.com/office/drawing/2014/main" id="{B2FEC0A7-1573-4038-9076-3F74CF1D46A3}"/>
               </a:ext>
             </a:extLst>
           </p:cNvPr>
@@ -3051,7 +3051,7 @@
           <p:cNvPr id="17" name="claim">
             <a:extLst xmlns:a="http://schemas.openxmlformats.org/drawingml/2006/main">
               <a:ext uri="{FF2B5EF4-FFF2-40B4-BE49-F238E27FC236}">
-                <a16:creationId xmlns:a16="http://schemas.microsoft.com/office/drawing/2014/main" id="{1359FC5C-629A-4FEB-B3D2-F1E86F31B2A8}"/>
+                <a16:creationId xmlns:a16="http://schemas.microsoft.com/office/drawing/2014/main" id="{945CE8E9-99DC-4BC6-8B71-78F5D3330B38}"/>
               </a:ext>
             </a:extLst>
           </p:cNvPr>
@@ -3115,7 +3115,7 @@
           <p:cNvPr id="18" name="">
             <a:extLst xmlns:a="http://schemas.openxmlformats.org/drawingml/2006/main">
               <a:ext uri="{FF2B5EF4-FFF2-40B4-BE49-F238E27FC236}">
-                <a16:creationId xmlns:a16="http://schemas.microsoft.com/office/drawing/2014/main" id="{97A4D43A-DE9E-493D-999B-68540E2CF0F6}"/>
+                <a16:creationId xmlns:a16="http://schemas.microsoft.com/office/drawing/2014/main" id="{FE6418FC-2386-4026-A0A5-1DCF2435FF00}"/>
               </a:ext>
             </a:extLst>
           </p:cNvPr>
@@ -3148,7 +3148,7 @@
           <p:cNvPr id="19" name="">
             <a:extLst xmlns:a="http://schemas.openxmlformats.org/drawingml/2006/main">
               <a:ext uri="{FF2B5EF4-FFF2-40B4-BE49-F238E27FC236}">
-                <a16:creationId xmlns:a16="http://schemas.microsoft.com/office/drawing/2014/main" id="{73096DA2-905A-44FC-9A87-7956334E36A0}"/>
+                <a16:creationId xmlns:a16="http://schemas.microsoft.com/office/drawing/2014/main" id="{3DEEA398-7556-4867-8E93-DD84B8122A9A}"/>
               </a:ext>
             </a:extLst>
           </p:cNvPr>
@@ -3212,7 +3212,7 @@
           <p:cNvPr id="20" name="">
             <a:extLst xmlns:a="http://schemas.openxmlformats.org/drawingml/2006/main">
               <a:ext uri="{FF2B5EF4-FFF2-40B4-BE49-F238E27FC236}">
-                <a16:creationId xmlns:a16="http://schemas.microsoft.com/office/drawing/2014/main" id="{34A54EE0-C182-45FD-B761-7BAE55952CBB}"/>
+                <a16:creationId xmlns:a16="http://schemas.microsoft.com/office/drawing/2014/main" id="{848CD7FA-FCC0-40F2-8853-E4FD1A5A5C23}"/>
               </a:ext>
             </a:extLst>
           </p:cNvPr>
@@ -3247,7 +3247,7 @@
           <p:cNvPr id="21" name="">
             <a:extLst xmlns:a="http://schemas.openxmlformats.org/drawingml/2006/main">
               <a:ext uri="{FF2B5EF4-FFF2-40B4-BE49-F238E27FC236}">
-                <a16:creationId xmlns:a16="http://schemas.microsoft.com/office/drawing/2014/main" id="{A0081A78-A373-494A-8BA7-3D38E8556540}"/>
+                <a16:creationId xmlns:a16="http://schemas.microsoft.com/office/drawing/2014/main" id="{B0E5C633-3FFF-485B-AFED-949EDBD38B7A}"/>
               </a:ext>
             </a:extLst>
           </p:cNvPr>
@@ -3282,7 +3282,7 @@
           <p:cNvPr id="22" name="">
             <a:extLst xmlns:a="http://schemas.openxmlformats.org/drawingml/2006/main">
               <a:ext uri="{FF2B5EF4-FFF2-40B4-BE49-F238E27FC236}">
-                <a16:creationId xmlns:a16="http://schemas.microsoft.com/office/drawing/2014/main" id="{1107539D-5929-44F1-B3A1-EA45FE4B06FD}"/>
+                <a16:creationId xmlns:a16="http://schemas.microsoft.com/office/drawing/2014/main" id="{3399F874-585C-4DDD-BCFA-D3322F32E216}"/>
               </a:ext>
             </a:extLst>
           </p:cNvPr>
@@ -3346,7 +3346,7 @@
           <p:cNvPr id="23" name="">
             <a:extLst xmlns:a="http://schemas.openxmlformats.org/drawingml/2006/main">
               <a:ext uri="{FF2B5EF4-FFF2-40B4-BE49-F238E27FC236}">
-                <a16:creationId xmlns:a16="http://schemas.microsoft.com/office/drawing/2014/main" id="{190EF739-F638-4116-AC18-C319A4A40FA5}"/>
+                <a16:creationId xmlns:a16="http://schemas.microsoft.com/office/drawing/2014/main" id="{A0AC928F-F9B4-4731-B3D6-103218BD539F}"/>
               </a:ext>
             </a:extLst>
           </p:cNvPr>
@@ -3381,7 +3381,7 @@
           <p:cNvPr id="24" name="">
             <a:extLst xmlns:a="http://schemas.openxmlformats.org/drawingml/2006/main">
               <a:ext uri="{FF2B5EF4-FFF2-40B4-BE49-F238E27FC236}">
-                <a16:creationId xmlns:a16="http://schemas.microsoft.com/office/drawing/2014/main" id="{33D6501D-070E-43FC-9B94-B7AD03E48520}"/>
+                <a16:creationId xmlns:a16="http://schemas.microsoft.com/office/drawing/2014/main" id="{5B0101D7-8B92-4E07-8878-C03E945441FA}"/>
               </a:ext>
             </a:extLst>
           </p:cNvPr>
@@ -3416,7 +3416,7 @@
           <p:cNvPr id="25" name="">
             <a:extLst xmlns:a="http://schemas.openxmlformats.org/drawingml/2006/main">
               <a:ext uri="{FF2B5EF4-FFF2-40B4-BE49-F238E27FC236}">
-                <a16:creationId xmlns:a16="http://schemas.microsoft.com/office/drawing/2014/main" id="{F809DA29-4C7E-468D-9686-F5CC93A49319}"/>
+                <a16:creationId xmlns:a16="http://schemas.microsoft.com/office/drawing/2014/main" id="{62F8FFC3-EC35-467F-BF44-90A1B87A4631}"/>
               </a:ext>
             </a:extLst>
           </p:cNvPr>
@@ -3480,7 +3480,7 @@
           <p:cNvPr id="26" name="">
             <a:extLst xmlns:a="http://schemas.openxmlformats.org/drawingml/2006/main">
               <a:ext uri="{FF2B5EF4-FFF2-40B4-BE49-F238E27FC236}">
-                <a16:creationId xmlns:a16="http://schemas.microsoft.com/office/drawing/2014/main" id="{00C015C6-AF1F-41EF-898B-5D6A94F3A655}"/>
+                <a16:creationId xmlns:a16="http://schemas.microsoft.com/office/drawing/2014/main" id="{FA5CF181-61EA-496C-B4B5-3F3DD00CAD0E}"/>
               </a:ext>
             </a:extLst>
           </p:cNvPr>
@@ -3515,7 +3515,7 @@
           <p:cNvPr id="27" name="">
             <a:extLst xmlns:a="http://schemas.openxmlformats.org/drawingml/2006/main">
               <a:ext uri="{FF2B5EF4-FFF2-40B4-BE49-F238E27FC236}">
-                <a16:creationId xmlns:a16="http://schemas.microsoft.com/office/drawing/2014/main" id="{9602CFE6-A4F7-4F12-8E83-7CF177946A55}"/>
+                <a16:creationId xmlns:a16="http://schemas.microsoft.com/office/drawing/2014/main" id="{E345FFEB-AC7F-4E84-B87B-20F213D93045}"/>
               </a:ext>
             </a:extLst>
           </p:cNvPr>
@@ -3550,7 +3550,7 @@
           <p:cNvPr id="28" name="">
             <a:extLst xmlns:a="http://schemas.openxmlformats.org/drawingml/2006/main">
               <a:ext uri="{FF2B5EF4-FFF2-40B4-BE49-F238E27FC236}">
-                <a16:creationId xmlns:a16="http://schemas.microsoft.com/office/drawing/2014/main" id="{D55FBE6A-1A8A-4001-872C-70F0A8818170}"/>
+                <a16:creationId xmlns:a16="http://schemas.microsoft.com/office/drawing/2014/main" id="{95A1F756-0DEB-4504-B7FA-78D6F7A689D6}"/>
               </a:ext>
             </a:extLst>
           </p:cNvPr>
@@ -3614,7 +3614,7 @@
           <p:cNvPr id="29" name="">
             <a:extLst xmlns:a="http://schemas.openxmlformats.org/drawingml/2006/main">
               <a:ext uri="{FF2B5EF4-FFF2-40B4-BE49-F238E27FC236}">
-                <a16:creationId xmlns:a16="http://schemas.microsoft.com/office/drawing/2014/main" id="{5D6EE756-4D94-42D8-95B8-D3F871A0D048}"/>
+                <a16:creationId xmlns:a16="http://schemas.microsoft.com/office/drawing/2014/main" id="{BC804CC9-F1B5-4BFB-88FC-A6CD6F1A10D2}"/>
               </a:ext>
             </a:extLst>
           </p:cNvPr>
@@ -3649,7 +3649,7 @@
           <p:cNvPr id="30" name="">
             <a:extLst xmlns:a="http://schemas.openxmlformats.org/drawingml/2006/main">
               <a:ext uri="{FF2B5EF4-FFF2-40B4-BE49-F238E27FC236}">
-                <a16:creationId xmlns:a16="http://schemas.microsoft.com/office/drawing/2014/main" id="{C338E23E-BA96-4250-891B-BF35886EC675}"/>
+                <a16:creationId xmlns:a16="http://schemas.microsoft.com/office/drawing/2014/main" id="{E0EBC6B4-9EFE-4916-A2E6-2E099631ABA3}"/>
               </a:ext>
             </a:extLst>
           </p:cNvPr>
@@ -3684,7 +3684,7 @@
           <p:cNvPr id="31" name="">
             <a:extLst xmlns:a="http://schemas.openxmlformats.org/drawingml/2006/main">
               <a:ext uri="{FF2B5EF4-FFF2-40B4-BE49-F238E27FC236}">
-                <a16:creationId xmlns:a16="http://schemas.microsoft.com/office/drawing/2014/main" id="{374136AA-7D24-4A8E-9679-71D9844EC687}"/>
+                <a16:creationId xmlns:a16="http://schemas.microsoft.com/office/drawing/2014/main" id="{EC4B401D-7154-488C-836B-20C49FC955B1}"/>
               </a:ext>
             </a:extLst>
           </p:cNvPr>
@@ -3748,7 +3748,7 @@
           <p:cNvPr id="32" name="">
             <a:extLst xmlns:a="http://schemas.openxmlformats.org/drawingml/2006/main">
               <a:ext uri="{FF2B5EF4-FFF2-40B4-BE49-F238E27FC236}">
-                <a16:creationId xmlns:a16="http://schemas.microsoft.com/office/drawing/2014/main" id="{CEF402C5-D897-4F00-8088-F9E46F4C4AE3}"/>
+                <a16:creationId xmlns:a16="http://schemas.microsoft.com/office/drawing/2014/main" id="{C860BCB4-722E-4F37-A33F-C96F3C3B0481}"/>
               </a:ext>
             </a:extLst>
           </p:cNvPr>
@@ -3783,7 +3783,7 @@
           <p:cNvPr id="33" name="">
             <a:extLst xmlns:a="http://schemas.openxmlformats.org/drawingml/2006/main">
               <a:ext uri="{FF2B5EF4-FFF2-40B4-BE49-F238E27FC236}">
-                <a16:creationId xmlns:a16="http://schemas.microsoft.com/office/drawing/2014/main" id="{E0D91CFD-B796-4B0D-9A5D-41ED68C18DF9}"/>
+                <a16:creationId xmlns:a16="http://schemas.microsoft.com/office/drawing/2014/main" id="{F7060FA3-F116-456A-B9EA-C2D2E5042FB6}"/>
               </a:ext>
             </a:extLst>
           </p:cNvPr>
@@ -3847,7 +3847,7 @@
           <p:cNvPr id="34" name="">
             <a:extLst xmlns:a="http://schemas.openxmlformats.org/drawingml/2006/main">
               <a:ext uri="{FF2B5EF4-FFF2-40B4-BE49-F238E27FC236}">
-                <a16:creationId xmlns:a16="http://schemas.microsoft.com/office/drawing/2014/main" id="{2714CC5D-523F-469C-8464-A69E73338356}"/>
+                <a16:creationId xmlns:a16="http://schemas.microsoft.com/office/drawing/2014/main" id="{2FEFBD70-4720-4A3A-843C-E121BB1A907B}"/>
               </a:ext>
             </a:extLst>
           </p:cNvPr>
@@ -3882,7 +3882,7 @@
           <p:cNvPr id="35" name="">
             <a:extLst xmlns:a="http://schemas.openxmlformats.org/drawingml/2006/main">
               <a:ext uri="{FF2B5EF4-FFF2-40B4-BE49-F238E27FC236}">
-                <a16:creationId xmlns:a16="http://schemas.microsoft.com/office/drawing/2014/main" id="{3F41E107-2C32-46C3-8F91-5DABE307F9DE}"/>
+                <a16:creationId xmlns:a16="http://schemas.microsoft.com/office/drawing/2014/main" id="{4EE3EED7-1006-410F-B886-0AB5AEC58B44}"/>
               </a:ext>
             </a:extLst>
           </p:cNvPr>
@@ -3946,7 +3946,7 @@
           <p:cNvPr id="36" name="card">
             <a:extLst xmlns:a="http://schemas.openxmlformats.org/drawingml/2006/main">
               <a:ext uri="{FF2B5EF4-FFF2-40B4-BE49-F238E27FC236}">
-                <a16:creationId xmlns:a16="http://schemas.microsoft.com/office/drawing/2014/main" id="{48628439-7D4F-45AB-94F2-EB4DD1E0FAC2}"/>
+                <a16:creationId xmlns:a16="http://schemas.microsoft.com/office/drawing/2014/main" id="{BC7EF8D6-0BAE-4A2D-BD98-936A6AEA4657}"/>
               </a:ext>
             </a:extLst>
           </p:cNvPr>
@@ -3981,7 +3981,7 @@
           <p:cNvPr id="37" name="card-accent">
             <a:extLst xmlns:a="http://schemas.openxmlformats.org/drawingml/2006/main">
               <a:ext uri="{FF2B5EF4-FFF2-40B4-BE49-F238E27FC236}">
-                <a16:creationId xmlns:a16="http://schemas.microsoft.com/office/drawing/2014/main" id="{26482936-FE43-4C0D-9838-F6EA99FA080B}"/>
+                <a16:creationId xmlns:a16="http://schemas.microsoft.com/office/drawing/2014/main" id="{EEABF890-34CA-4A38-8725-AD73DBB018E7}"/>
               </a:ext>
             </a:extLst>
           </p:cNvPr>
@@ -4016,7 +4016,7 @@
           <p:cNvPr id="38" name="card-eyebrow">
             <a:extLst xmlns:a="http://schemas.openxmlformats.org/drawingml/2006/main">
               <a:ext uri="{FF2B5EF4-FFF2-40B4-BE49-F238E27FC236}">
-                <a16:creationId xmlns:a16="http://schemas.microsoft.com/office/drawing/2014/main" id="{92BD5F40-6895-4CE4-BE4A-97C9880835D8}"/>
+                <a16:creationId xmlns:a16="http://schemas.microsoft.com/office/drawing/2014/main" id="{A503F87B-7E4F-4CF7-AE68-12A9C49A40F4}"/>
               </a:ext>
             </a:extLst>
           </p:cNvPr>
@@ -4080,7 +4080,7 @@
           <p:cNvPr id="39" name="card-title">
             <a:extLst xmlns:a="http://schemas.openxmlformats.org/drawingml/2006/main">
               <a:ext uri="{FF2B5EF4-FFF2-40B4-BE49-F238E27FC236}">
-                <a16:creationId xmlns:a16="http://schemas.microsoft.com/office/drawing/2014/main" id="{7E436B3C-986B-4CEB-88C6-6DDE2FAE4CA4}"/>
+                <a16:creationId xmlns:a16="http://schemas.microsoft.com/office/drawing/2014/main" id="{1A1BD5D2-3FC1-4E07-AC47-FB3290664667}"/>
               </a:ext>
             </a:extLst>
           </p:cNvPr>
@@ -4144,7 +4144,7 @@
           <p:cNvPr id="40" name="card-body">
             <a:extLst xmlns:a="http://schemas.openxmlformats.org/drawingml/2006/main">
               <a:ext uri="{FF2B5EF4-FFF2-40B4-BE49-F238E27FC236}">
-                <a16:creationId xmlns:a16="http://schemas.microsoft.com/office/drawing/2014/main" id="{B948B659-9AF3-4787-82DB-65C829214901}"/>
+                <a16:creationId xmlns:a16="http://schemas.microsoft.com/office/drawing/2014/main" id="{78ADE2B4-8FA8-43E0-8E2F-678ED6C13E7D}"/>
               </a:ext>
             </a:extLst>
           </p:cNvPr>
@@ -4544,7 +4544,7 @@
           <p:nvPr/>
         </p:nvPicPr>
         <p:blipFill>
-          <a:blip xmlns:r="http://schemas.openxmlformats.org/officeDocument/2006/relationships" xmlns:a="http://schemas.openxmlformats.org/drawingml/2006/main" r:embed="R0cc8b582564c4ae4"/>
+          <a:blip xmlns:r="http://schemas.openxmlformats.org/officeDocument/2006/relationships" xmlns:a="http://schemas.openxmlformats.org/drawingml/2006/main" r:embed="R1c4ed82f1ddd4a8d"/>
           <a:stretch xmlns:a="http://schemas.openxmlformats.org/drawingml/2006/main"/>
         </p:blipFill>
         <p:spPr>
@@ -4562,7 +4562,7 @@
           <p:cNvPr id="15" name="timing-pill">
             <a:extLst xmlns:a="http://schemas.openxmlformats.org/drawingml/2006/main">
               <a:ext uri="{FF2B5EF4-FFF2-40B4-BE49-F238E27FC236}">
-                <a16:creationId xmlns:a16="http://schemas.microsoft.com/office/drawing/2014/main" id="{3156A295-6375-4385-8E66-F27D3315375F}"/>
+                <a16:creationId xmlns:a16="http://schemas.microsoft.com/office/drawing/2014/main" id="{4CC1B8CA-0588-45CB-8E57-FDF3B8CFD35E}"/>
               </a:ext>
             </a:extLst>
           </p:cNvPr>
@@ -4597,7 +4597,7 @@
           <p:cNvPr id="16" name="timing-label">
             <a:extLst xmlns:a="http://schemas.openxmlformats.org/drawingml/2006/main">
               <a:ext uri="{FF2B5EF4-FFF2-40B4-BE49-F238E27FC236}">
-                <a16:creationId xmlns:a16="http://schemas.microsoft.com/office/drawing/2014/main" id="{E04C5467-DB9E-45E9-A211-D5BAF53C5BAA}"/>
+                <a16:creationId xmlns:a16="http://schemas.microsoft.com/office/drawing/2014/main" id="{9569D192-15F4-4B54-9252-36668B4339FE}"/>
               </a:ext>
             </a:extLst>
           </p:cNvPr>
@@ -4661,7 +4661,7 @@
           <p:cNvPr id="17" name="claim">
             <a:extLst xmlns:a="http://schemas.openxmlformats.org/drawingml/2006/main">
               <a:ext uri="{FF2B5EF4-FFF2-40B4-BE49-F238E27FC236}">
-                <a16:creationId xmlns:a16="http://schemas.microsoft.com/office/drawing/2014/main" id="{350E064E-F65D-48C5-967A-B8F53266892F}"/>
+                <a16:creationId xmlns:a16="http://schemas.microsoft.com/office/drawing/2014/main" id="{ABF05B14-5B74-4D98-9AD8-035C01857B98}"/>
               </a:ext>
             </a:extLst>
           </p:cNvPr>
@@ -4725,7 +4725,7 @@
           <p:cNvPr id="18" name="card">
             <a:extLst xmlns:a="http://schemas.openxmlformats.org/drawingml/2006/main">
               <a:ext uri="{FF2B5EF4-FFF2-40B4-BE49-F238E27FC236}">
-                <a16:creationId xmlns:a16="http://schemas.microsoft.com/office/drawing/2014/main" id="{EB17204E-CD80-46F9-B38B-1D4551C7D3B0}"/>
+                <a16:creationId xmlns:a16="http://schemas.microsoft.com/office/drawing/2014/main" id="{E4CE211C-93A0-47A6-8AB6-C73B4432BA16}"/>
               </a:ext>
             </a:extLst>
           </p:cNvPr>
@@ -4760,7 +4760,7 @@
           <p:cNvPr id="19" name="card-accent">
             <a:extLst xmlns:a="http://schemas.openxmlformats.org/drawingml/2006/main">
               <a:ext uri="{FF2B5EF4-FFF2-40B4-BE49-F238E27FC236}">
-                <a16:creationId xmlns:a16="http://schemas.microsoft.com/office/drawing/2014/main" id="{F22F6284-23AE-48C4-A5F5-0DFB564CCFAB}"/>
+                <a16:creationId xmlns:a16="http://schemas.microsoft.com/office/drawing/2014/main" id="{2CB73592-5784-4BAF-B0AD-54AD3E7D9F52}"/>
               </a:ext>
             </a:extLst>
           </p:cNvPr>
@@ -4795,7 +4795,7 @@
           <p:cNvPr id="20" name="card-eyebrow">
             <a:extLst xmlns:a="http://schemas.openxmlformats.org/drawingml/2006/main">
               <a:ext uri="{FF2B5EF4-FFF2-40B4-BE49-F238E27FC236}">
-                <a16:creationId xmlns:a16="http://schemas.microsoft.com/office/drawing/2014/main" id="{63DB0C64-0EEB-4DBC-BA26-6E9366FA692E}"/>
+                <a16:creationId xmlns:a16="http://schemas.microsoft.com/office/drawing/2014/main" id="{A0599302-C95F-4977-9107-AD80AD8C0B0A}"/>
               </a:ext>
             </a:extLst>
           </p:cNvPr>
@@ -4859,7 +4859,7 @@
           <p:cNvPr id="21" name="card-title">
             <a:extLst xmlns:a="http://schemas.openxmlformats.org/drawingml/2006/main">
               <a:ext uri="{FF2B5EF4-FFF2-40B4-BE49-F238E27FC236}">
-                <a16:creationId xmlns:a16="http://schemas.microsoft.com/office/drawing/2014/main" id="{004F1EE7-661B-44D8-87ED-68A4353510FA}"/>
+                <a16:creationId xmlns:a16="http://schemas.microsoft.com/office/drawing/2014/main" id="{7CB1E8A3-4966-4F33-8AC0-9E8C9B466597}"/>
               </a:ext>
             </a:extLst>
           </p:cNvPr>
@@ -4923,7 +4923,7 @@
           <p:cNvPr id="22" name="card-body">
             <a:extLst xmlns:a="http://schemas.openxmlformats.org/drawingml/2006/main">
               <a:ext uri="{FF2B5EF4-FFF2-40B4-BE49-F238E27FC236}">
-                <a16:creationId xmlns:a16="http://schemas.microsoft.com/office/drawing/2014/main" id="{9D4826DD-7924-4721-9FB7-A44F8DD7D55F}"/>
+                <a16:creationId xmlns:a16="http://schemas.microsoft.com/office/drawing/2014/main" id="{7EC039B5-EF6E-45C2-A4FD-547A26B4BC43}"/>
               </a:ext>
             </a:extLst>
           </p:cNvPr>
@@ -4987,7 +4987,7 @@
           <p:cNvPr id="23" name="card">
             <a:extLst xmlns:a="http://schemas.openxmlformats.org/drawingml/2006/main">
               <a:ext uri="{FF2B5EF4-FFF2-40B4-BE49-F238E27FC236}">
-                <a16:creationId xmlns:a16="http://schemas.microsoft.com/office/drawing/2014/main" id="{95F30955-6E27-43D3-AB89-4E47B822B40C}"/>
+                <a16:creationId xmlns:a16="http://schemas.microsoft.com/office/drawing/2014/main" id="{0C1AFB85-9183-40DA-A767-662E5E0F581D}"/>
               </a:ext>
             </a:extLst>
           </p:cNvPr>
@@ -5022,7 +5022,7 @@
           <p:cNvPr id="24" name="card-accent">
             <a:extLst xmlns:a="http://schemas.openxmlformats.org/drawingml/2006/main">
               <a:ext uri="{FF2B5EF4-FFF2-40B4-BE49-F238E27FC236}">
-                <a16:creationId xmlns:a16="http://schemas.microsoft.com/office/drawing/2014/main" id="{4820A25F-65BD-430B-80FE-0C222914416D}"/>
+                <a16:creationId xmlns:a16="http://schemas.microsoft.com/office/drawing/2014/main" id="{FCDD1CA3-E505-4982-8A39-745D56D46CE8}"/>
               </a:ext>
             </a:extLst>
           </p:cNvPr>
@@ -5057,7 +5057,7 @@
           <p:cNvPr id="25" name="card-eyebrow">
             <a:extLst xmlns:a="http://schemas.openxmlformats.org/drawingml/2006/main">
               <a:ext uri="{FF2B5EF4-FFF2-40B4-BE49-F238E27FC236}">
-                <a16:creationId xmlns:a16="http://schemas.microsoft.com/office/drawing/2014/main" id="{1A91A893-7383-495B-9049-88E5ED0931CB}"/>
+                <a16:creationId xmlns:a16="http://schemas.microsoft.com/office/drawing/2014/main" id="{BC04411F-DCCA-4CA1-A179-A1FE9BB8737F}"/>
               </a:ext>
             </a:extLst>
           </p:cNvPr>
@@ -5121,7 +5121,7 @@
           <p:cNvPr id="26" name="card-title">
             <a:extLst xmlns:a="http://schemas.openxmlformats.org/drawingml/2006/main">
               <a:ext uri="{FF2B5EF4-FFF2-40B4-BE49-F238E27FC236}">
-                <a16:creationId xmlns:a16="http://schemas.microsoft.com/office/drawing/2014/main" id="{EEF45BB3-98C1-4906-97EC-8712CD78D604}"/>
+                <a16:creationId xmlns:a16="http://schemas.microsoft.com/office/drawing/2014/main" id="{884D932C-6A8A-4615-BF0B-44DDC7C9153B}"/>
               </a:ext>
             </a:extLst>
           </p:cNvPr>
@@ -5185,7 +5185,7 @@
           <p:cNvPr id="27" name="card-body">
             <a:extLst xmlns:a="http://schemas.openxmlformats.org/drawingml/2006/main">
               <a:ext uri="{FF2B5EF4-FFF2-40B4-BE49-F238E27FC236}">
-                <a16:creationId xmlns:a16="http://schemas.microsoft.com/office/drawing/2014/main" id="{CC5493B8-AA3A-45AD-8DA5-F17C93C150AC}"/>
+                <a16:creationId xmlns:a16="http://schemas.microsoft.com/office/drawing/2014/main" id="{16E58FE9-BCB9-4EC7-A6BB-E27CF0634467}"/>
               </a:ext>
             </a:extLst>
           </p:cNvPr>
@@ -5380,7 +5380,7 @@
           <p:nvPr/>
         </p:nvPicPr>
         <p:blipFill>
-          <a:blip xmlns:r="http://schemas.openxmlformats.org/officeDocument/2006/relationships" xmlns:a="http://schemas.openxmlformats.org/drawingml/2006/main" r:embed="R2540607a8d194566"/>
+          <a:blip xmlns:r="http://schemas.openxmlformats.org/officeDocument/2006/relationships" xmlns:a="http://schemas.openxmlformats.org/drawingml/2006/main" r:embed="R09dcc1356abd4d25"/>
           <a:srcRect xmlns:a="http://schemas.openxmlformats.org/drawingml/2006/main" l="0" t="15385" r="0" b="15385"/>
           <a:stretch xmlns:a="http://schemas.openxmlformats.org/drawingml/2006/main">
             <a:fillRect l="0" t="0" r="0" b="0"/>
@@ -5666,7 +5666,7 @@
           <p:nvPr/>
         </p:nvPicPr>
         <p:blipFill>
-          <a:blip xmlns:r="http://schemas.openxmlformats.org/officeDocument/2006/relationships" xmlns:a="http://schemas.openxmlformats.org/drawingml/2006/main" r:embed="Rbef51e3bc1524b8e"/>
+          <a:blip xmlns:r="http://schemas.openxmlformats.org/officeDocument/2006/relationships" xmlns:a="http://schemas.openxmlformats.org/drawingml/2006/main" r:embed="R979c82ec1c224ba4"/>
           <a:stretch xmlns:a="http://schemas.openxmlformats.org/drawingml/2006/main"/>
         </p:blipFill>
         <p:spPr>
@@ -5684,7 +5684,7 @@
           <p:cNvPr id="11" name="">
             <a:extLst xmlns:a="http://schemas.openxmlformats.org/drawingml/2006/main">
               <a:ext uri="{FF2B5EF4-FFF2-40B4-BE49-F238E27FC236}">
-                <a16:creationId xmlns:a16="http://schemas.microsoft.com/office/drawing/2014/main" id="{FCED6016-5EAD-4240-A3E9-F90BEB3ADC61}"/>
+                <a16:creationId xmlns:a16="http://schemas.microsoft.com/office/drawing/2014/main" id="{D689364D-D4BB-4822-9F56-38910628E66F}"/>
               </a:ext>
             </a:extLst>
           </p:cNvPr>
@@ -5794,7 +5794,7 @@
           <p:cNvPr id="12" name="timing-pill">
             <a:extLst xmlns:a="http://schemas.openxmlformats.org/drawingml/2006/main">
               <a:ext uri="{FF2B5EF4-FFF2-40B4-BE49-F238E27FC236}">
-                <a16:creationId xmlns:a16="http://schemas.microsoft.com/office/drawing/2014/main" id="{7E318259-C924-45F1-88B8-89B388432150}"/>
+                <a16:creationId xmlns:a16="http://schemas.microsoft.com/office/drawing/2014/main" id="{2073ABEA-4750-46E8-92FF-38793D21A399}"/>
               </a:ext>
             </a:extLst>
           </p:cNvPr>
@@ -5829,7 +5829,7 @@
           <p:cNvPr id="13" name="timing-label">
             <a:extLst xmlns:a="http://schemas.openxmlformats.org/drawingml/2006/main">
               <a:ext uri="{FF2B5EF4-FFF2-40B4-BE49-F238E27FC236}">
-                <a16:creationId xmlns:a16="http://schemas.microsoft.com/office/drawing/2014/main" id="{59399ED3-C99D-4CBF-B79E-48B24341B7C9}"/>
+                <a16:creationId xmlns:a16="http://schemas.microsoft.com/office/drawing/2014/main" id="{8383D9D1-2638-408B-8B5A-CC32011AF51C}"/>
               </a:ext>
             </a:extLst>
           </p:cNvPr>
@@ -6229,7 +6229,7 @@
           <p:nvPr/>
         </p:nvPicPr>
         <p:blipFill>
-          <a:blip xmlns:r="http://schemas.openxmlformats.org/officeDocument/2006/relationships" xmlns:a="http://schemas.openxmlformats.org/drawingml/2006/main" r:embed="Rd568de15f8d74100"/>
+          <a:blip xmlns:r="http://schemas.openxmlformats.org/officeDocument/2006/relationships" xmlns:a="http://schemas.openxmlformats.org/drawingml/2006/main" r:embed="R573bbd2558cc4d48"/>
           <a:stretch xmlns:a="http://schemas.openxmlformats.org/drawingml/2006/main"/>
         </p:blipFill>
         <p:spPr>
@@ -6247,7 +6247,7 @@
           <p:cNvPr id="15" name="timing-pill">
             <a:extLst xmlns:a="http://schemas.openxmlformats.org/drawingml/2006/main">
               <a:ext uri="{FF2B5EF4-FFF2-40B4-BE49-F238E27FC236}">
-                <a16:creationId xmlns:a16="http://schemas.microsoft.com/office/drawing/2014/main" id="{569357F6-3CB6-4759-9FD5-DC33C5C98520}"/>
+                <a16:creationId xmlns:a16="http://schemas.microsoft.com/office/drawing/2014/main" id="{D008B094-50DC-499E-A33F-3F41CC1D8346}"/>
               </a:ext>
             </a:extLst>
           </p:cNvPr>
@@ -6282,7 +6282,7 @@
           <p:cNvPr id="16" name="timing-label">
             <a:extLst xmlns:a="http://schemas.openxmlformats.org/drawingml/2006/main">
               <a:ext uri="{FF2B5EF4-FFF2-40B4-BE49-F238E27FC236}">
-                <a16:creationId xmlns:a16="http://schemas.microsoft.com/office/drawing/2014/main" id="{E0F4C3D9-25B4-46D3-8E9C-98445F890E4D}"/>
+                <a16:creationId xmlns:a16="http://schemas.microsoft.com/office/drawing/2014/main" id="{FDD6375A-C6BB-4645-B73E-195A6BF74BC6}"/>
               </a:ext>
             </a:extLst>
           </p:cNvPr>
@@ -6346,7 +6346,7 @@
           <p:cNvPr id="17" name="claim">
             <a:extLst xmlns:a="http://schemas.openxmlformats.org/drawingml/2006/main">
               <a:ext uri="{FF2B5EF4-FFF2-40B4-BE49-F238E27FC236}">
-                <a16:creationId xmlns:a16="http://schemas.microsoft.com/office/drawing/2014/main" id="{C06C6B86-EC53-412C-9780-6A028A455A89}"/>
+                <a16:creationId xmlns:a16="http://schemas.microsoft.com/office/drawing/2014/main" id="{D38267DC-1909-40D8-874B-6B6B55BB31B0}"/>
               </a:ext>
             </a:extLst>
           </p:cNvPr>
@@ -6410,7 +6410,7 @@
           <p:cNvPr id="18" name="card">
             <a:extLst xmlns:a="http://schemas.openxmlformats.org/drawingml/2006/main">
               <a:ext uri="{FF2B5EF4-FFF2-40B4-BE49-F238E27FC236}">
-                <a16:creationId xmlns:a16="http://schemas.microsoft.com/office/drawing/2014/main" id="{41D8F284-A08B-4347-8C92-EB5834C72FB7}"/>
+                <a16:creationId xmlns:a16="http://schemas.microsoft.com/office/drawing/2014/main" id="{43921A30-1C17-4FDD-8BD4-A552D818FFC2}"/>
               </a:ext>
             </a:extLst>
           </p:cNvPr>
@@ -6445,7 +6445,7 @@
           <p:cNvPr id="19" name="card-accent">
             <a:extLst xmlns:a="http://schemas.openxmlformats.org/drawingml/2006/main">
               <a:ext uri="{FF2B5EF4-FFF2-40B4-BE49-F238E27FC236}">
-                <a16:creationId xmlns:a16="http://schemas.microsoft.com/office/drawing/2014/main" id="{3DC08EBB-937F-43D5-9D96-BB678DCC95FA}"/>
+                <a16:creationId xmlns:a16="http://schemas.microsoft.com/office/drawing/2014/main" id="{FB4F6511-57F7-415A-B495-7967D31FAF16}"/>
               </a:ext>
             </a:extLst>
           </p:cNvPr>
@@ -6480,7 +6480,7 @@
           <p:cNvPr id="20" name="card-eyebrow">
             <a:extLst xmlns:a="http://schemas.openxmlformats.org/drawingml/2006/main">
               <a:ext uri="{FF2B5EF4-FFF2-40B4-BE49-F238E27FC236}">
-                <a16:creationId xmlns:a16="http://schemas.microsoft.com/office/drawing/2014/main" id="{7894A90A-18B8-409F-B907-F21BE9AED154}"/>
+                <a16:creationId xmlns:a16="http://schemas.microsoft.com/office/drawing/2014/main" id="{17B354AA-B590-4156-A797-C95A7A9E31EA}"/>
               </a:ext>
             </a:extLst>
           </p:cNvPr>
@@ -6544,7 +6544,7 @@
           <p:cNvPr id="21" name="card-title">
             <a:extLst xmlns:a="http://schemas.openxmlformats.org/drawingml/2006/main">
               <a:ext uri="{FF2B5EF4-FFF2-40B4-BE49-F238E27FC236}">
-                <a16:creationId xmlns:a16="http://schemas.microsoft.com/office/drawing/2014/main" id="{1255D8E9-77BF-4F4B-9D02-BA8D863A9085}"/>
+                <a16:creationId xmlns:a16="http://schemas.microsoft.com/office/drawing/2014/main" id="{605D89B2-ECC7-4B38-9913-C9F0E1496028}"/>
               </a:ext>
             </a:extLst>
           </p:cNvPr>
@@ -6608,7 +6608,7 @@
           <p:cNvPr id="22" name="card-body">
             <a:extLst xmlns:a="http://schemas.openxmlformats.org/drawingml/2006/main">
               <a:ext uri="{FF2B5EF4-FFF2-40B4-BE49-F238E27FC236}">
-                <a16:creationId xmlns:a16="http://schemas.microsoft.com/office/drawing/2014/main" id="{A4FE9BCD-2E8F-4248-96FC-D692EABB7E63}"/>
+                <a16:creationId xmlns:a16="http://schemas.microsoft.com/office/drawing/2014/main" id="{64B97A53-135B-402E-9861-880D1AB63BD4}"/>
               </a:ext>
             </a:extLst>
           </p:cNvPr>
@@ -6672,7 +6672,7 @@
           <p:cNvPr id="23" name="card">
             <a:extLst xmlns:a="http://schemas.openxmlformats.org/drawingml/2006/main">
               <a:ext uri="{FF2B5EF4-FFF2-40B4-BE49-F238E27FC236}">
-                <a16:creationId xmlns:a16="http://schemas.microsoft.com/office/drawing/2014/main" id="{AF68D0D2-15CC-4933-98B4-1FA36C147260}"/>
+                <a16:creationId xmlns:a16="http://schemas.microsoft.com/office/drawing/2014/main" id="{AEB65A5B-E317-4E45-9A99-4A935F1717D2}"/>
               </a:ext>
             </a:extLst>
           </p:cNvPr>
@@ -6707,7 +6707,7 @@
           <p:cNvPr id="24" name="card-accent">
             <a:extLst xmlns:a="http://schemas.openxmlformats.org/drawingml/2006/main">
               <a:ext uri="{FF2B5EF4-FFF2-40B4-BE49-F238E27FC236}">
-                <a16:creationId xmlns:a16="http://schemas.microsoft.com/office/drawing/2014/main" id="{E58DA63A-D8E7-4416-8D71-3F1B418E4647}"/>
+                <a16:creationId xmlns:a16="http://schemas.microsoft.com/office/drawing/2014/main" id="{80DA6E1B-5F5B-4C63-9113-1DB084CD6A21}"/>
               </a:ext>
             </a:extLst>
           </p:cNvPr>
@@ -6742,7 +6742,7 @@
           <p:cNvPr id="25" name="card-eyebrow">
             <a:extLst xmlns:a="http://schemas.openxmlformats.org/drawingml/2006/main">
               <a:ext uri="{FF2B5EF4-FFF2-40B4-BE49-F238E27FC236}">
-                <a16:creationId xmlns:a16="http://schemas.microsoft.com/office/drawing/2014/main" id="{65AF2B2B-8174-4CD5-AF18-BA73DFB92E35}"/>
+                <a16:creationId xmlns:a16="http://schemas.microsoft.com/office/drawing/2014/main" id="{01B9DD71-3EB9-42B4-A2D6-6E0F5114991C}"/>
               </a:ext>
             </a:extLst>
           </p:cNvPr>
@@ -6806,7 +6806,7 @@
           <p:cNvPr id="26" name="card-title">
             <a:extLst xmlns:a="http://schemas.openxmlformats.org/drawingml/2006/main">
               <a:ext uri="{FF2B5EF4-FFF2-40B4-BE49-F238E27FC236}">
-                <a16:creationId xmlns:a16="http://schemas.microsoft.com/office/drawing/2014/main" id="{3E42623B-3A77-4650-B87C-2459C9173E17}"/>
+                <a16:creationId xmlns:a16="http://schemas.microsoft.com/office/drawing/2014/main" id="{D95A7160-E1C9-43B5-9CAF-BC5F7C784227}"/>
               </a:ext>
             </a:extLst>
           </p:cNvPr>
@@ -6870,7 +6870,7 @@
           <p:cNvPr id="27" name="card-body">
             <a:extLst xmlns:a="http://schemas.openxmlformats.org/drawingml/2006/main">
               <a:ext uri="{FF2B5EF4-FFF2-40B4-BE49-F238E27FC236}">
-                <a16:creationId xmlns:a16="http://schemas.microsoft.com/office/drawing/2014/main" id="{16DAC68E-69D1-4CAF-8798-92A018B1744C}"/>
+                <a16:creationId xmlns:a16="http://schemas.microsoft.com/office/drawing/2014/main" id="{FC1083FE-4A08-4BC7-B63A-B3FF9AEC7EB3}"/>
               </a:ext>
             </a:extLst>
           </p:cNvPr>
@@ -6934,7 +6934,7 @@
           <p:cNvPr id="28" name="card">
             <a:extLst xmlns:a="http://schemas.openxmlformats.org/drawingml/2006/main">
               <a:ext uri="{FF2B5EF4-FFF2-40B4-BE49-F238E27FC236}">
-                <a16:creationId xmlns:a16="http://schemas.microsoft.com/office/drawing/2014/main" id="{CE3B63B5-89D6-4F9D-9AEE-0D6970949BB7}"/>
+                <a16:creationId xmlns:a16="http://schemas.microsoft.com/office/drawing/2014/main" id="{C0784F68-4FCD-4953-8F6C-AF493BBCD390}"/>
               </a:ext>
             </a:extLst>
           </p:cNvPr>
@@ -6969,7 +6969,7 @@
           <p:cNvPr id="29" name="card-accent">
             <a:extLst xmlns:a="http://schemas.openxmlformats.org/drawingml/2006/main">
               <a:ext uri="{FF2B5EF4-FFF2-40B4-BE49-F238E27FC236}">
-                <a16:creationId xmlns:a16="http://schemas.microsoft.com/office/drawing/2014/main" id="{82020001-E523-4CED-B9D8-712C86635DD9}"/>
+                <a16:creationId xmlns:a16="http://schemas.microsoft.com/office/drawing/2014/main" id="{171953BC-35AC-45D7-ACA5-67D1FB4F9CDB}"/>
               </a:ext>
             </a:extLst>
           </p:cNvPr>
@@ -7004,7 +7004,7 @@
           <p:cNvPr id="30" name="card-eyebrow">
             <a:extLst xmlns:a="http://schemas.openxmlformats.org/drawingml/2006/main">
               <a:ext uri="{FF2B5EF4-FFF2-40B4-BE49-F238E27FC236}">
-                <a16:creationId xmlns:a16="http://schemas.microsoft.com/office/drawing/2014/main" id="{B759B6F7-B416-48D5-9907-F1D1843E3C76}"/>
+                <a16:creationId xmlns:a16="http://schemas.microsoft.com/office/drawing/2014/main" id="{A4F53833-4D8B-4FCA-A060-12E4A89185D1}"/>
               </a:ext>
             </a:extLst>
           </p:cNvPr>
@@ -7068,7 +7068,7 @@
           <p:cNvPr id="31" name="card-title">
             <a:extLst xmlns:a="http://schemas.openxmlformats.org/drawingml/2006/main">
               <a:ext uri="{FF2B5EF4-FFF2-40B4-BE49-F238E27FC236}">
-                <a16:creationId xmlns:a16="http://schemas.microsoft.com/office/drawing/2014/main" id="{52191873-AF96-4F08-8DE4-22E4E7FC92D2}"/>
+                <a16:creationId xmlns:a16="http://schemas.microsoft.com/office/drawing/2014/main" id="{110E5198-5BE3-461A-A5F6-25C50B072806}"/>
               </a:ext>
             </a:extLst>
           </p:cNvPr>
@@ -7132,7 +7132,7 @@
           <p:cNvPr id="32" name="card-body">
             <a:extLst xmlns:a="http://schemas.openxmlformats.org/drawingml/2006/main">
               <a:ext uri="{FF2B5EF4-FFF2-40B4-BE49-F238E27FC236}">
-                <a16:creationId xmlns:a16="http://schemas.microsoft.com/office/drawing/2014/main" id="{5924E78C-6BA3-4707-B00E-230BAD489080}"/>
+                <a16:creationId xmlns:a16="http://schemas.microsoft.com/office/drawing/2014/main" id="{2F4BBA55-F87E-4D1D-815C-D85FD4F4351B}"/>
               </a:ext>
             </a:extLst>
           </p:cNvPr>
@@ -7200,7 +7200,7 @@
           <p:nvPr/>
         </p:nvPicPr>
         <p:blipFill>
-          <a:blip xmlns:r="http://schemas.openxmlformats.org/officeDocument/2006/relationships" xmlns:a="http://schemas.openxmlformats.org/drawingml/2006/main" r:embed="Raa8a7fbacc0f42bb"/>
+          <a:blip xmlns:r="http://schemas.openxmlformats.org/officeDocument/2006/relationships" xmlns:a="http://schemas.openxmlformats.org/drawingml/2006/main" r:embed="R62f66acf6b534cc7"/>
           <a:stretch xmlns:a="http://schemas.openxmlformats.org/drawingml/2006/main"/>
         </p:blipFill>
         <p:spPr>
@@ -7554,7 +7554,7 @@
           <p:nvPr/>
         </p:nvPicPr>
         <p:blipFill>
-          <a:blip xmlns:r="http://schemas.openxmlformats.org/officeDocument/2006/relationships" xmlns:a="http://schemas.openxmlformats.org/drawingml/2006/main" r:embed="Rc61522f791c042d6"/>
+          <a:blip xmlns:r="http://schemas.openxmlformats.org/officeDocument/2006/relationships" xmlns:a="http://schemas.openxmlformats.org/drawingml/2006/main" r:embed="Ra8ced316a1904973"/>
           <a:stretch xmlns:a="http://schemas.openxmlformats.org/drawingml/2006/main"/>
         </p:blipFill>
         <p:spPr>
@@ -7572,7 +7572,7 @@
           <p:cNvPr id="15" name="timing-pill">
             <a:extLst xmlns:a="http://schemas.openxmlformats.org/drawingml/2006/main">
               <a:ext uri="{FF2B5EF4-FFF2-40B4-BE49-F238E27FC236}">
-                <a16:creationId xmlns:a16="http://schemas.microsoft.com/office/drawing/2014/main" id="{A4D913DE-BBEF-4FD3-90F9-0010C1F97071}"/>
+                <a16:creationId xmlns:a16="http://schemas.microsoft.com/office/drawing/2014/main" id="{E0C3C552-4AE8-4209-A205-D27F6C36C1A6}"/>
               </a:ext>
             </a:extLst>
           </p:cNvPr>
@@ -7607,7 +7607,7 @@
           <p:cNvPr id="16" name="timing-label">
             <a:extLst xmlns:a="http://schemas.openxmlformats.org/drawingml/2006/main">
               <a:ext uri="{FF2B5EF4-FFF2-40B4-BE49-F238E27FC236}">
-                <a16:creationId xmlns:a16="http://schemas.microsoft.com/office/drawing/2014/main" id="{52AA3CB0-30F5-4B84-9576-27246250BC23}"/>
+                <a16:creationId xmlns:a16="http://schemas.microsoft.com/office/drawing/2014/main" id="{DB28CFFD-7553-422C-8DE1-C1642E78EA4A}"/>
               </a:ext>
             </a:extLst>
           </p:cNvPr>
@@ -7671,7 +7671,7 @@
           <p:cNvPr id="17" name="claim">
             <a:extLst xmlns:a="http://schemas.openxmlformats.org/drawingml/2006/main">
               <a:ext uri="{FF2B5EF4-FFF2-40B4-BE49-F238E27FC236}">
-                <a16:creationId xmlns:a16="http://schemas.microsoft.com/office/drawing/2014/main" id="{5D3788F7-5891-4995-AAA0-09D69358E384}"/>
+                <a16:creationId xmlns:a16="http://schemas.microsoft.com/office/drawing/2014/main" id="{7217CEBF-5522-4BB3-8A8A-C7EF4D096D24}"/>
               </a:ext>
             </a:extLst>
           </p:cNvPr>
@@ -7735,7 +7735,7 @@
           <p:cNvPr id="18" name="">
             <a:extLst xmlns:a="http://schemas.openxmlformats.org/drawingml/2006/main">
               <a:ext uri="{FF2B5EF4-FFF2-40B4-BE49-F238E27FC236}">
-                <a16:creationId xmlns:a16="http://schemas.microsoft.com/office/drawing/2014/main" id="{CF296923-D1DF-4637-8E65-C667CAB12D83}"/>
+                <a16:creationId xmlns:a16="http://schemas.microsoft.com/office/drawing/2014/main" id="{E1860A82-977F-489B-8A09-40DAFE2E7D09}"/>
               </a:ext>
             </a:extLst>
           </p:cNvPr>
@@ -7770,7 +7770,7 @@
           <p:cNvPr id="19" name="">
             <a:extLst xmlns:a="http://schemas.openxmlformats.org/drawingml/2006/main">
               <a:ext uri="{FF2B5EF4-FFF2-40B4-BE49-F238E27FC236}">
-                <a16:creationId xmlns:a16="http://schemas.microsoft.com/office/drawing/2014/main" id="{15E3A2F0-20C4-48DA-822A-C41877B9FCA7}"/>
+                <a16:creationId xmlns:a16="http://schemas.microsoft.com/office/drawing/2014/main" id="{F28DBBC7-FFCE-463E-AB64-D0624AD0C16F}"/>
               </a:ext>
             </a:extLst>
           </p:cNvPr>
@@ -7805,7 +7805,7 @@
           <p:cNvPr id="20" name="">
             <a:extLst xmlns:a="http://schemas.openxmlformats.org/drawingml/2006/main">
               <a:ext uri="{FF2B5EF4-FFF2-40B4-BE49-F238E27FC236}">
-                <a16:creationId xmlns:a16="http://schemas.microsoft.com/office/drawing/2014/main" id="{CEDA5EEE-456E-4458-B2A8-5A38E0E98BF4}"/>
+                <a16:creationId xmlns:a16="http://schemas.microsoft.com/office/drawing/2014/main" id="{C6875385-857D-4B41-AE54-3B4D6E282F9A}"/>
               </a:ext>
             </a:extLst>
           </p:cNvPr>
@@ -7869,7 +7869,7 @@
           <p:cNvPr id="21" name="">
             <a:extLst xmlns:a="http://schemas.openxmlformats.org/drawingml/2006/main">
               <a:ext uri="{FF2B5EF4-FFF2-40B4-BE49-F238E27FC236}">
-                <a16:creationId xmlns:a16="http://schemas.microsoft.com/office/drawing/2014/main" id="{B9C64606-2BF0-4FFF-8108-53BD16358D24}"/>
+                <a16:creationId xmlns:a16="http://schemas.microsoft.com/office/drawing/2014/main" id="{E58F7EDD-69F5-401C-A72A-E941A0B98025}"/>
               </a:ext>
             </a:extLst>
           </p:cNvPr>
@@ -7933,7 +7933,7 @@
           <p:cNvPr id="22" name="">
             <a:extLst xmlns:a="http://schemas.openxmlformats.org/drawingml/2006/main">
               <a:ext uri="{FF2B5EF4-FFF2-40B4-BE49-F238E27FC236}">
-                <a16:creationId xmlns:a16="http://schemas.microsoft.com/office/drawing/2014/main" id="{12AA6204-D8B0-4CD5-B1D0-B68E59C146B1}"/>
+                <a16:creationId xmlns:a16="http://schemas.microsoft.com/office/drawing/2014/main" id="{83BF5EC1-2650-41A2-ACDA-CDC3D9B16B35}"/>
               </a:ext>
             </a:extLst>
           </p:cNvPr>
@@ -7997,7 +7997,7 @@
           <p:cNvPr id="23" name="">
             <a:extLst xmlns:a="http://schemas.openxmlformats.org/drawingml/2006/main">
               <a:ext uri="{FF2B5EF4-FFF2-40B4-BE49-F238E27FC236}">
-                <a16:creationId xmlns:a16="http://schemas.microsoft.com/office/drawing/2014/main" id="{22BED6BF-FAC6-46B7-97CF-0FFC133FFD53}"/>
+                <a16:creationId xmlns:a16="http://schemas.microsoft.com/office/drawing/2014/main" id="{6E4377C4-75A9-4BEE-A75B-2D87F72AFC92}"/>
               </a:ext>
             </a:extLst>
           </p:cNvPr>
@@ -8061,7 +8061,7 @@
           <p:cNvPr id="24" name="">
             <a:extLst xmlns:a="http://schemas.openxmlformats.org/drawingml/2006/main">
               <a:ext uri="{FF2B5EF4-FFF2-40B4-BE49-F238E27FC236}">
-                <a16:creationId xmlns:a16="http://schemas.microsoft.com/office/drawing/2014/main" id="{770B8E0A-DC73-4CB7-997B-5F62C1F3D9C8}"/>
+                <a16:creationId xmlns:a16="http://schemas.microsoft.com/office/drawing/2014/main" id="{84EF9241-4E15-4F33-AE8A-0C799B6624CB}"/>
               </a:ext>
             </a:extLst>
           </p:cNvPr>
@@ -8125,7 +8125,7 @@
           <p:cNvPr id="25" name="">
             <a:extLst xmlns:a="http://schemas.openxmlformats.org/drawingml/2006/main">
               <a:ext uri="{FF2B5EF4-FFF2-40B4-BE49-F238E27FC236}">
-                <a16:creationId xmlns:a16="http://schemas.microsoft.com/office/drawing/2014/main" id="{632C16E8-A83A-4D4A-ADC5-E0A811318619}"/>
+                <a16:creationId xmlns:a16="http://schemas.microsoft.com/office/drawing/2014/main" id="{9D8609EB-0C28-4F43-9293-82615D408E5B}"/>
               </a:ext>
             </a:extLst>
           </p:cNvPr>
@@ -8189,7 +8189,7 @@
           <p:cNvPr id="26" name="">
             <a:extLst xmlns:a="http://schemas.openxmlformats.org/drawingml/2006/main">
               <a:ext uri="{FF2B5EF4-FFF2-40B4-BE49-F238E27FC236}">
-                <a16:creationId xmlns:a16="http://schemas.microsoft.com/office/drawing/2014/main" id="{76594769-DE57-4815-A872-F567B05EB06D}"/>
+                <a16:creationId xmlns:a16="http://schemas.microsoft.com/office/drawing/2014/main" id="{EB8CE971-BE36-42F3-B3C3-0336AF7103D6}"/>
               </a:ext>
             </a:extLst>
           </p:cNvPr>
@@ -8224,7 +8224,7 @@
           <p:cNvPr id="27" name="">
             <a:extLst xmlns:a="http://schemas.openxmlformats.org/drawingml/2006/main">
               <a:ext uri="{FF2B5EF4-FFF2-40B4-BE49-F238E27FC236}">
-                <a16:creationId xmlns:a16="http://schemas.microsoft.com/office/drawing/2014/main" id="{5A79F369-CD1C-49E2-B11C-B9200E8888CC}"/>
+                <a16:creationId xmlns:a16="http://schemas.microsoft.com/office/drawing/2014/main" id="{FBB53E28-AE77-4E1B-8CCB-CFEA5232FE80}"/>
               </a:ext>
             </a:extLst>
           </p:cNvPr>
@@ -8288,7 +8288,7 @@
           <p:cNvPr id="28" name="">
             <a:extLst xmlns:a="http://schemas.openxmlformats.org/drawingml/2006/main">
               <a:ext uri="{FF2B5EF4-FFF2-40B4-BE49-F238E27FC236}">
-                <a16:creationId xmlns:a16="http://schemas.microsoft.com/office/drawing/2014/main" id="{FE62913C-0C7E-4D2F-96CA-3F0E8AED5D6D}"/>
+                <a16:creationId xmlns:a16="http://schemas.microsoft.com/office/drawing/2014/main" id="{641EFA96-1AA7-4861-8B0C-8B7C7A481EEA}"/>
               </a:ext>
             </a:extLst>
           </p:cNvPr>
@@ -8352,7 +8352,7 @@
           <p:cNvPr id="29" name="">
             <a:extLst xmlns:a="http://schemas.openxmlformats.org/drawingml/2006/main">
               <a:ext uri="{FF2B5EF4-FFF2-40B4-BE49-F238E27FC236}">
-                <a16:creationId xmlns:a16="http://schemas.microsoft.com/office/drawing/2014/main" id="{54AF0CB3-88C6-4BC1-A7DB-23EAE0972AE4}"/>
+                <a16:creationId xmlns:a16="http://schemas.microsoft.com/office/drawing/2014/main" id="{923B72CF-F53A-4435-9436-F002D9E81569}"/>
               </a:ext>
             </a:extLst>
           </p:cNvPr>
@@ -8416,7 +8416,7 @@
           <p:cNvPr id="30" name="">
             <a:extLst xmlns:a="http://schemas.openxmlformats.org/drawingml/2006/main">
               <a:ext uri="{FF2B5EF4-FFF2-40B4-BE49-F238E27FC236}">
-                <a16:creationId xmlns:a16="http://schemas.microsoft.com/office/drawing/2014/main" id="{38057E00-A916-4D71-89F2-1BFF4710DA71}"/>
+                <a16:creationId xmlns:a16="http://schemas.microsoft.com/office/drawing/2014/main" id="{00413E76-EE1A-4672-910A-15C440CCC705}"/>
               </a:ext>
             </a:extLst>
           </p:cNvPr>
@@ -8480,7 +8480,7 @@
           <p:cNvPr id="31" name="">
             <a:extLst xmlns:a="http://schemas.openxmlformats.org/drawingml/2006/main">
               <a:ext uri="{FF2B5EF4-FFF2-40B4-BE49-F238E27FC236}">
-                <a16:creationId xmlns:a16="http://schemas.microsoft.com/office/drawing/2014/main" id="{2F8010F4-C97E-4525-B634-978B99DB2C20}"/>
+                <a16:creationId xmlns:a16="http://schemas.microsoft.com/office/drawing/2014/main" id="{903E73DC-EB4C-4705-B7C6-647EE2954D5C}"/>
               </a:ext>
             </a:extLst>
           </p:cNvPr>
@@ -8515,7 +8515,7 @@
           <p:cNvPr id="32" name="">
             <a:extLst xmlns:a="http://schemas.openxmlformats.org/drawingml/2006/main">
               <a:ext uri="{FF2B5EF4-FFF2-40B4-BE49-F238E27FC236}">
-                <a16:creationId xmlns:a16="http://schemas.microsoft.com/office/drawing/2014/main" id="{49909241-3D1D-497D-A303-0FE60DA7714E}"/>
+                <a16:creationId xmlns:a16="http://schemas.microsoft.com/office/drawing/2014/main" id="{45D9FC23-EFA7-41FC-9096-31563A0CC55F}"/>
               </a:ext>
             </a:extLst>
           </p:cNvPr>
@@ -8579,7 +8579,7 @@
           <p:cNvPr id="33" name="">
             <a:extLst xmlns:a="http://schemas.openxmlformats.org/drawingml/2006/main">
               <a:ext uri="{FF2B5EF4-FFF2-40B4-BE49-F238E27FC236}">
-                <a16:creationId xmlns:a16="http://schemas.microsoft.com/office/drawing/2014/main" id="{7D3553EE-0330-4871-8D73-B2A05F3F2D0B}"/>
+                <a16:creationId xmlns:a16="http://schemas.microsoft.com/office/drawing/2014/main" id="{ED7F3336-EDD5-428D-A406-13B7802181C3}"/>
               </a:ext>
             </a:extLst>
           </p:cNvPr>
@@ -8643,7 +8643,7 @@
           <p:cNvPr id="34" name="">
             <a:extLst xmlns:a="http://schemas.openxmlformats.org/drawingml/2006/main">
               <a:ext uri="{FF2B5EF4-FFF2-40B4-BE49-F238E27FC236}">
-                <a16:creationId xmlns:a16="http://schemas.microsoft.com/office/drawing/2014/main" id="{60472408-F4F6-4FA1-AED6-585A1A60332D}"/>
+                <a16:creationId xmlns:a16="http://schemas.microsoft.com/office/drawing/2014/main" id="{46C70653-6F6F-4A37-8DC9-A6AD051E2805}"/>
               </a:ext>
             </a:extLst>
           </p:cNvPr>
@@ -8707,7 +8707,7 @@
           <p:cNvPr id="35" name="">
             <a:extLst xmlns:a="http://schemas.openxmlformats.org/drawingml/2006/main">
               <a:ext uri="{FF2B5EF4-FFF2-40B4-BE49-F238E27FC236}">
-                <a16:creationId xmlns:a16="http://schemas.microsoft.com/office/drawing/2014/main" id="{3402454F-9210-4617-811D-03322F44A4B6}"/>
+                <a16:creationId xmlns:a16="http://schemas.microsoft.com/office/drawing/2014/main" id="{BD1E687F-07F2-44D3-9CCC-5B0742877B79}"/>
               </a:ext>
             </a:extLst>
           </p:cNvPr>
@@ -8771,7 +8771,7 @@
           <p:cNvPr id="36" name="">
             <a:extLst xmlns:a="http://schemas.openxmlformats.org/drawingml/2006/main">
               <a:ext uri="{FF2B5EF4-FFF2-40B4-BE49-F238E27FC236}">
-                <a16:creationId xmlns:a16="http://schemas.microsoft.com/office/drawing/2014/main" id="{858D3FE8-64B4-4FB6-9C22-18A88C08BA9E}"/>
+                <a16:creationId xmlns:a16="http://schemas.microsoft.com/office/drawing/2014/main" id="{44CD6F42-6D90-4919-ADCD-94D4DB63F397}"/>
               </a:ext>
             </a:extLst>
           </p:cNvPr>
@@ -8919,7 +8919,7 @@
           <p:nvPr/>
         </p:nvPicPr>
         <p:blipFill>
-          <a:blip xmlns:r="http://schemas.openxmlformats.org/officeDocument/2006/relationships" xmlns:a="http://schemas.openxmlformats.org/drawingml/2006/main" r:embed="Ree3872a24b044d3a"/>
+          <a:blip xmlns:r="http://schemas.openxmlformats.org/officeDocument/2006/relationships" xmlns:a="http://schemas.openxmlformats.org/drawingml/2006/main" r:embed="R52e006911e2849e1"/>
           <a:stretch xmlns:a="http://schemas.openxmlformats.org/drawingml/2006/main"/>
         </p:blipFill>
         <p:spPr>
@@ -10307,7 +10307,7 @@
           <p:cNvPr id="34" name="timing-pill">
             <a:extLst xmlns:a="http://schemas.openxmlformats.org/drawingml/2006/main">
               <a:ext uri="{FF2B5EF4-FFF2-40B4-BE49-F238E27FC236}">
-                <a16:creationId xmlns:a16="http://schemas.microsoft.com/office/drawing/2014/main" id="{6D89B913-F4C7-445F-B107-2F44A9D944AD}"/>
+                <a16:creationId xmlns:a16="http://schemas.microsoft.com/office/drawing/2014/main" id="{2F93C3C6-37D9-4E25-B7D6-D0AF1A63447D}"/>
               </a:ext>
             </a:extLst>
           </p:cNvPr>
@@ -10342,7 +10342,7 @@
           <p:cNvPr id="35" name="timing-label">
             <a:extLst xmlns:a="http://schemas.openxmlformats.org/drawingml/2006/main">
               <a:ext uri="{FF2B5EF4-FFF2-40B4-BE49-F238E27FC236}">
-                <a16:creationId xmlns:a16="http://schemas.microsoft.com/office/drawing/2014/main" id="{4A99F9CD-58B2-4C3F-9864-29F0907637F3}"/>
+                <a16:creationId xmlns:a16="http://schemas.microsoft.com/office/drawing/2014/main" id="{23E8E356-9B86-4D48-AFFB-3B36F1535F67}"/>
               </a:ext>
             </a:extLst>
           </p:cNvPr>
@@ -10406,7 +10406,7 @@
           <p:cNvPr id="36" name="claim">
             <a:extLst xmlns:a="http://schemas.openxmlformats.org/drawingml/2006/main">
               <a:ext uri="{FF2B5EF4-FFF2-40B4-BE49-F238E27FC236}">
-                <a16:creationId xmlns:a16="http://schemas.microsoft.com/office/drawing/2014/main" id="{5661019F-8BE5-4D15-AF4B-6AB1C8E77F5B}"/>
+                <a16:creationId xmlns:a16="http://schemas.microsoft.com/office/drawing/2014/main" id="{F4966C5C-0B4D-4A9D-959F-6F83FB871015}"/>
               </a:ext>
             </a:extLst>
           </p:cNvPr>
@@ -10474,7 +10474,7 @@
           <p:nvPr/>
         </p:nvPicPr>
         <p:blipFill>
-          <a:blip xmlns:r="http://schemas.openxmlformats.org/officeDocument/2006/relationships" xmlns:a="http://schemas.openxmlformats.org/drawingml/2006/main" r:embed="Rbe3dfb9752ba49ec"/>
+          <a:blip xmlns:r="http://schemas.openxmlformats.org/officeDocument/2006/relationships" xmlns:a="http://schemas.openxmlformats.org/drawingml/2006/main" r:embed="Rab92e8a062c347ff"/>
           <a:stretch xmlns:a="http://schemas.openxmlformats.org/drawingml/2006/main"/>
         </p:blipFill>
         <p:spPr>
@@ -10608,7 +10608,7 @@
           <p:nvPr/>
         </p:nvPicPr>
         <p:blipFill>
-          <a:blip xmlns:r="http://schemas.openxmlformats.org/officeDocument/2006/relationships" xmlns:a="http://schemas.openxmlformats.org/drawingml/2006/main" r:embed="R262c204f7d304002"/>
+          <a:blip xmlns:r="http://schemas.openxmlformats.org/officeDocument/2006/relationships" xmlns:a="http://schemas.openxmlformats.org/drawingml/2006/main" r:embed="R016f62d1876644d7"/>
           <a:stretch xmlns:a="http://schemas.openxmlformats.org/drawingml/2006/main"/>
         </p:blipFill>
         <p:spPr>
@@ -11996,7 +11996,7 @@
           <p:cNvPr id="34" name="timing-pill">
             <a:extLst xmlns:a="http://schemas.openxmlformats.org/drawingml/2006/main">
               <a:ext uri="{FF2B5EF4-FFF2-40B4-BE49-F238E27FC236}">
-                <a16:creationId xmlns:a16="http://schemas.microsoft.com/office/drawing/2014/main" id="{D771E9DF-4F14-4581-A46C-AD7346719E2A}"/>
+                <a16:creationId xmlns:a16="http://schemas.microsoft.com/office/drawing/2014/main" id="{22A9F6FB-E6CA-409B-9918-D3191E399035}"/>
               </a:ext>
             </a:extLst>
           </p:cNvPr>
@@ -12031,7 +12031,7 @@
           <p:cNvPr id="35" name="timing-label">
             <a:extLst xmlns:a="http://schemas.openxmlformats.org/drawingml/2006/main">
               <a:ext uri="{FF2B5EF4-FFF2-40B4-BE49-F238E27FC236}">
-                <a16:creationId xmlns:a16="http://schemas.microsoft.com/office/drawing/2014/main" id="{132C4718-EE86-4061-BFC8-512F775D893E}"/>
+                <a16:creationId xmlns:a16="http://schemas.microsoft.com/office/drawing/2014/main" id="{4F0A0DBD-7CFF-4C28-92C9-5DEA92A2E555}"/>
               </a:ext>
             </a:extLst>
           </p:cNvPr>
@@ -12099,7 +12099,7 @@
           <p:nvPr/>
         </p:nvPicPr>
         <p:blipFill>
-          <a:blip xmlns:r="http://schemas.openxmlformats.org/officeDocument/2006/relationships" xmlns:a="http://schemas.openxmlformats.org/drawingml/2006/main" r:embed="Rf3444a841be2406f"/>
+          <a:blip xmlns:r="http://schemas.openxmlformats.org/officeDocument/2006/relationships" xmlns:a="http://schemas.openxmlformats.org/drawingml/2006/main" r:embed="R71068e4e1423462f"/>
           <a:stretch xmlns:a="http://schemas.openxmlformats.org/drawingml/2006/main"/>
         </p:blipFill>
         <p:spPr>
@@ -12230,7 +12230,7 @@
           <p:nvPr/>
         </p:nvPicPr>
         <p:blipFill>
-          <a:blip xmlns:r="http://schemas.openxmlformats.org/officeDocument/2006/relationships" xmlns:a="http://schemas.openxmlformats.org/drawingml/2006/main" r:embed="R4223cac10cec4c62"/>
+          <a:blip xmlns:r="http://schemas.openxmlformats.org/officeDocument/2006/relationships" xmlns:a="http://schemas.openxmlformats.org/drawingml/2006/main" r:embed="R77e1475930f541e7"/>
           <a:stretch xmlns:a="http://schemas.openxmlformats.org/drawingml/2006/main"/>
         </p:blipFill>
         <p:spPr>
@@ -13068,7 +13068,7 @@
           <p:cNvPr id="23" name="timing-pill">
             <a:extLst xmlns:a="http://schemas.openxmlformats.org/drawingml/2006/main">
               <a:ext uri="{FF2B5EF4-FFF2-40B4-BE49-F238E27FC236}">
-                <a16:creationId xmlns:a16="http://schemas.microsoft.com/office/drawing/2014/main" id="{009210D4-1C29-4CAF-AE04-43E8996649E5}"/>
+                <a16:creationId xmlns:a16="http://schemas.microsoft.com/office/drawing/2014/main" id="{B3B8DC18-FAC6-4B32-853A-34D5CA7605E6}"/>
               </a:ext>
             </a:extLst>
           </p:cNvPr>
@@ -13103,7 +13103,7 @@
           <p:cNvPr id="24" name="timing-label">
             <a:extLst xmlns:a="http://schemas.openxmlformats.org/drawingml/2006/main">
               <a:ext uri="{FF2B5EF4-FFF2-40B4-BE49-F238E27FC236}">
-                <a16:creationId xmlns:a16="http://schemas.microsoft.com/office/drawing/2014/main" id="{3B5DC6E3-C643-450C-A537-BCA2A359E494}"/>
+                <a16:creationId xmlns:a16="http://schemas.microsoft.com/office/drawing/2014/main" id="{7FBA74B3-79CD-4B6E-B0C2-6F28E4304943}"/>
               </a:ext>
             </a:extLst>
           </p:cNvPr>
@@ -13283,7 +13283,7 @@
           <p:nvPr/>
         </p:nvPicPr>
         <p:blipFill>
-          <a:blip xmlns:r="http://schemas.openxmlformats.org/officeDocument/2006/relationships" xmlns:a="http://schemas.openxmlformats.org/drawingml/2006/main" r:embed="R22ce1676151e475d"/>
+          <a:blip xmlns:r="http://schemas.openxmlformats.org/officeDocument/2006/relationships" xmlns:a="http://schemas.openxmlformats.org/drawingml/2006/main" r:embed="Re1e92347ff6e4ba8"/>
           <a:stretch xmlns:a="http://schemas.openxmlformats.org/drawingml/2006/main"/>
         </p:blipFill>
         <p:spPr>
@@ -14671,7 +14671,7 @@
           <p:cNvPr id="34" name="timing-pill">
             <a:extLst xmlns:a="http://schemas.openxmlformats.org/drawingml/2006/main">
               <a:ext uri="{FF2B5EF4-FFF2-40B4-BE49-F238E27FC236}">
-                <a16:creationId xmlns:a16="http://schemas.microsoft.com/office/drawing/2014/main" id="{EDD11B1A-39E5-4A70-8E70-C1C62F5AC8FF}"/>
+                <a16:creationId xmlns:a16="http://schemas.microsoft.com/office/drawing/2014/main" id="{9883073A-94F6-4976-AB6B-B5332A3090B2}"/>
               </a:ext>
             </a:extLst>
           </p:cNvPr>
@@ -14706,7 +14706,7 @@
           <p:cNvPr id="35" name="timing-label">
             <a:extLst xmlns:a="http://schemas.openxmlformats.org/drawingml/2006/main">
               <a:ext uri="{FF2B5EF4-FFF2-40B4-BE49-F238E27FC236}">
-                <a16:creationId xmlns:a16="http://schemas.microsoft.com/office/drawing/2014/main" id="{B718AD12-B35E-4861-9CD7-5228226C5463}"/>
+                <a16:creationId xmlns:a16="http://schemas.microsoft.com/office/drawing/2014/main" id="{818D5E4B-60BA-4D00-B91E-9B3E48CA8C5A}"/>
               </a:ext>
             </a:extLst>
           </p:cNvPr>
@@ -15106,7 +15106,7 @@
           <p:nvPr/>
         </p:nvPicPr>
         <p:blipFill>
-          <a:blip xmlns:r="http://schemas.openxmlformats.org/officeDocument/2006/relationships" xmlns:a="http://schemas.openxmlformats.org/drawingml/2006/main" r:embed="Ra00bc6f3f43d40a4"/>
+          <a:blip xmlns:r="http://schemas.openxmlformats.org/officeDocument/2006/relationships" xmlns:a="http://schemas.openxmlformats.org/drawingml/2006/main" r:embed="R9b3b66f9bc4c4f90"/>
           <a:stretch xmlns:a="http://schemas.openxmlformats.org/drawingml/2006/main"/>
         </p:blipFill>
         <p:spPr>
@@ -15124,7 +15124,7 @@
           <p:cNvPr id="15" name="timing-pill">
             <a:extLst xmlns:a="http://schemas.openxmlformats.org/drawingml/2006/main">
               <a:ext uri="{FF2B5EF4-FFF2-40B4-BE49-F238E27FC236}">
-                <a16:creationId xmlns:a16="http://schemas.microsoft.com/office/drawing/2014/main" id="{004AED08-2C65-4F81-82AF-D30669498596}"/>
+                <a16:creationId xmlns:a16="http://schemas.microsoft.com/office/drawing/2014/main" id="{25F9C551-74E7-485E-8DF4-F43BB3D2061A}"/>
               </a:ext>
             </a:extLst>
           </p:cNvPr>
@@ -15159,7 +15159,7 @@
           <p:cNvPr id="16" name="timing-label">
             <a:extLst xmlns:a="http://schemas.openxmlformats.org/drawingml/2006/main">
               <a:ext uri="{FF2B5EF4-FFF2-40B4-BE49-F238E27FC236}">
-                <a16:creationId xmlns:a16="http://schemas.microsoft.com/office/drawing/2014/main" id="{6C475C8C-099C-4776-A303-D84548AF249F}"/>
+                <a16:creationId xmlns:a16="http://schemas.microsoft.com/office/drawing/2014/main" id="{3D01A90C-10E5-4898-8A71-AEC51A19A9F0}"/>
               </a:ext>
             </a:extLst>
           </p:cNvPr>
@@ -15223,7 +15223,7 @@
           <p:cNvPr id="17" name="claim">
             <a:extLst xmlns:a="http://schemas.openxmlformats.org/drawingml/2006/main">
               <a:ext uri="{FF2B5EF4-FFF2-40B4-BE49-F238E27FC236}">
-                <a16:creationId xmlns:a16="http://schemas.microsoft.com/office/drawing/2014/main" id="{889E499F-31CC-4340-9767-4DBE99CC56EF}"/>
+                <a16:creationId xmlns:a16="http://schemas.microsoft.com/office/drawing/2014/main" id="{0B01B7D8-ED58-404F-95FC-BBFD9C340E56}"/>
               </a:ext>
             </a:extLst>
           </p:cNvPr>
@@ -15287,7 +15287,7 @@
           <p:cNvPr id="18" name="">
             <a:extLst xmlns:a="http://schemas.openxmlformats.org/drawingml/2006/main">
               <a:ext uri="{FF2B5EF4-FFF2-40B4-BE49-F238E27FC236}">
-                <a16:creationId xmlns:a16="http://schemas.microsoft.com/office/drawing/2014/main" id="{2CF0F488-111D-4B49-A834-D4E86CA4A2CB}"/>
+                <a16:creationId xmlns:a16="http://schemas.microsoft.com/office/drawing/2014/main" id="{A5FB7AA6-8AA4-4D93-A10E-9EFE3DE38C09}"/>
               </a:ext>
             </a:extLst>
           </p:cNvPr>
@@ -15351,7 +15351,7 @@
           <p:cNvPr id="19" name="">
             <a:extLst xmlns:a="http://schemas.openxmlformats.org/drawingml/2006/main">
               <a:ext uri="{FF2B5EF4-FFF2-40B4-BE49-F238E27FC236}">
-                <a16:creationId xmlns:a16="http://schemas.microsoft.com/office/drawing/2014/main" id="{EDB14047-7432-4A5C-95A2-7ADFB616F948}"/>
+                <a16:creationId xmlns:a16="http://schemas.microsoft.com/office/drawing/2014/main" id="{CCFE9A7B-9800-430C-86D7-BACC74CDF5EE}"/>
               </a:ext>
             </a:extLst>
           </p:cNvPr>
@@ -15415,7 +15415,7 @@
           <p:cNvPr id="20" name="">
             <a:extLst xmlns:a="http://schemas.openxmlformats.org/drawingml/2006/main">
               <a:ext uri="{FF2B5EF4-FFF2-40B4-BE49-F238E27FC236}">
-                <a16:creationId xmlns:a16="http://schemas.microsoft.com/office/drawing/2014/main" id="{519083F4-F505-481D-A862-02B7DE2F608C}"/>
+                <a16:creationId xmlns:a16="http://schemas.microsoft.com/office/drawing/2014/main" id="{A365CE2F-B78F-4EB8-8084-F4671CB24DAA}"/>
               </a:ext>
             </a:extLst>
           </p:cNvPr>
@@ -15452,7 +15452,7 @@
           <p:cNvPr id="21" name="">
             <a:extLst xmlns:a="http://schemas.openxmlformats.org/drawingml/2006/main">
               <a:ext uri="{FF2B5EF4-FFF2-40B4-BE49-F238E27FC236}">
-                <a16:creationId xmlns:a16="http://schemas.microsoft.com/office/drawing/2014/main" id="{50DF3D73-DC19-4EC5-938A-C95707CA1C98}"/>
+                <a16:creationId xmlns:a16="http://schemas.microsoft.com/office/drawing/2014/main" id="{5BDAE1E6-86DC-42D6-9544-234536B4F38A}"/>
               </a:ext>
             </a:extLst>
           </p:cNvPr>
@@ -15489,7 +15489,7 @@
           <p:cNvPr id="22" name="">
             <a:extLst xmlns:a="http://schemas.openxmlformats.org/drawingml/2006/main">
               <a:ext uri="{FF2B5EF4-FFF2-40B4-BE49-F238E27FC236}">
-                <a16:creationId xmlns:a16="http://schemas.microsoft.com/office/drawing/2014/main" id="{BA27E149-9582-4896-8542-0D62668E80BD}"/>
+                <a16:creationId xmlns:a16="http://schemas.microsoft.com/office/drawing/2014/main" id="{2D426669-D460-4E5F-8D41-B870E5636930}"/>
               </a:ext>
             </a:extLst>
           </p:cNvPr>
@@ -15553,7 +15553,7 @@
           <p:cNvPr id="23" name="">
             <a:extLst xmlns:a="http://schemas.openxmlformats.org/drawingml/2006/main">
               <a:ext uri="{FF2B5EF4-FFF2-40B4-BE49-F238E27FC236}">
-                <a16:creationId xmlns:a16="http://schemas.microsoft.com/office/drawing/2014/main" id="{9429F3CB-E4D6-4E26-92CA-43E7EA8C39FD}"/>
+                <a16:creationId xmlns:a16="http://schemas.microsoft.com/office/drawing/2014/main" id="{960CEDED-8BF6-4F41-BDFF-D9B4ED68DBD9}"/>
               </a:ext>
             </a:extLst>
           </p:cNvPr>
@@ -15617,7 +15617,7 @@
           <p:cNvPr id="24" name="">
             <a:extLst xmlns:a="http://schemas.openxmlformats.org/drawingml/2006/main">
               <a:ext uri="{FF2B5EF4-FFF2-40B4-BE49-F238E27FC236}">
-                <a16:creationId xmlns:a16="http://schemas.microsoft.com/office/drawing/2014/main" id="{CD3F5AB1-4929-4580-AAA3-6BFE96A6373A}"/>
+                <a16:creationId xmlns:a16="http://schemas.microsoft.com/office/drawing/2014/main" id="{84D65975-100C-4B83-866E-F241F4145B4F}"/>
               </a:ext>
             </a:extLst>
           </p:cNvPr>
@@ -15654,7 +15654,7 @@
           <p:cNvPr id="25" name="">
             <a:extLst xmlns:a="http://schemas.openxmlformats.org/drawingml/2006/main">
               <a:ext uri="{FF2B5EF4-FFF2-40B4-BE49-F238E27FC236}">
-                <a16:creationId xmlns:a16="http://schemas.microsoft.com/office/drawing/2014/main" id="{A14BA109-91AF-4582-A0FC-D1FE684D5291}"/>
+                <a16:creationId xmlns:a16="http://schemas.microsoft.com/office/drawing/2014/main" id="{53FD6F7A-42B3-46F8-923F-38E853F3A1C5}"/>
               </a:ext>
             </a:extLst>
           </p:cNvPr>
@@ -15691,7 +15691,7 @@
           <p:cNvPr id="26" name="">
             <a:extLst xmlns:a="http://schemas.openxmlformats.org/drawingml/2006/main">
               <a:ext uri="{FF2B5EF4-FFF2-40B4-BE49-F238E27FC236}">
-                <a16:creationId xmlns:a16="http://schemas.microsoft.com/office/drawing/2014/main" id="{6F80E298-B083-466C-951D-1B9495F78289}"/>
+                <a16:creationId xmlns:a16="http://schemas.microsoft.com/office/drawing/2014/main" id="{1C1D0F5E-69E9-46D3-AB8C-8D270ABDE954}"/>
               </a:ext>
             </a:extLst>
           </p:cNvPr>
@@ -15755,7 +15755,7 @@
           <p:cNvPr id="27" name="">
             <a:extLst xmlns:a="http://schemas.openxmlformats.org/drawingml/2006/main">
               <a:ext uri="{FF2B5EF4-FFF2-40B4-BE49-F238E27FC236}">
-                <a16:creationId xmlns:a16="http://schemas.microsoft.com/office/drawing/2014/main" id="{9A59DBD1-0468-4B4E-8A47-38430735D9BB}"/>
+                <a16:creationId xmlns:a16="http://schemas.microsoft.com/office/drawing/2014/main" id="{B7B900B0-F778-49EF-B84F-AD2366D88BD9}"/>
               </a:ext>
             </a:extLst>
           </p:cNvPr>
@@ -15819,7 +15819,7 @@
           <p:cNvPr id="28" name="">
             <a:extLst xmlns:a="http://schemas.openxmlformats.org/drawingml/2006/main">
               <a:ext uri="{FF2B5EF4-FFF2-40B4-BE49-F238E27FC236}">
-                <a16:creationId xmlns:a16="http://schemas.microsoft.com/office/drawing/2014/main" id="{D9358F49-5E3C-4196-ABC5-B499A5903141}"/>
+                <a16:creationId xmlns:a16="http://schemas.microsoft.com/office/drawing/2014/main" id="{32ED4D52-3EEA-41AD-906A-1E6369239B28}"/>
               </a:ext>
             </a:extLst>
           </p:cNvPr>
@@ -15856,7 +15856,7 @@
           <p:cNvPr id="29" name="">
             <a:extLst xmlns:a="http://schemas.openxmlformats.org/drawingml/2006/main">
               <a:ext uri="{FF2B5EF4-FFF2-40B4-BE49-F238E27FC236}">
-                <a16:creationId xmlns:a16="http://schemas.microsoft.com/office/drawing/2014/main" id="{0180521E-F798-4931-8AB7-553B12A90B23}"/>
+                <a16:creationId xmlns:a16="http://schemas.microsoft.com/office/drawing/2014/main" id="{C6144F7E-5CC8-4138-9CB6-982D6DF57A06}"/>
               </a:ext>
             </a:extLst>
           </p:cNvPr>
@@ -15893,7 +15893,7 @@
           <p:cNvPr id="30" name="">
             <a:extLst xmlns:a="http://schemas.openxmlformats.org/drawingml/2006/main">
               <a:ext uri="{FF2B5EF4-FFF2-40B4-BE49-F238E27FC236}">
-                <a16:creationId xmlns:a16="http://schemas.microsoft.com/office/drawing/2014/main" id="{23DC719A-AD44-4C3F-8D25-11D26BAE9901}"/>
+                <a16:creationId xmlns:a16="http://schemas.microsoft.com/office/drawing/2014/main" id="{FD56F7F5-8CFC-4A35-BBC8-B674FDABA0AA}"/>
               </a:ext>
             </a:extLst>
           </p:cNvPr>
@@ -15957,7 +15957,7 @@
           <p:cNvPr id="31" name="">
             <a:extLst xmlns:a="http://schemas.openxmlformats.org/drawingml/2006/main">
               <a:ext uri="{FF2B5EF4-FFF2-40B4-BE49-F238E27FC236}">
-                <a16:creationId xmlns:a16="http://schemas.microsoft.com/office/drawing/2014/main" id="{D9C11C8B-0129-4E14-BC9E-299641786340}"/>
+                <a16:creationId xmlns:a16="http://schemas.microsoft.com/office/drawing/2014/main" id="{0587A1D1-2FD1-492D-B634-E9EB03D93966}"/>
               </a:ext>
             </a:extLst>
           </p:cNvPr>
@@ -16021,7 +16021,7 @@
           <p:cNvPr id="32" name="">
             <a:extLst xmlns:a="http://schemas.openxmlformats.org/drawingml/2006/main">
               <a:ext uri="{FF2B5EF4-FFF2-40B4-BE49-F238E27FC236}">
-                <a16:creationId xmlns:a16="http://schemas.microsoft.com/office/drawing/2014/main" id="{5A9B4C2E-3953-404B-A0FB-A7EB30417C14}"/>
+                <a16:creationId xmlns:a16="http://schemas.microsoft.com/office/drawing/2014/main" id="{31BF921D-0CDE-4F14-AF86-4E7109AAE096}"/>
               </a:ext>
             </a:extLst>
           </p:cNvPr>
@@ -16058,7 +16058,7 @@
           <p:cNvPr id="33" name="">
             <a:extLst xmlns:a="http://schemas.openxmlformats.org/drawingml/2006/main">
               <a:ext uri="{FF2B5EF4-FFF2-40B4-BE49-F238E27FC236}">
-                <a16:creationId xmlns:a16="http://schemas.microsoft.com/office/drawing/2014/main" id="{C11F72B9-3E72-4DBF-90CB-200D97AB70E8}"/>
+                <a16:creationId xmlns:a16="http://schemas.microsoft.com/office/drawing/2014/main" id="{9B65B482-517B-4342-8DAD-89D52F6ED2C7}"/>
               </a:ext>
             </a:extLst>
           </p:cNvPr>
@@ -16095,7 +16095,7 @@
           <p:cNvPr id="34" name="">
             <a:extLst xmlns:a="http://schemas.openxmlformats.org/drawingml/2006/main">
               <a:ext uri="{FF2B5EF4-FFF2-40B4-BE49-F238E27FC236}">
-                <a16:creationId xmlns:a16="http://schemas.microsoft.com/office/drawing/2014/main" id="{AADA1404-24B5-420D-9CC7-423FECB24875}"/>
+                <a16:creationId xmlns:a16="http://schemas.microsoft.com/office/drawing/2014/main" id="{D64610B8-5D37-41B1-963E-2DCA88C603F4}"/>
               </a:ext>
             </a:extLst>
           </p:cNvPr>
@@ -16159,7 +16159,7 @@
           <p:cNvPr id="35" name="">
             <a:extLst xmlns:a="http://schemas.openxmlformats.org/drawingml/2006/main">
               <a:ext uri="{FF2B5EF4-FFF2-40B4-BE49-F238E27FC236}">
-                <a16:creationId xmlns:a16="http://schemas.microsoft.com/office/drawing/2014/main" id="{99A063F4-B2C1-4FF7-8144-3BD369D1C72C}"/>
+                <a16:creationId xmlns:a16="http://schemas.microsoft.com/office/drawing/2014/main" id="{6217F7E1-CAE2-476F-B32D-E54462A126FB}"/>
               </a:ext>
             </a:extLst>
           </p:cNvPr>
@@ -16223,7 +16223,7 @@
           <p:cNvPr id="36" name="">
             <a:extLst xmlns:a="http://schemas.openxmlformats.org/drawingml/2006/main">
               <a:ext uri="{FF2B5EF4-FFF2-40B4-BE49-F238E27FC236}">
-                <a16:creationId xmlns:a16="http://schemas.microsoft.com/office/drawing/2014/main" id="{0A330AE8-282E-4666-A9EF-AA4EC2C75E2B}"/>
+                <a16:creationId xmlns:a16="http://schemas.microsoft.com/office/drawing/2014/main" id="{A63E3887-D492-469F-B3CA-5D6A5E28960F}"/>
               </a:ext>
             </a:extLst>
           </p:cNvPr>
@@ -16260,7 +16260,7 @@
           <p:cNvPr id="37" name="">
             <a:extLst xmlns:a="http://schemas.openxmlformats.org/drawingml/2006/main">
               <a:ext uri="{FF2B5EF4-FFF2-40B4-BE49-F238E27FC236}">
-                <a16:creationId xmlns:a16="http://schemas.microsoft.com/office/drawing/2014/main" id="{D62F0663-DBFE-4222-8981-C996181E0A9A}"/>
+                <a16:creationId xmlns:a16="http://schemas.microsoft.com/office/drawing/2014/main" id="{0FBE7A8E-9540-44A0-8710-DD66720E97DA}"/>
               </a:ext>
             </a:extLst>
           </p:cNvPr>
@@ -16297,7 +16297,7 @@
           <p:cNvPr id="38" name="">
             <a:extLst xmlns:a="http://schemas.openxmlformats.org/drawingml/2006/main">
               <a:ext uri="{FF2B5EF4-FFF2-40B4-BE49-F238E27FC236}">
-                <a16:creationId xmlns:a16="http://schemas.microsoft.com/office/drawing/2014/main" id="{85B25E44-AD2B-4DAB-B6DC-E0DEBDA4B844}"/>
+                <a16:creationId xmlns:a16="http://schemas.microsoft.com/office/drawing/2014/main" id="{9915402F-F4A1-47C8-B936-08D6CE4797CE}"/>
               </a:ext>
             </a:extLst>
           </p:cNvPr>
@@ -16361,7 +16361,7 @@
           <p:cNvPr id="39" name="">
             <a:extLst xmlns:a="http://schemas.openxmlformats.org/drawingml/2006/main">
               <a:ext uri="{FF2B5EF4-FFF2-40B4-BE49-F238E27FC236}">
-                <a16:creationId xmlns:a16="http://schemas.microsoft.com/office/drawing/2014/main" id="{3F29F039-DB30-43A0-A2EE-24C02604CF66}"/>
+                <a16:creationId xmlns:a16="http://schemas.microsoft.com/office/drawing/2014/main" id="{7AC609E4-83FE-494C-BF5A-416F9B07B94F}"/>
               </a:ext>
             </a:extLst>
           </p:cNvPr>
@@ -16425,7 +16425,7 @@
           <p:cNvPr id="40" name="">
             <a:extLst xmlns:a="http://schemas.openxmlformats.org/drawingml/2006/main">
               <a:ext uri="{FF2B5EF4-FFF2-40B4-BE49-F238E27FC236}">
-                <a16:creationId xmlns:a16="http://schemas.microsoft.com/office/drawing/2014/main" id="{543DB9BD-6948-4C91-86A4-AF39FE571B46}"/>
+                <a16:creationId xmlns:a16="http://schemas.microsoft.com/office/drawing/2014/main" id="{9E944024-0072-4A74-ACF2-88129FE93AD2}"/>
               </a:ext>
             </a:extLst>
           </p:cNvPr>
@@ -16462,7 +16462,7 @@
           <p:cNvPr id="41" name="">
             <a:extLst xmlns:a="http://schemas.openxmlformats.org/drawingml/2006/main">
               <a:ext uri="{FF2B5EF4-FFF2-40B4-BE49-F238E27FC236}">
-                <a16:creationId xmlns:a16="http://schemas.microsoft.com/office/drawing/2014/main" id="{B071490E-DFFB-407E-B428-8148DFCBCDB7}"/>
+                <a16:creationId xmlns:a16="http://schemas.microsoft.com/office/drawing/2014/main" id="{ECD79062-C7D4-4228-A688-B06837D2FD5B}"/>
               </a:ext>
             </a:extLst>
           </p:cNvPr>
@@ -16499,7 +16499,7 @@
           <p:cNvPr id="42" name="">
             <a:extLst xmlns:a="http://schemas.openxmlformats.org/drawingml/2006/main">
               <a:ext uri="{FF2B5EF4-FFF2-40B4-BE49-F238E27FC236}">
-                <a16:creationId xmlns:a16="http://schemas.microsoft.com/office/drawing/2014/main" id="{64D3A6DC-995B-41AB-95EF-2838B4B785EC}"/>
+                <a16:creationId xmlns:a16="http://schemas.microsoft.com/office/drawing/2014/main" id="{F3215AD0-7BF3-416D-BF6C-25ACCEDB5DE3}"/>
               </a:ext>
             </a:extLst>
           </p:cNvPr>
@@ -16563,7 +16563,7 @@
           <p:cNvPr id="43" name="">
             <a:extLst xmlns:a="http://schemas.openxmlformats.org/drawingml/2006/main">
               <a:ext uri="{FF2B5EF4-FFF2-40B4-BE49-F238E27FC236}">
-                <a16:creationId xmlns:a16="http://schemas.microsoft.com/office/drawing/2014/main" id="{615DD9F8-7619-4285-8C8E-E2FDE3C07226}"/>
+                <a16:creationId xmlns:a16="http://schemas.microsoft.com/office/drawing/2014/main" id="{0E8BE5E7-73F8-4ACA-97FA-F6147C1C469F}"/>
               </a:ext>
             </a:extLst>
           </p:cNvPr>
@@ -16627,7 +16627,7 @@
           <p:cNvPr id="44" name="">
             <a:extLst xmlns:a="http://schemas.openxmlformats.org/drawingml/2006/main">
               <a:ext uri="{FF2B5EF4-FFF2-40B4-BE49-F238E27FC236}">
-                <a16:creationId xmlns:a16="http://schemas.microsoft.com/office/drawing/2014/main" id="{26258E4A-28B7-4B45-802A-B7A3465B069C}"/>
+                <a16:creationId xmlns:a16="http://schemas.microsoft.com/office/drawing/2014/main" id="{03DB775D-6432-4E5F-B009-35AEBFB6C099}"/>
               </a:ext>
             </a:extLst>
           </p:cNvPr>
@@ -16664,7 +16664,7 @@
           <p:cNvPr id="45" name="">
             <a:extLst xmlns:a="http://schemas.openxmlformats.org/drawingml/2006/main">
               <a:ext uri="{FF2B5EF4-FFF2-40B4-BE49-F238E27FC236}">
-                <a16:creationId xmlns:a16="http://schemas.microsoft.com/office/drawing/2014/main" id="{C3A0D83F-AE84-48C0-AA62-777B57008DC4}"/>
+                <a16:creationId xmlns:a16="http://schemas.microsoft.com/office/drawing/2014/main" id="{C95AB9D8-58FE-46D7-82CD-FD086552DEB1}"/>
               </a:ext>
             </a:extLst>
           </p:cNvPr>
@@ -16701,7 +16701,7 @@
           <p:cNvPr id="46" name="">
             <a:extLst xmlns:a="http://schemas.openxmlformats.org/drawingml/2006/main">
               <a:ext uri="{FF2B5EF4-FFF2-40B4-BE49-F238E27FC236}">
-                <a16:creationId xmlns:a16="http://schemas.microsoft.com/office/drawing/2014/main" id="{5DE9AEC7-B070-462B-9CF4-64578E73E0E3}"/>
+                <a16:creationId xmlns:a16="http://schemas.microsoft.com/office/drawing/2014/main" id="{4408F0ED-BD1A-4EAD-959B-A76FFDDDC828}"/>
               </a:ext>
             </a:extLst>
           </p:cNvPr>
@@ -16765,7 +16765,7 @@
           <p:cNvPr id="47" name="">
             <a:extLst xmlns:a="http://schemas.openxmlformats.org/drawingml/2006/main">
               <a:ext uri="{FF2B5EF4-FFF2-40B4-BE49-F238E27FC236}">
-                <a16:creationId xmlns:a16="http://schemas.microsoft.com/office/drawing/2014/main" id="{C16E591D-ABA5-49B1-921C-F15DFFED9A0A}"/>
+                <a16:creationId xmlns:a16="http://schemas.microsoft.com/office/drawing/2014/main" id="{5337DE54-D797-40AE-9E13-349444E23341}"/>
               </a:ext>
             </a:extLst>
           </p:cNvPr>
@@ -16800,7 +16800,7 @@
           <p:cNvPr id="48" name="">
             <a:extLst xmlns:a="http://schemas.openxmlformats.org/drawingml/2006/main">
               <a:ext uri="{FF2B5EF4-FFF2-40B4-BE49-F238E27FC236}">
-                <a16:creationId xmlns:a16="http://schemas.microsoft.com/office/drawing/2014/main" id="{5D2DB7AD-F8D7-4BCA-A1B0-75A45DE3A24D}"/>
+                <a16:creationId xmlns:a16="http://schemas.microsoft.com/office/drawing/2014/main" id="{E0B2CC73-1145-4F90-BA7C-31A80B28C5F3}"/>
               </a:ext>
             </a:extLst>
           </p:cNvPr>
@@ -16864,7 +16864,7 @@
           <p:cNvPr id="49" name="">
             <a:extLst xmlns:a="http://schemas.openxmlformats.org/drawingml/2006/main">
               <a:ext uri="{FF2B5EF4-FFF2-40B4-BE49-F238E27FC236}">
-                <a16:creationId xmlns:a16="http://schemas.microsoft.com/office/drawing/2014/main" id="{A84CC34A-2CAB-462C-94D0-E0412680679C}"/>
+                <a16:creationId xmlns:a16="http://schemas.microsoft.com/office/drawing/2014/main" id="{B69279E6-2CE7-44A6-9939-E6678C37A840}"/>
               </a:ext>
             </a:extLst>
           </p:cNvPr>
@@ -16928,7 +16928,7 @@
           <p:cNvPr id="50" name="">
             <a:extLst xmlns:a="http://schemas.openxmlformats.org/drawingml/2006/main">
               <a:ext uri="{FF2B5EF4-FFF2-40B4-BE49-F238E27FC236}">
-                <a16:creationId xmlns:a16="http://schemas.microsoft.com/office/drawing/2014/main" id="{7A3C1055-4382-4A12-9745-E27311B4ECD4}"/>
+                <a16:creationId xmlns:a16="http://schemas.microsoft.com/office/drawing/2014/main" id="{BA62F486-EE72-47C4-AFCE-F6D68B306BBC}"/>
               </a:ext>
             </a:extLst>
           </p:cNvPr>
@@ -16992,7 +16992,7 @@
           <p:cNvPr id="51" name="">
             <a:extLst xmlns:a="http://schemas.openxmlformats.org/drawingml/2006/main">
               <a:ext uri="{FF2B5EF4-FFF2-40B4-BE49-F238E27FC236}">
-                <a16:creationId xmlns:a16="http://schemas.microsoft.com/office/drawing/2014/main" id="{3E95884C-9788-4265-B927-6422FB818992}"/>
+                <a16:creationId xmlns:a16="http://schemas.microsoft.com/office/drawing/2014/main" id="{A7D6ACF6-A8F9-4DFE-884C-4AD6D7705AFB}"/>
               </a:ext>
             </a:extLst>
           </p:cNvPr>
@@ -17027,7 +17027,7 @@
           <p:cNvPr id="52" name="">
             <a:extLst xmlns:a="http://schemas.openxmlformats.org/drawingml/2006/main">
               <a:ext uri="{FF2B5EF4-FFF2-40B4-BE49-F238E27FC236}">
-                <a16:creationId xmlns:a16="http://schemas.microsoft.com/office/drawing/2014/main" id="{CCFD177C-EE1F-4045-B997-E5783257BC00}"/>
+                <a16:creationId xmlns:a16="http://schemas.microsoft.com/office/drawing/2014/main" id="{7EE281A8-BCAC-4A42-BDB0-561EC39CD6BD}"/>
               </a:ext>
             </a:extLst>
           </p:cNvPr>
@@ -17091,7 +17091,7 @@
           <p:cNvPr id="53" name="">
             <a:extLst xmlns:a="http://schemas.openxmlformats.org/drawingml/2006/main">
               <a:ext uri="{FF2B5EF4-FFF2-40B4-BE49-F238E27FC236}">
-                <a16:creationId xmlns:a16="http://schemas.microsoft.com/office/drawing/2014/main" id="{827563B1-9EFF-4C0D-A7CC-DE0B57F774F3}"/>
+                <a16:creationId xmlns:a16="http://schemas.microsoft.com/office/drawing/2014/main" id="{8EC14BC3-6246-40BD-A1DE-8FF84F628A37}"/>
               </a:ext>
             </a:extLst>
           </p:cNvPr>
@@ -17155,7 +17155,7 @@
           <p:cNvPr id="54" name="">
             <a:extLst xmlns:a="http://schemas.openxmlformats.org/drawingml/2006/main">
               <a:ext uri="{FF2B5EF4-FFF2-40B4-BE49-F238E27FC236}">
-                <a16:creationId xmlns:a16="http://schemas.microsoft.com/office/drawing/2014/main" id="{02EA29E1-BD98-49B0-907F-F0FAE4B37F23}"/>
+                <a16:creationId xmlns:a16="http://schemas.microsoft.com/office/drawing/2014/main" id="{2EC82DCA-46AE-4F26-9C44-7DD5DD02B011}"/>
               </a:ext>
             </a:extLst>
           </p:cNvPr>
@@ -17219,7 +17219,7 @@
           <p:cNvPr id="55" name="">
             <a:extLst xmlns:a="http://schemas.openxmlformats.org/drawingml/2006/main">
               <a:ext uri="{FF2B5EF4-FFF2-40B4-BE49-F238E27FC236}">
-                <a16:creationId xmlns:a16="http://schemas.microsoft.com/office/drawing/2014/main" id="{C058D2C9-2549-4D9E-940A-B1E82BC2A465}"/>
+                <a16:creationId xmlns:a16="http://schemas.microsoft.com/office/drawing/2014/main" id="{C39D73F6-2920-4183-8D2C-A078EB7DBDB8}"/>
               </a:ext>
             </a:extLst>
           </p:cNvPr>
@@ -17616,7 +17616,7 @@
           <p:nvPr/>
         </p:nvPicPr>
         <p:blipFill>
-          <a:blip xmlns:r="http://schemas.openxmlformats.org/officeDocument/2006/relationships" xmlns:a="http://schemas.openxmlformats.org/drawingml/2006/main" r:embed="Ra700b3245e00403e"/>
+          <a:blip xmlns:r="http://schemas.openxmlformats.org/officeDocument/2006/relationships" xmlns:a="http://schemas.openxmlformats.org/drawingml/2006/main" r:embed="R6b16ad06ef5f418e"/>
           <a:stretch xmlns:a="http://schemas.openxmlformats.org/drawingml/2006/main"/>
         </p:blipFill>
         <p:spPr>
@@ -17634,7 +17634,7 @@
           <p:cNvPr id="15" name="timing-pill">
             <a:extLst xmlns:a="http://schemas.openxmlformats.org/drawingml/2006/main">
               <a:ext uri="{FF2B5EF4-FFF2-40B4-BE49-F238E27FC236}">
-                <a16:creationId xmlns:a16="http://schemas.microsoft.com/office/drawing/2014/main" id="{3A888CDE-4883-4896-B768-15C590CF3A43}"/>
+                <a16:creationId xmlns:a16="http://schemas.microsoft.com/office/drawing/2014/main" id="{3302C7FC-775C-4445-AC9F-CE3AD50C2C4C}"/>
               </a:ext>
             </a:extLst>
           </p:cNvPr>
@@ -17669,7 +17669,7 @@
           <p:cNvPr id="16" name="timing-label">
             <a:extLst xmlns:a="http://schemas.openxmlformats.org/drawingml/2006/main">
               <a:ext uri="{FF2B5EF4-FFF2-40B4-BE49-F238E27FC236}">
-                <a16:creationId xmlns:a16="http://schemas.microsoft.com/office/drawing/2014/main" id="{F9E5D2C6-9F7F-45D1-A2D2-A13014B1CC47}"/>
+                <a16:creationId xmlns:a16="http://schemas.microsoft.com/office/drawing/2014/main" id="{11C70E33-38DE-41A7-B1BE-119729E448D8}"/>
               </a:ext>
             </a:extLst>
           </p:cNvPr>
@@ -17733,7 +17733,7 @@
           <p:cNvPr id="17" name="claim">
             <a:extLst xmlns:a="http://schemas.openxmlformats.org/drawingml/2006/main">
               <a:ext uri="{FF2B5EF4-FFF2-40B4-BE49-F238E27FC236}">
-                <a16:creationId xmlns:a16="http://schemas.microsoft.com/office/drawing/2014/main" id="{95DF078E-5567-4177-AA5C-3A163AC75D4C}"/>
+                <a16:creationId xmlns:a16="http://schemas.microsoft.com/office/drawing/2014/main" id="{237A9046-8028-413B-99B2-7F74F238588E}"/>
               </a:ext>
             </a:extLst>
           </p:cNvPr>
@@ -17797,7 +17797,7 @@
           <p:cNvPr id="18" name="">
             <a:extLst xmlns:a="http://schemas.openxmlformats.org/drawingml/2006/main">
               <a:ext uri="{FF2B5EF4-FFF2-40B4-BE49-F238E27FC236}">
-                <a16:creationId xmlns:a16="http://schemas.microsoft.com/office/drawing/2014/main" id="{B84A6398-E8A5-4C73-AC60-98E43E8F1804}"/>
+                <a16:creationId xmlns:a16="http://schemas.microsoft.com/office/drawing/2014/main" id="{03FB0BF1-3526-43C7-B5AA-D36450872D83}"/>
               </a:ext>
             </a:extLst>
           </p:cNvPr>
@@ -17832,7 +17832,7 @@
           <p:cNvPr id="19" name="">
             <a:extLst xmlns:a="http://schemas.openxmlformats.org/drawingml/2006/main">
               <a:ext uri="{FF2B5EF4-FFF2-40B4-BE49-F238E27FC236}">
-                <a16:creationId xmlns:a16="http://schemas.microsoft.com/office/drawing/2014/main" id="{46B5D9FD-AD35-4724-8E77-6C2B4AB9821C}"/>
+                <a16:creationId xmlns:a16="http://schemas.microsoft.com/office/drawing/2014/main" id="{56DB0651-A74B-4024-910E-DE443BDEFF5C}"/>
               </a:ext>
             </a:extLst>
           </p:cNvPr>
@@ -17896,7 +17896,7 @@
           <p:cNvPr id="20" name="">
             <a:extLst xmlns:a="http://schemas.openxmlformats.org/drawingml/2006/main">
               <a:ext uri="{FF2B5EF4-FFF2-40B4-BE49-F238E27FC236}">
-                <a16:creationId xmlns:a16="http://schemas.microsoft.com/office/drawing/2014/main" id="{5949D1FA-68A9-44B6-A348-BB7FD4C51FDF}"/>
+                <a16:creationId xmlns:a16="http://schemas.microsoft.com/office/drawing/2014/main" id="{030693E8-4707-440C-8538-472FAFAAC04F}"/>
               </a:ext>
             </a:extLst>
           </p:cNvPr>
@@ -17960,7 +17960,7 @@
           <p:cNvPr id="21" name="">
             <a:extLst xmlns:a="http://schemas.openxmlformats.org/drawingml/2006/main">
               <a:ext uri="{FF2B5EF4-FFF2-40B4-BE49-F238E27FC236}">
-                <a16:creationId xmlns:a16="http://schemas.microsoft.com/office/drawing/2014/main" id="{BC55895E-1CCE-4A3D-AF84-029C4CEA62F0}"/>
+                <a16:creationId xmlns:a16="http://schemas.microsoft.com/office/drawing/2014/main" id="{C64CDD2C-2CC3-4DA0-99E0-9AB25D3F544E}"/>
               </a:ext>
             </a:extLst>
           </p:cNvPr>
@@ -18024,7 +18024,7 @@
           <p:cNvPr id="22" name="">
             <a:extLst xmlns:a="http://schemas.openxmlformats.org/drawingml/2006/main">
               <a:ext uri="{FF2B5EF4-FFF2-40B4-BE49-F238E27FC236}">
-                <a16:creationId xmlns:a16="http://schemas.microsoft.com/office/drawing/2014/main" id="{C9CC99BC-B5E7-4000-B9F6-49EE700E599C}"/>
+                <a16:creationId xmlns:a16="http://schemas.microsoft.com/office/drawing/2014/main" id="{BEE25001-2C29-42DA-81AB-84491E42708F}"/>
               </a:ext>
             </a:extLst>
           </p:cNvPr>
@@ -18059,7 +18059,7 @@
           <p:cNvPr id="23" name="">
             <a:extLst xmlns:a="http://schemas.openxmlformats.org/drawingml/2006/main">
               <a:ext uri="{FF2B5EF4-FFF2-40B4-BE49-F238E27FC236}">
-                <a16:creationId xmlns:a16="http://schemas.microsoft.com/office/drawing/2014/main" id="{BEDA946F-FF35-46B7-A39C-B43356D170B7}"/>
+                <a16:creationId xmlns:a16="http://schemas.microsoft.com/office/drawing/2014/main" id="{814B213F-595D-4B47-88EE-44F0E9EF6531}"/>
               </a:ext>
             </a:extLst>
           </p:cNvPr>
@@ -18123,7 +18123,7 @@
           <p:cNvPr id="24" name="">
             <a:extLst xmlns:a="http://schemas.openxmlformats.org/drawingml/2006/main">
               <a:ext uri="{FF2B5EF4-FFF2-40B4-BE49-F238E27FC236}">
-                <a16:creationId xmlns:a16="http://schemas.microsoft.com/office/drawing/2014/main" id="{4327FACE-3268-4F4B-8469-67E42FB9BBA3}"/>
+                <a16:creationId xmlns:a16="http://schemas.microsoft.com/office/drawing/2014/main" id="{922C8582-0F86-4170-86EC-B3732B050CFC}"/>
               </a:ext>
             </a:extLst>
           </p:cNvPr>
@@ -18187,7 +18187,7 @@
           <p:cNvPr id="25" name="">
             <a:extLst xmlns:a="http://schemas.openxmlformats.org/drawingml/2006/main">
               <a:ext uri="{FF2B5EF4-FFF2-40B4-BE49-F238E27FC236}">
-                <a16:creationId xmlns:a16="http://schemas.microsoft.com/office/drawing/2014/main" id="{CF54EEF7-F540-4AFA-A5F2-AA94EC89E244}"/>
+                <a16:creationId xmlns:a16="http://schemas.microsoft.com/office/drawing/2014/main" id="{2C0D992A-7FAD-44B3-9E1B-61892027B2B1}"/>
               </a:ext>
             </a:extLst>
           </p:cNvPr>
@@ -18251,7 +18251,7 @@
           <p:cNvPr id="26" name="">
             <a:extLst xmlns:a="http://schemas.openxmlformats.org/drawingml/2006/main">
               <a:ext uri="{FF2B5EF4-FFF2-40B4-BE49-F238E27FC236}">
-                <a16:creationId xmlns:a16="http://schemas.microsoft.com/office/drawing/2014/main" id="{99819E2B-2B91-43F0-834E-E11A0226F692}"/>
+                <a16:creationId xmlns:a16="http://schemas.microsoft.com/office/drawing/2014/main" id="{2B0783A2-D603-43EF-B84F-8B3CCC4388E1}"/>
               </a:ext>
             </a:extLst>
           </p:cNvPr>
@@ -18286,7 +18286,7 @@
           <p:cNvPr id="27" name="">
             <a:extLst xmlns:a="http://schemas.openxmlformats.org/drawingml/2006/main">
               <a:ext uri="{FF2B5EF4-FFF2-40B4-BE49-F238E27FC236}">
-                <a16:creationId xmlns:a16="http://schemas.microsoft.com/office/drawing/2014/main" id="{33E01DC7-4C6D-4D57-99E0-FEFE73AF6F86}"/>
+                <a16:creationId xmlns:a16="http://schemas.microsoft.com/office/drawing/2014/main" id="{EE4CD315-D37A-40CF-82C6-9741669BBB2E}"/>
               </a:ext>
             </a:extLst>
           </p:cNvPr>
@@ -18350,7 +18350,7 @@
           <p:cNvPr id="28" name="">
             <a:extLst xmlns:a="http://schemas.openxmlformats.org/drawingml/2006/main">
               <a:ext uri="{FF2B5EF4-FFF2-40B4-BE49-F238E27FC236}">
-                <a16:creationId xmlns:a16="http://schemas.microsoft.com/office/drawing/2014/main" id="{FDF2590E-4B96-443A-BBF5-FBDAF97EE7A1}"/>
+                <a16:creationId xmlns:a16="http://schemas.microsoft.com/office/drawing/2014/main" id="{89DC5675-EB57-4AF5-BA02-89534A45BAB2}"/>
               </a:ext>
             </a:extLst>
           </p:cNvPr>
@@ -18414,7 +18414,7 @@
           <p:cNvPr id="29" name="">
             <a:extLst xmlns:a="http://schemas.openxmlformats.org/drawingml/2006/main">
               <a:ext uri="{FF2B5EF4-FFF2-40B4-BE49-F238E27FC236}">
-                <a16:creationId xmlns:a16="http://schemas.microsoft.com/office/drawing/2014/main" id="{7F19DD3D-7483-48E5-ADF2-478B8386AB6F}"/>
+                <a16:creationId xmlns:a16="http://schemas.microsoft.com/office/drawing/2014/main" id="{0AB699C8-9EDD-4C15-A1E1-2FB3A7142804}"/>
               </a:ext>
             </a:extLst>
           </p:cNvPr>
@@ -18478,7 +18478,7 @@
           <p:cNvPr id="30" name="">
             <a:extLst xmlns:a="http://schemas.openxmlformats.org/drawingml/2006/main">
               <a:ext uri="{FF2B5EF4-FFF2-40B4-BE49-F238E27FC236}">
-                <a16:creationId xmlns:a16="http://schemas.microsoft.com/office/drawing/2014/main" id="{6421DC52-0741-42BB-B1D1-DAD86D21B7C5}"/>
+                <a16:creationId xmlns:a16="http://schemas.microsoft.com/office/drawing/2014/main" id="{ECADCFA7-495C-4856-B7E8-11932A43B9D5}"/>
               </a:ext>
             </a:extLst>
           </p:cNvPr>
@@ -18513,7 +18513,7 @@
           <p:cNvPr id="31" name="">
             <a:extLst xmlns:a="http://schemas.openxmlformats.org/drawingml/2006/main">
               <a:ext uri="{FF2B5EF4-FFF2-40B4-BE49-F238E27FC236}">
-                <a16:creationId xmlns:a16="http://schemas.microsoft.com/office/drawing/2014/main" id="{30CA667D-DA12-4E1C-9FB0-6FE113CBC40B}"/>
+                <a16:creationId xmlns:a16="http://schemas.microsoft.com/office/drawing/2014/main" id="{93C6EC43-4FE8-4F0E-A6FA-2E0342998E5E}"/>
               </a:ext>
             </a:extLst>
           </p:cNvPr>

</xml_diff>

<commit_message>
Remove meta-commentary and fix image/text layering on four slides
Slide 4 (Core idea): delete the four template workflow step shapes
(01 Data / 02 Method / 03 Validation / 04 Impact) before placing the
proxy-gold-paradigm figure — they were sitting under the image as dead
template artifacts.

Slide 5 (Pipeline): remove the method-pipeline.png overlay that was
covering the already-correct text box replacements.

Slide 6 (Regimes): replace "What to say" meta-instruction card with
"Key distinction" — Theorem 1 identified vs. Theorem 2 transported
guarantees stated as slide content, not speaker instructions.

Slide 9 (Finite-sample): remove the "Talk move:" box — speaker
instruction does not belong on the slide face.

Co-Authored-By: Claude Sonnet 4.6 <noreply@anthropic.com>
</commit_message>
<xml_diff>
--- a/presentation/output/transfer-learning-meta-analysis-ichi-2026-talk.pptx
+++ b/presentation/output/transfer-learning-meta-analysis-ichi-2026-talk.pptx
@@ -2,24 +2,24 @@
 <file path=ppt/presentation.xml><?xml version="1.0" encoding="utf-8"?>
 <p:presentation xmlns:p="http://schemas.openxmlformats.org/presentationml/2006/main">
   <p:sldMasterIdLst>
-    <p:sldMasterId xmlns:r="http://schemas.openxmlformats.org/officeDocument/2006/relationships" id="2147483648" r:id="R5e4868bed4954b21"/>
+    <p:sldMasterId xmlns:r="http://schemas.openxmlformats.org/officeDocument/2006/relationships" id="2147483648" r:id="Rdedf7b3b4b694130"/>
   </p:sldMasterIdLst>
   <p:notesMasterIdLst>
-    <p:notesMasterId xmlns:r="http://schemas.openxmlformats.org/officeDocument/2006/relationships" r:id="R7bfcf21c2128479f"/>
+    <p:notesMasterId xmlns:r="http://schemas.openxmlformats.org/officeDocument/2006/relationships" r:id="Rbd28eb2ab07a470d"/>
   </p:notesMasterIdLst>
   <p:sldIdLst>
-    <p:sldId xmlns:r="http://schemas.openxmlformats.org/officeDocument/2006/relationships" id="256" r:id="Rfdb910b9143f4de1"/>
-    <p:sldId xmlns:r="http://schemas.openxmlformats.org/officeDocument/2006/relationships" id="257" r:id="R630ac54669834cc2"/>
-    <p:sldId xmlns:r="http://schemas.openxmlformats.org/officeDocument/2006/relationships" id="258" r:id="R1f06c5cbcf9d41ce"/>
-    <p:sldId xmlns:r="http://schemas.openxmlformats.org/officeDocument/2006/relationships" id="259" r:id="R1ee05e4b13c94e2b"/>
-    <p:sldId xmlns:r="http://schemas.openxmlformats.org/officeDocument/2006/relationships" id="260" r:id="Rc5de09a761304c5b"/>
-    <p:sldId xmlns:r="http://schemas.openxmlformats.org/officeDocument/2006/relationships" id="261" r:id="Rf2c98393b6124e42"/>
-    <p:sldId xmlns:r="http://schemas.openxmlformats.org/officeDocument/2006/relationships" id="262" r:id="R3b0595253c434445"/>
-    <p:sldId xmlns:r="http://schemas.openxmlformats.org/officeDocument/2006/relationships" id="263" r:id="Raddf8334b70b4751"/>
-    <p:sldId xmlns:r="http://schemas.openxmlformats.org/officeDocument/2006/relationships" id="264" r:id="Re3adbc9bb2974e4e"/>
-    <p:sldId xmlns:r="http://schemas.openxmlformats.org/officeDocument/2006/relationships" id="265" r:id="R107aecf8b017436d"/>
-    <p:sldId xmlns:r="http://schemas.openxmlformats.org/officeDocument/2006/relationships" id="266" r:id="Rb4c3a53be8bd455a"/>
-    <p:sldId xmlns:r="http://schemas.openxmlformats.org/officeDocument/2006/relationships" id="267" r:id="R99ac41ae16d9421b"/>
+    <p:sldId xmlns:r="http://schemas.openxmlformats.org/officeDocument/2006/relationships" id="256" r:id="Rc7399a77d5f54c9e"/>
+    <p:sldId xmlns:r="http://schemas.openxmlformats.org/officeDocument/2006/relationships" id="257" r:id="R6cfd87034dd340a1"/>
+    <p:sldId xmlns:r="http://schemas.openxmlformats.org/officeDocument/2006/relationships" id="258" r:id="R0171fcffd7f84ad8"/>
+    <p:sldId xmlns:r="http://schemas.openxmlformats.org/officeDocument/2006/relationships" id="259" r:id="R9a19508e7ed547b1"/>
+    <p:sldId xmlns:r="http://schemas.openxmlformats.org/officeDocument/2006/relationships" id="260" r:id="R21c92d2e1c864e41"/>
+    <p:sldId xmlns:r="http://schemas.openxmlformats.org/officeDocument/2006/relationships" id="261" r:id="R46862657e26c4135"/>
+    <p:sldId xmlns:r="http://schemas.openxmlformats.org/officeDocument/2006/relationships" id="262" r:id="Refd1007ec28f46bd"/>
+    <p:sldId xmlns:r="http://schemas.openxmlformats.org/officeDocument/2006/relationships" id="263" r:id="R6e5d4814e61e46b2"/>
+    <p:sldId xmlns:r="http://schemas.openxmlformats.org/officeDocument/2006/relationships" id="264" r:id="R907e88d81a6f479d"/>
+    <p:sldId xmlns:r="http://schemas.openxmlformats.org/officeDocument/2006/relationships" id="265" r:id="Rb4a91797cc154c5f"/>
+    <p:sldId xmlns:r="http://schemas.openxmlformats.org/officeDocument/2006/relationships" id="266" r:id="Rce93b71c51124156"/>
+    <p:sldId xmlns:r="http://schemas.openxmlformats.org/officeDocument/2006/relationships" id="267" r:id="Rb471bf84972e4039"/>
   </p:sldIdLst>
   <p:sldSz cx="12192000" cy="6858000"/>
   <p:notesSz cx="6858000" cy="9144000"/>
@@ -1577,7 +1577,7 @@
   </p:cSld>
   <p:clrMap bg1="lt1" tx1="dk1" bg2="lt2" tx2="dk2" accent1="accent1" accent2="accent2" accent3="accent3" accent4="accent4" accent5="accent5" accent6="accent6" hlink="hlink" folHlink="folHlink"/>
   <p:sldLayoutIdLst>
-    <p:sldLayoutId xmlns:r="http://schemas.openxmlformats.org/officeDocument/2006/relationships" id="2147483649" r:id="Ref8733c4b760468b"/>
+    <p:sldLayoutId xmlns:r="http://schemas.openxmlformats.org/officeDocument/2006/relationships" id="2147483649" r:id="R74e643db15a144cb"/>
   </p:sldLayoutIdLst>
   <p:txStyles>
     <p:titleStyle>
@@ -1967,7 +1967,7 @@
           <p:nvPr/>
         </p:nvPicPr>
         <p:blipFill>
-          <a:blip xmlns:r="http://schemas.openxmlformats.org/officeDocument/2006/relationships" xmlns:a="http://schemas.openxmlformats.org/drawingml/2006/main" r:embed="Red742a7c317b4ea2"/>
+          <a:blip xmlns:r="http://schemas.openxmlformats.org/officeDocument/2006/relationships" xmlns:a="http://schemas.openxmlformats.org/drawingml/2006/main" r:embed="Ra367b23515194a78"/>
           <a:stretch xmlns:a="http://schemas.openxmlformats.org/drawingml/2006/main"/>
         </p:blipFill>
         <p:spPr>
@@ -2502,7 +2502,7 @@
           <p:cNvPr id="19" name="timing-pill">
             <a:extLst xmlns:a="http://schemas.openxmlformats.org/drawingml/2006/main">
               <a:ext uri="{FF2B5EF4-FFF2-40B4-BE49-F238E27FC236}">
-                <a16:creationId xmlns:a16="http://schemas.microsoft.com/office/drawing/2014/main" id="{BADA5551-6DAA-4A8C-8041-42A565D22FDE}"/>
+                <a16:creationId xmlns:a16="http://schemas.microsoft.com/office/drawing/2014/main" id="{F163A1E7-086F-4ED5-839B-149423E90674}"/>
               </a:ext>
             </a:extLst>
           </p:cNvPr>
@@ -2537,7 +2537,7 @@
           <p:cNvPr id="20" name="timing-label">
             <a:extLst xmlns:a="http://schemas.openxmlformats.org/drawingml/2006/main">
               <a:ext uri="{FF2B5EF4-FFF2-40B4-BE49-F238E27FC236}">
-                <a16:creationId xmlns:a16="http://schemas.microsoft.com/office/drawing/2014/main" id="{83C3FF14-CE86-4CCE-AFE8-27EA83B19B4C}"/>
+                <a16:creationId xmlns:a16="http://schemas.microsoft.com/office/drawing/2014/main" id="{67791CBC-C2F5-4BBF-A864-0FD56B819326}"/>
               </a:ext>
             </a:extLst>
           </p:cNvPr>
@@ -2934,7 +2934,7 @@
           <p:nvPr/>
         </p:nvPicPr>
         <p:blipFill>
-          <a:blip xmlns:r="http://schemas.openxmlformats.org/officeDocument/2006/relationships" xmlns:a="http://schemas.openxmlformats.org/drawingml/2006/main" r:embed="Rc4101388e36a42e3"/>
+          <a:blip xmlns:r="http://schemas.openxmlformats.org/officeDocument/2006/relationships" xmlns:a="http://schemas.openxmlformats.org/drawingml/2006/main" r:embed="Rf3b430010ec241b8"/>
           <a:stretch xmlns:a="http://schemas.openxmlformats.org/drawingml/2006/main"/>
         </p:blipFill>
         <p:spPr>
@@ -2952,7 +2952,7 @@
           <p:cNvPr id="15" name="timing-pill">
             <a:extLst xmlns:a="http://schemas.openxmlformats.org/drawingml/2006/main">
               <a:ext uri="{FF2B5EF4-FFF2-40B4-BE49-F238E27FC236}">
-                <a16:creationId xmlns:a16="http://schemas.microsoft.com/office/drawing/2014/main" id="{F18AADC6-7799-47DA-90FF-7F9C25A41B30}"/>
+                <a16:creationId xmlns:a16="http://schemas.microsoft.com/office/drawing/2014/main" id="{96FA885B-BBA2-451F-A020-7F4A5E1DED1A}"/>
               </a:ext>
             </a:extLst>
           </p:cNvPr>
@@ -2987,7 +2987,7 @@
           <p:cNvPr id="16" name="timing-label">
             <a:extLst xmlns:a="http://schemas.openxmlformats.org/drawingml/2006/main">
               <a:ext uri="{FF2B5EF4-FFF2-40B4-BE49-F238E27FC236}">
-                <a16:creationId xmlns:a16="http://schemas.microsoft.com/office/drawing/2014/main" id="{B2FEC0A7-1573-4038-9076-3F74CF1D46A3}"/>
+                <a16:creationId xmlns:a16="http://schemas.microsoft.com/office/drawing/2014/main" id="{D18F5293-BC36-4471-AE1E-E93BE4B1E16F}"/>
               </a:ext>
             </a:extLst>
           </p:cNvPr>
@@ -3051,7 +3051,7 @@
           <p:cNvPr id="17" name="claim">
             <a:extLst xmlns:a="http://schemas.openxmlformats.org/drawingml/2006/main">
               <a:ext uri="{FF2B5EF4-FFF2-40B4-BE49-F238E27FC236}">
-                <a16:creationId xmlns:a16="http://schemas.microsoft.com/office/drawing/2014/main" id="{945CE8E9-99DC-4BC6-8B71-78F5D3330B38}"/>
+                <a16:creationId xmlns:a16="http://schemas.microsoft.com/office/drawing/2014/main" id="{5BF476DD-8FFB-4F15-8210-1B118E282992}"/>
               </a:ext>
             </a:extLst>
           </p:cNvPr>
@@ -3115,7 +3115,7 @@
           <p:cNvPr id="18" name="">
             <a:extLst xmlns:a="http://schemas.openxmlformats.org/drawingml/2006/main">
               <a:ext uri="{FF2B5EF4-FFF2-40B4-BE49-F238E27FC236}">
-                <a16:creationId xmlns:a16="http://schemas.microsoft.com/office/drawing/2014/main" id="{FE6418FC-2386-4026-A0A5-1DCF2435FF00}"/>
+                <a16:creationId xmlns:a16="http://schemas.microsoft.com/office/drawing/2014/main" id="{E4E0189B-C4AC-46AE-9676-E93B89A7DE6E}"/>
               </a:ext>
             </a:extLst>
           </p:cNvPr>
@@ -3148,7 +3148,7 @@
           <p:cNvPr id="19" name="">
             <a:extLst xmlns:a="http://schemas.openxmlformats.org/drawingml/2006/main">
               <a:ext uri="{FF2B5EF4-FFF2-40B4-BE49-F238E27FC236}">
-                <a16:creationId xmlns:a16="http://schemas.microsoft.com/office/drawing/2014/main" id="{3DEEA398-7556-4867-8E93-DD84B8122A9A}"/>
+                <a16:creationId xmlns:a16="http://schemas.microsoft.com/office/drawing/2014/main" id="{651DC934-3175-4D00-A989-922A94C40E53}"/>
               </a:ext>
             </a:extLst>
           </p:cNvPr>
@@ -3212,7 +3212,7 @@
           <p:cNvPr id="20" name="">
             <a:extLst xmlns:a="http://schemas.openxmlformats.org/drawingml/2006/main">
               <a:ext uri="{FF2B5EF4-FFF2-40B4-BE49-F238E27FC236}">
-                <a16:creationId xmlns:a16="http://schemas.microsoft.com/office/drawing/2014/main" id="{848CD7FA-FCC0-40F2-8853-E4FD1A5A5C23}"/>
+                <a16:creationId xmlns:a16="http://schemas.microsoft.com/office/drawing/2014/main" id="{8BA1E6A5-A766-48A7-839E-8123E780906E}"/>
               </a:ext>
             </a:extLst>
           </p:cNvPr>
@@ -3247,7 +3247,7 @@
           <p:cNvPr id="21" name="">
             <a:extLst xmlns:a="http://schemas.openxmlformats.org/drawingml/2006/main">
               <a:ext uri="{FF2B5EF4-FFF2-40B4-BE49-F238E27FC236}">
-                <a16:creationId xmlns:a16="http://schemas.microsoft.com/office/drawing/2014/main" id="{B0E5C633-3FFF-485B-AFED-949EDBD38B7A}"/>
+                <a16:creationId xmlns:a16="http://schemas.microsoft.com/office/drawing/2014/main" id="{55025DEB-3017-4761-873C-0FC28559C087}"/>
               </a:ext>
             </a:extLst>
           </p:cNvPr>
@@ -3282,7 +3282,7 @@
           <p:cNvPr id="22" name="">
             <a:extLst xmlns:a="http://schemas.openxmlformats.org/drawingml/2006/main">
               <a:ext uri="{FF2B5EF4-FFF2-40B4-BE49-F238E27FC236}">
-                <a16:creationId xmlns:a16="http://schemas.microsoft.com/office/drawing/2014/main" id="{3399F874-585C-4DDD-BCFA-D3322F32E216}"/>
+                <a16:creationId xmlns:a16="http://schemas.microsoft.com/office/drawing/2014/main" id="{A3BBEE20-37D9-4DC8-BB4D-E655AD9393AB}"/>
               </a:ext>
             </a:extLst>
           </p:cNvPr>
@@ -3346,7 +3346,7 @@
           <p:cNvPr id="23" name="">
             <a:extLst xmlns:a="http://schemas.openxmlformats.org/drawingml/2006/main">
               <a:ext uri="{FF2B5EF4-FFF2-40B4-BE49-F238E27FC236}">
-                <a16:creationId xmlns:a16="http://schemas.microsoft.com/office/drawing/2014/main" id="{A0AC928F-F9B4-4731-B3D6-103218BD539F}"/>
+                <a16:creationId xmlns:a16="http://schemas.microsoft.com/office/drawing/2014/main" id="{A0FD3FB7-9866-4564-A325-7EE6AD473ECA}"/>
               </a:ext>
             </a:extLst>
           </p:cNvPr>
@@ -3381,7 +3381,7 @@
           <p:cNvPr id="24" name="">
             <a:extLst xmlns:a="http://schemas.openxmlformats.org/drawingml/2006/main">
               <a:ext uri="{FF2B5EF4-FFF2-40B4-BE49-F238E27FC236}">
-                <a16:creationId xmlns:a16="http://schemas.microsoft.com/office/drawing/2014/main" id="{5B0101D7-8B92-4E07-8878-C03E945441FA}"/>
+                <a16:creationId xmlns:a16="http://schemas.microsoft.com/office/drawing/2014/main" id="{3D8FD636-4F2C-459E-A6FB-DAE89296425E}"/>
               </a:ext>
             </a:extLst>
           </p:cNvPr>
@@ -3416,7 +3416,7 @@
           <p:cNvPr id="25" name="">
             <a:extLst xmlns:a="http://schemas.openxmlformats.org/drawingml/2006/main">
               <a:ext uri="{FF2B5EF4-FFF2-40B4-BE49-F238E27FC236}">
-                <a16:creationId xmlns:a16="http://schemas.microsoft.com/office/drawing/2014/main" id="{62F8FFC3-EC35-467F-BF44-90A1B87A4631}"/>
+                <a16:creationId xmlns:a16="http://schemas.microsoft.com/office/drawing/2014/main" id="{9972DBF9-E73A-49EE-9802-105386EC1EB2}"/>
               </a:ext>
             </a:extLst>
           </p:cNvPr>
@@ -3480,7 +3480,7 @@
           <p:cNvPr id="26" name="">
             <a:extLst xmlns:a="http://schemas.openxmlformats.org/drawingml/2006/main">
               <a:ext uri="{FF2B5EF4-FFF2-40B4-BE49-F238E27FC236}">
-                <a16:creationId xmlns:a16="http://schemas.microsoft.com/office/drawing/2014/main" id="{FA5CF181-61EA-496C-B4B5-3F3DD00CAD0E}"/>
+                <a16:creationId xmlns:a16="http://schemas.microsoft.com/office/drawing/2014/main" id="{FAA97BFA-B053-4071-AD6A-71744BFE6537}"/>
               </a:ext>
             </a:extLst>
           </p:cNvPr>
@@ -3515,7 +3515,7 @@
           <p:cNvPr id="27" name="">
             <a:extLst xmlns:a="http://schemas.openxmlformats.org/drawingml/2006/main">
               <a:ext uri="{FF2B5EF4-FFF2-40B4-BE49-F238E27FC236}">
-                <a16:creationId xmlns:a16="http://schemas.microsoft.com/office/drawing/2014/main" id="{E345FFEB-AC7F-4E84-B87B-20F213D93045}"/>
+                <a16:creationId xmlns:a16="http://schemas.microsoft.com/office/drawing/2014/main" id="{1815E1D9-723E-4CE9-86E8-CEEF3A18AA9A}"/>
               </a:ext>
             </a:extLst>
           </p:cNvPr>
@@ -3550,7 +3550,7 @@
           <p:cNvPr id="28" name="">
             <a:extLst xmlns:a="http://schemas.openxmlformats.org/drawingml/2006/main">
               <a:ext uri="{FF2B5EF4-FFF2-40B4-BE49-F238E27FC236}">
-                <a16:creationId xmlns:a16="http://schemas.microsoft.com/office/drawing/2014/main" id="{95A1F756-0DEB-4504-B7FA-78D6F7A689D6}"/>
+                <a16:creationId xmlns:a16="http://schemas.microsoft.com/office/drawing/2014/main" id="{DC2F5B64-D7AC-4DAE-A3DB-9919CCDD34CE}"/>
               </a:ext>
             </a:extLst>
           </p:cNvPr>
@@ -3614,7 +3614,7 @@
           <p:cNvPr id="29" name="">
             <a:extLst xmlns:a="http://schemas.openxmlformats.org/drawingml/2006/main">
               <a:ext uri="{FF2B5EF4-FFF2-40B4-BE49-F238E27FC236}">
-                <a16:creationId xmlns:a16="http://schemas.microsoft.com/office/drawing/2014/main" id="{BC804CC9-F1B5-4BFB-88FC-A6CD6F1A10D2}"/>
+                <a16:creationId xmlns:a16="http://schemas.microsoft.com/office/drawing/2014/main" id="{0B17E2E5-8259-4CFA-9037-D13B023D3D8F}"/>
               </a:ext>
             </a:extLst>
           </p:cNvPr>
@@ -3649,7 +3649,7 @@
           <p:cNvPr id="30" name="">
             <a:extLst xmlns:a="http://schemas.openxmlformats.org/drawingml/2006/main">
               <a:ext uri="{FF2B5EF4-FFF2-40B4-BE49-F238E27FC236}">
-                <a16:creationId xmlns:a16="http://schemas.microsoft.com/office/drawing/2014/main" id="{E0EBC6B4-9EFE-4916-A2E6-2E099631ABA3}"/>
+                <a16:creationId xmlns:a16="http://schemas.microsoft.com/office/drawing/2014/main" id="{3A030468-F38A-448B-971B-56FE30DB3489}"/>
               </a:ext>
             </a:extLst>
           </p:cNvPr>
@@ -3684,7 +3684,7 @@
           <p:cNvPr id="31" name="">
             <a:extLst xmlns:a="http://schemas.openxmlformats.org/drawingml/2006/main">
               <a:ext uri="{FF2B5EF4-FFF2-40B4-BE49-F238E27FC236}">
-                <a16:creationId xmlns:a16="http://schemas.microsoft.com/office/drawing/2014/main" id="{EC4B401D-7154-488C-836B-20C49FC955B1}"/>
+                <a16:creationId xmlns:a16="http://schemas.microsoft.com/office/drawing/2014/main" id="{0DB7DBE5-4605-47B9-A64B-45E7FFF4FA00}"/>
               </a:ext>
             </a:extLst>
           </p:cNvPr>
@@ -3748,7 +3748,7 @@
           <p:cNvPr id="32" name="">
             <a:extLst xmlns:a="http://schemas.openxmlformats.org/drawingml/2006/main">
               <a:ext uri="{FF2B5EF4-FFF2-40B4-BE49-F238E27FC236}">
-                <a16:creationId xmlns:a16="http://schemas.microsoft.com/office/drawing/2014/main" id="{C860BCB4-722E-4F37-A33F-C96F3C3B0481}"/>
+                <a16:creationId xmlns:a16="http://schemas.microsoft.com/office/drawing/2014/main" id="{52A312DB-E5EA-4184-A66F-BE38F6369E89}"/>
               </a:ext>
             </a:extLst>
           </p:cNvPr>
@@ -3783,7 +3783,7 @@
           <p:cNvPr id="33" name="">
             <a:extLst xmlns:a="http://schemas.openxmlformats.org/drawingml/2006/main">
               <a:ext uri="{FF2B5EF4-FFF2-40B4-BE49-F238E27FC236}">
-                <a16:creationId xmlns:a16="http://schemas.microsoft.com/office/drawing/2014/main" id="{F7060FA3-F116-456A-B9EA-C2D2E5042FB6}"/>
+                <a16:creationId xmlns:a16="http://schemas.microsoft.com/office/drawing/2014/main" id="{0E4EB2D5-AA30-4FE1-8274-83CDF5D4145B}"/>
               </a:ext>
             </a:extLst>
           </p:cNvPr>
@@ -3847,7 +3847,7 @@
           <p:cNvPr id="34" name="">
             <a:extLst xmlns:a="http://schemas.openxmlformats.org/drawingml/2006/main">
               <a:ext uri="{FF2B5EF4-FFF2-40B4-BE49-F238E27FC236}">
-                <a16:creationId xmlns:a16="http://schemas.microsoft.com/office/drawing/2014/main" id="{2FEFBD70-4720-4A3A-843C-E121BB1A907B}"/>
+                <a16:creationId xmlns:a16="http://schemas.microsoft.com/office/drawing/2014/main" id="{F65B6389-4D92-49F1-86D4-E16170AFC695}"/>
               </a:ext>
             </a:extLst>
           </p:cNvPr>
@@ -3882,7 +3882,7 @@
           <p:cNvPr id="35" name="">
             <a:extLst xmlns:a="http://schemas.openxmlformats.org/drawingml/2006/main">
               <a:ext uri="{FF2B5EF4-FFF2-40B4-BE49-F238E27FC236}">
-                <a16:creationId xmlns:a16="http://schemas.microsoft.com/office/drawing/2014/main" id="{4EE3EED7-1006-410F-B886-0AB5AEC58B44}"/>
+                <a16:creationId xmlns:a16="http://schemas.microsoft.com/office/drawing/2014/main" id="{9F89E220-60E4-4200-B5B6-AD515972D331}"/>
               </a:ext>
             </a:extLst>
           </p:cNvPr>
@@ -3946,7 +3946,7 @@
           <p:cNvPr id="36" name="card">
             <a:extLst xmlns:a="http://schemas.openxmlformats.org/drawingml/2006/main">
               <a:ext uri="{FF2B5EF4-FFF2-40B4-BE49-F238E27FC236}">
-                <a16:creationId xmlns:a16="http://schemas.microsoft.com/office/drawing/2014/main" id="{BC7EF8D6-0BAE-4A2D-BD98-936A6AEA4657}"/>
+                <a16:creationId xmlns:a16="http://schemas.microsoft.com/office/drawing/2014/main" id="{26F4F2CA-1A55-4392-8077-F6DD66E7B713}"/>
               </a:ext>
             </a:extLst>
           </p:cNvPr>
@@ -3981,7 +3981,7 @@
           <p:cNvPr id="37" name="card-accent">
             <a:extLst xmlns:a="http://schemas.openxmlformats.org/drawingml/2006/main">
               <a:ext uri="{FF2B5EF4-FFF2-40B4-BE49-F238E27FC236}">
-                <a16:creationId xmlns:a16="http://schemas.microsoft.com/office/drawing/2014/main" id="{EEABF890-34CA-4A38-8725-AD73DBB018E7}"/>
+                <a16:creationId xmlns:a16="http://schemas.microsoft.com/office/drawing/2014/main" id="{EF06988D-A2CA-47DE-B146-22CBACEFFE47}"/>
               </a:ext>
             </a:extLst>
           </p:cNvPr>
@@ -4016,7 +4016,7 @@
           <p:cNvPr id="38" name="card-eyebrow">
             <a:extLst xmlns:a="http://schemas.openxmlformats.org/drawingml/2006/main">
               <a:ext uri="{FF2B5EF4-FFF2-40B4-BE49-F238E27FC236}">
-                <a16:creationId xmlns:a16="http://schemas.microsoft.com/office/drawing/2014/main" id="{A503F87B-7E4F-4CF7-AE68-12A9C49A40F4}"/>
+                <a16:creationId xmlns:a16="http://schemas.microsoft.com/office/drawing/2014/main" id="{71AF8D06-060A-4E84-9C71-F9FB1294178A}"/>
               </a:ext>
             </a:extLst>
           </p:cNvPr>
@@ -4080,7 +4080,7 @@
           <p:cNvPr id="39" name="card-title">
             <a:extLst xmlns:a="http://schemas.openxmlformats.org/drawingml/2006/main">
               <a:ext uri="{FF2B5EF4-FFF2-40B4-BE49-F238E27FC236}">
-                <a16:creationId xmlns:a16="http://schemas.microsoft.com/office/drawing/2014/main" id="{1A1BD5D2-3FC1-4E07-AC47-FB3290664667}"/>
+                <a16:creationId xmlns:a16="http://schemas.microsoft.com/office/drawing/2014/main" id="{CCC69C6D-CFCA-4B7C-8A45-DFD69E62D954}"/>
               </a:ext>
             </a:extLst>
           </p:cNvPr>
@@ -4144,7 +4144,7 @@
           <p:cNvPr id="40" name="card-body">
             <a:extLst xmlns:a="http://schemas.openxmlformats.org/drawingml/2006/main">
               <a:ext uri="{FF2B5EF4-FFF2-40B4-BE49-F238E27FC236}">
-                <a16:creationId xmlns:a16="http://schemas.microsoft.com/office/drawing/2014/main" id="{78ADE2B4-8FA8-43E0-8E2F-678ED6C13E7D}"/>
+                <a16:creationId xmlns:a16="http://schemas.microsoft.com/office/drawing/2014/main" id="{D416943A-04BF-48DD-A687-2967BFE3A599}"/>
               </a:ext>
             </a:extLst>
           </p:cNvPr>
@@ -4544,7 +4544,7 @@
           <p:nvPr/>
         </p:nvPicPr>
         <p:blipFill>
-          <a:blip xmlns:r="http://schemas.openxmlformats.org/officeDocument/2006/relationships" xmlns:a="http://schemas.openxmlformats.org/drawingml/2006/main" r:embed="R1c4ed82f1ddd4a8d"/>
+          <a:blip xmlns:r="http://schemas.openxmlformats.org/officeDocument/2006/relationships" xmlns:a="http://schemas.openxmlformats.org/drawingml/2006/main" r:embed="R2f1a7ce635184a8e"/>
           <a:stretch xmlns:a="http://schemas.openxmlformats.org/drawingml/2006/main"/>
         </p:blipFill>
         <p:spPr>
@@ -4562,7 +4562,7 @@
           <p:cNvPr id="15" name="timing-pill">
             <a:extLst xmlns:a="http://schemas.openxmlformats.org/drawingml/2006/main">
               <a:ext uri="{FF2B5EF4-FFF2-40B4-BE49-F238E27FC236}">
-                <a16:creationId xmlns:a16="http://schemas.microsoft.com/office/drawing/2014/main" id="{4CC1B8CA-0588-45CB-8E57-FDF3B8CFD35E}"/>
+                <a16:creationId xmlns:a16="http://schemas.microsoft.com/office/drawing/2014/main" id="{72239E22-9519-4E66-AD54-579C58BE8F77}"/>
               </a:ext>
             </a:extLst>
           </p:cNvPr>
@@ -4597,7 +4597,7 @@
           <p:cNvPr id="16" name="timing-label">
             <a:extLst xmlns:a="http://schemas.openxmlformats.org/drawingml/2006/main">
               <a:ext uri="{FF2B5EF4-FFF2-40B4-BE49-F238E27FC236}">
-                <a16:creationId xmlns:a16="http://schemas.microsoft.com/office/drawing/2014/main" id="{9569D192-15F4-4B54-9252-36668B4339FE}"/>
+                <a16:creationId xmlns:a16="http://schemas.microsoft.com/office/drawing/2014/main" id="{56405CF6-3618-400B-9332-E2EC4E8C893F}"/>
               </a:ext>
             </a:extLst>
           </p:cNvPr>
@@ -4661,7 +4661,7 @@
           <p:cNvPr id="17" name="claim">
             <a:extLst xmlns:a="http://schemas.openxmlformats.org/drawingml/2006/main">
               <a:ext uri="{FF2B5EF4-FFF2-40B4-BE49-F238E27FC236}">
-                <a16:creationId xmlns:a16="http://schemas.microsoft.com/office/drawing/2014/main" id="{ABF05B14-5B74-4D98-9AD8-035C01857B98}"/>
+                <a16:creationId xmlns:a16="http://schemas.microsoft.com/office/drawing/2014/main" id="{02AEFF2E-DA93-47B0-9EEF-8F0B73B0FDD6}"/>
               </a:ext>
             </a:extLst>
           </p:cNvPr>
@@ -4725,7 +4725,7 @@
           <p:cNvPr id="18" name="card">
             <a:extLst xmlns:a="http://schemas.openxmlformats.org/drawingml/2006/main">
               <a:ext uri="{FF2B5EF4-FFF2-40B4-BE49-F238E27FC236}">
-                <a16:creationId xmlns:a16="http://schemas.microsoft.com/office/drawing/2014/main" id="{E4CE211C-93A0-47A6-8AB6-C73B4432BA16}"/>
+                <a16:creationId xmlns:a16="http://schemas.microsoft.com/office/drawing/2014/main" id="{951666C0-C803-4CB8-8F6B-C25A2A76AB66}"/>
               </a:ext>
             </a:extLst>
           </p:cNvPr>
@@ -4760,7 +4760,7 @@
           <p:cNvPr id="19" name="card-accent">
             <a:extLst xmlns:a="http://schemas.openxmlformats.org/drawingml/2006/main">
               <a:ext uri="{FF2B5EF4-FFF2-40B4-BE49-F238E27FC236}">
-                <a16:creationId xmlns:a16="http://schemas.microsoft.com/office/drawing/2014/main" id="{2CB73592-5784-4BAF-B0AD-54AD3E7D9F52}"/>
+                <a16:creationId xmlns:a16="http://schemas.microsoft.com/office/drawing/2014/main" id="{7066B8F8-4159-494E-9A9D-23AB331D1710}"/>
               </a:ext>
             </a:extLst>
           </p:cNvPr>
@@ -4795,7 +4795,7 @@
           <p:cNvPr id="20" name="card-eyebrow">
             <a:extLst xmlns:a="http://schemas.openxmlformats.org/drawingml/2006/main">
               <a:ext uri="{FF2B5EF4-FFF2-40B4-BE49-F238E27FC236}">
-                <a16:creationId xmlns:a16="http://schemas.microsoft.com/office/drawing/2014/main" id="{A0599302-C95F-4977-9107-AD80AD8C0B0A}"/>
+                <a16:creationId xmlns:a16="http://schemas.microsoft.com/office/drawing/2014/main" id="{C8143E0E-B8E0-49E1-BE5F-D078591E9F3E}"/>
               </a:ext>
             </a:extLst>
           </p:cNvPr>
@@ -4859,7 +4859,7 @@
           <p:cNvPr id="21" name="card-title">
             <a:extLst xmlns:a="http://schemas.openxmlformats.org/drawingml/2006/main">
               <a:ext uri="{FF2B5EF4-FFF2-40B4-BE49-F238E27FC236}">
-                <a16:creationId xmlns:a16="http://schemas.microsoft.com/office/drawing/2014/main" id="{7CB1E8A3-4966-4F33-8AC0-9E8C9B466597}"/>
+                <a16:creationId xmlns:a16="http://schemas.microsoft.com/office/drawing/2014/main" id="{C3089C4E-E7F2-47E8-83F8-E45331BA901A}"/>
               </a:ext>
             </a:extLst>
           </p:cNvPr>
@@ -4923,7 +4923,7 @@
           <p:cNvPr id="22" name="card-body">
             <a:extLst xmlns:a="http://schemas.openxmlformats.org/drawingml/2006/main">
               <a:ext uri="{FF2B5EF4-FFF2-40B4-BE49-F238E27FC236}">
-                <a16:creationId xmlns:a16="http://schemas.microsoft.com/office/drawing/2014/main" id="{7EC039B5-EF6E-45C2-A4FD-547A26B4BC43}"/>
+                <a16:creationId xmlns:a16="http://schemas.microsoft.com/office/drawing/2014/main" id="{4F2EC8B7-8FDE-4B74-97DD-B58B0D2846F6}"/>
               </a:ext>
             </a:extLst>
           </p:cNvPr>
@@ -4987,7 +4987,7 @@
           <p:cNvPr id="23" name="card">
             <a:extLst xmlns:a="http://schemas.openxmlformats.org/drawingml/2006/main">
               <a:ext uri="{FF2B5EF4-FFF2-40B4-BE49-F238E27FC236}">
-                <a16:creationId xmlns:a16="http://schemas.microsoft.com/office/drawing/2014/main" id="{0C1AFB85-9183-40DA-A767-662E5E0F581D}"/>
+                <a16:creationId xmlns:a16="http://schemas.microsoft.com/office/drawing/2014/main" id="{914842CB-6B57-410B-A5DB-726238E53957}"/>
               </a:ext>
             </a:extLst>
           </p:cNvPr>
@@ -5022,7 +5022,7 @@
           <p:cNvPr id="24" name="card-accent">
             <a:extLst xmlns:a="http://schemas.openxmlformats.org/drawingml/2006/main">
               <a:ext uri="{FF2B5EF4-FFF2-40B4-BE49-F238E27FC236}">
-                <a16:creationId xmlns:a16="http://schemas.microsoft.com/office/drawing/2014/main" id="{FCDD1CA3-E505-4982-8A39-745D56D46CE8}"/>
+                <a16:creationId xmlns:a16="http://schemas.microsoft.com/office/drawing/2014/main" id="{6CBF574A-EC0E-4971-A8AD-AA312FF1DF91}"/>
               </a:ext>
             </a:extLst>
           </p:cNvPr>
@@ -5057,7 +5057,7 @@
           <p:cNvPr id="25" name="card-eyebrow">
             <a:extLst xmlns:a="http://schemas.openxmlformats.org/drawingml/2006/main">
               <a:ext uri="{FF2B5EF4-FFF2-40B4-BE49-F238E27FC236}">
-                <a16:creationId xmlns:a16="http://schemas.microsoft.com/office/drawing/2014/main" id="{BC04411F-DCCA-4CA1-A179-A1FE9BB8737F}"/>
+                <a16:creationId xmlns:a16="http://schemas.microsoft.com/office/drawing/2014/main" id="{7C6D334E-5871-4741-A3D3-E1E2D91654B9}"/>
               </a:ext>
             </a:extLst>
           </p:cNvPr>
@@ -5121,7 +5121,7 @@
           <p:cNvPr id="26" name="card-title">
             <a:extLst xmlns:a="http://schemas.openxmlformats.org/drawingml/2006/main">
               <a:ext uri="{FF2B5EF4-FFF2-40B4-BE49-F238E27FC236}">
-                <a16:creationId xmlns:a16="http://schemas.microsoft.com/office/drawing/2014/main" id="{884D932C-6A8A-4615-BF0B-44DDC7C9153B}"/>
+                <a16:creationId xmlns:a16="http://schemas.microsoft.com/office/drawing/2014/main" id="{5C293CAD-68F2-494B-A0A5-43737BC9D503}"/>
               </a:ext>
             </a:extLst>
           </p:cNvPr>
@@ -5185,7 +5185,7 @@
           <p:cNvPr id="27" name="card-body">
             <a:extLst xmlns:a="http://schemas.openxmlformats.org/drawingml/2006/main">
               <a:ext uri="{FF2B5EF4-FFF2-40B4-BE49-F238E27FC236}">
-                <a16:creationId xmlns:a16="http://schemas.microsoft.com/office/drawing/2014/main" id="{16E58FE9-BCB9-4EC7-A6BB-E27CF0634467}"/>
+                <a16:creationId xmlns:a16="http://schemas.microsoft.com/office/drawing/2014/main" id="{DCA4B2F2-2513-45D3-A9F6-DE1738658A22}"/>
               </a:ext>
             </a:extLst>
           </p:cNvPr>
@@ -5380,7 +5380,7 @@
           <p:nvPr/>
         </p:nvPicPr>
         <p:blipFill>
-          <a:blip xmlns:r="http://schemas.openxmlformats.org/officeDocument/2006/relationships" xmlns:a="http://schemas.openxmlformats.org/drawingml/2006/main" r:embed="R09dcc1356abd4d25"/>
+          <a:blip xmlns:r="http://schemas.openxmlformats.org/officeDocument/2006/relationships" xmlns:a="http://schemas.openxmlformats.org/drawingml/2006/main" r:embed="R5cb09d560c1b4f7e"/>
           <a:srcRect xmlns:a="http://schemas.openxmlformats.org/drawingml/2006/main" l="0" t="15385" r="0" b="15385"/>
           <a:stretch xmlns:a="http://schemas.openxmlformats.org/drawingml/2006/main">
             <a:fillRect l="0" t="0" r="0" b="0"/>
@@ -5666,7 +5666,7 @@
           <p:nvPr/>
         </p:nvPicPr>
         <p:blipFill>
-          <a:blip xmlns:r="http://schemas.openxmlformats.org/officeDocument/2006/relationships" xmlns:a="http://schemas.openxmlformats.org/drawingml/2006/main" r:embed="R979c82ec1c224ba4"/>
+          <a:blip xmlns:r="http://schemas.openxmlformats.org/officeDocument/2006/relationships" xmlns:a="http://schemas.openxmlformats.org/drawingml/2006/main" r:embed="R7ad97b7b3a4043de"/>
           <a:stretch xmlns:a="http://schemas.openxmlformats.org/drawingml/2006/main"/>
         </p:blipFill>
         <p:spPr>
@@ -5684,7 +5684,7 @@
           <p:cNvPr id="11" name="">
             <a:extLst xmlns:a="http://schemas.openxmlformats.org/drawingml/2006/main">
               <a:ext uri="{FF2B5EF4-FFF2-40B4-BE49-F238E27FC236}">
-                <a16:creationId xmlns:a16="http://schemas.microsoft.com/office/drawing/2014/main" id="{D689364D-D4BB-4822-9F56-38910628E66F}"/>
+                <a16:creationId xmlns:a16="http://schemas.microsoft.com/office/drawing/2014/main" id="{5A4B864C-EE11-411E-B6F2-729B65CDEE19}"/>
               </a:ext>
             </a:extLst>
           </p:cNvPr>
@@ -5794,7 +5794,7 @@
           <p:cNvPr id="12" name="timing-pill">
             <a:extLst xmlns:a="http://schemas.openxmlformats.org/drawingml/2006/main">
               <a:ext uri="{FF2B5EF4-FFF2-40B4-BE49-F238E27FC236}">
-                <a16:creationId xmlns:a16="http://schemas.microsoft.com/office/drawing/2014/main" id="{2073ABEA-4750-46E8-92FF-38793D21A399}"/>
+                <a16:creationId xmlns:a16="http://schemas.microsoft.com/office/drawing/2014/main" id="{39946BCA-5A82-4014-8FF9-726B90D172DD}"/>
               </a:ext>
             </a:extLst>
           </p:cNvPr>
@@ -5829,7 +5829,7 @@
           <p:cNvPr id="13" name="timing-label">
             <a:extLst xmlns:a="http://schemas.openxmlformats.org/drawingml/2006/main">
               <a:ext uri="{FF2B5EF4-FFF2-40B4-BE49-F238E27FC236}">
-                <a16:creationId xmlns:a16="http://schemas.microsoft.com/office/drawing/2014/main" id="{8383D9D1-2638-408B-8B5A-CC32011AF51C}"/>
+                <a16:creationId xmlns:a16="http://schemas.microsoft.com/office/drawing/2014/main" id="{3F0AE9CB-14D5-46A4-9FD7-B682FB79F158}"/>
               </a:ext>
             </a:extLst>
           </p:cNvPr>
@@ -6229,7 +6229,7 @@
           <p:nvPr/>
         </p:nvPicPr>
         <p:blipFill>
-          <a:blip xmlns:r="http://schemas.openxmlformats.org/officeDocument/2006/relationships" xmlns:a="http://schemas.openxmlformats.org/drawingml/2006/main" r:embed="R573bbd2558cc4d48"/>
+          <a:blip xmlns:r="http://schemas.openxmlformats.org/officeDocument/2006/relationships" xmlns:a="http://schemas.openxmlformats.org/drawingml/2006/main" r:embed="R033eefa2d84443bb"/>
           <a:stretch xmlns:a="http://schemas.openxmlformats.org/drawingml/2006/main"/>
         </p:blipFill>
         <p:spPr>
@@ -6247,7 +6247,7 @@
           <p:cNvPr id="15" name="timing-pill">
             <a:extLst xmlns:a="http://schemas.openxmlformats.org/drawingml/2006/main">
               <a:ext uri="{FF2B5EF4-FFF2-40B4-BE49-F238E27FC236}">
-                <a16:creationId xmlns:a16="http://schemas.microsoft.com/office/drawing/2014/main" id="{D008B094-50DC-499E-A33F-3F41CC1D8346}"/>
+                <a16:creationId xmlns:a16="http://schemas.microsoft.com/office/drawing/2014/main" id="{D9FBEB2F-9AE5-415E-A8C9-0D26C37FF9BF}"/>
               </a:ext>
             </a:extLst>
           </p:cNvPr>
@@ -6282,7 +6282,7 @@
           <p:cNvPr id="16" name="timing-label">
             <a:extLst xmlns:a="http://schemas.openxmlformats.org/drawingml/2006/main">
               <a:ext uri="{FF2B5EF4-FFF2-40B4-BE49-F238E27FC236}">
-                <a16:creationId xmlns:a16="http://schemas.microsoft.com/office/drawing/2014/main" id="{FDD6375A-C6BB-4645-B73E-195A6BF74BC6}"/>
+                <a16:creationId xmlns:a16="http://schemas.microsoft.com/office/drawing/2014/main" id="{86A163CE-A80F-4149-997D-5FCA57C857FA}"/>
               </a:ext>
             </a:extLst>
           </p:cNvPr>
@@ -6346,7 +6346,7 @@
           <p:cNvPr id="17" name="claim">
             <a:extLst xmlns:a="http://schemas.openxmlformats.org/drawingml/2006/main">
               <a:ext uri="{FF2B5EF4-FFF2-40B4-BE49-F238E27FC236}">
-                <a16:creationId xmlns:a16="http://schemas.microsoft.com/office/drawing/2014/main" id="{D38267DC-1909-40D8-874B-6B6B55BB31B0}"/>
+                <a16:creationId xmlns:a16="http://schemas.microsoft.com/office/drawing/2014/main" id="{DB817318-3A12-451B-BB45-31E329E7C251}"/>
               </a:ext>
             </a:extLst>
           </p:cNvPr>
@@ -6410,7 +6410,7 @@
           <p:cNvPr id="18" name="card">
             <a:extLst xmlns:a="http://schemas.openxmlformats.org/drawingml/2006/main">
               <a:ext uri="{FF2B5EF4-FFF2-40B4-BE49-F238E27FC236}">
-                <a16:creationId xmlns:a16="http://schemas.microsoft.com/office/drawing/2014/main" id="{43921A30-1C17-4FDD-8BD4-A552D818FFC2}"/>
+                <a16:creationId xmlns:a16="http://schemas.microsoft.com/office/drawing/2014/main" id="{780E4133-2483-4AFD-B059-C0AF237005B3}"/>
               </a:ext>
             </a:extLst>
           </p:cNvPr>
@@ -6445,7 +6445,7 @@
           <p:cNvPr id="19" name="card-accent">
             <a:extLst xmlns:a="http://schemas.openxmlformats.org/drawingml/2006/main">
               <a:ext uri="{FF2B5EF4-FFF2-40B4-BE49-F238E27FC236}">
-                <a16:creationId xmlns:a16="http://schemas.microsoft.com/office/drawing/2014/main" id="{FB4F6511-57F7-415A-B495-7967D31FAF16}"/>
+                <a16:creationId xmlns:a16="http://schemas.microsoft.com/office/drawing/2014/main" id="{85D5C83B-A84E-48C8-84BE-302AF99699AD}"/>
               </a:ext>
             </a:extLst>
           </p:cNvPr>
@@ -6480,7 +6480,7 @@
           <p:cNvPr id="20" name="card-eyebrow">
             <a:extLst xmlns:a="http://schemas.openxmlformats.org/drawingml/2006/main">
               <a:ext uri="{FF2B5EF4-FFF2-40B4-BE49-F238E27FC236}">
-                <a16:creationId xmlns:a16="http://schemas.microsoft.com/office/drawing/2014/main" id="{17B354AA-B590-4156-A797-C95A7A9E31EA}"/>
+                <a16:creationId xmlns:a16="http://schemas.microsoft.com/office/drawing/2014/main" id="{63FCB38A-390A-41B9-AD40-1F0022013F95}"/>
               </a:ext>
             </a:extLst>
           </p:cNvPr>
@@ -6544,7 +6544,7 @@
           <p:cNvPr id="21" name="card-title">
             <a:extLst xmlns:a="http://schemas.openxmlformats.org/drawingml/2006/main">
               <a:ext uri="{FF2B5EF4-FFF2-40B4-BE49-F238E27FC236}">
-                <a16:creationId xmlns:a16="http://schemas.microsoft.com/office/drawing/2014/main" id="{605D89B2-ECC7-4B38-9913-C9F0E1496028}"/>
+                <a16:creationId xmlns:a16="http://schemas.microsoft.com/office/drawing/2014/main" id="{2BBA0F21-FA59-49B2-A6A4-093E76B08871}"/>
               </a:ext>
             </a:extLst>
           </p:cNvPr>
@@ -6608,7 +6608,7 @@
           <p:cNvPr id="22" name="card-body">
             <a:extLst xmlns:a="http://schemas.openxmlformats.org/drawingml/2006/main">
               <a:ext uri="{FF2B5EF4-FFF2-40B4-BE49-F238E27FC236}">
-                <a16:creationId xmlns:a16="http://schemas.microsoft.com/office/drawing/2014/main" id="{64B97A53-135B-402E-9861-880D1AB63BD4}"/>
+                <a16:creationId xmlns:a16="http://schemas.microsoft.com/office/drawing/2014/main" id="{066F41D4-A5BA-4B73-82A3-B588B8993F2B}"/>
               </a:ext>
             </a:extLst>
           </p:cNvPr>
@@ -6672,7 +6672,7 @@
           <p:cNvPr id="23" name="card">
             <a:extLst xmlns:a="http://schemas.openxmlformats.org/drawingml/2006/main">
               <a:ext uri="{FF2B5EF4-FFF2-40B4-BE49-F238E27FC236}">
-                <a16:creationId xmlns:a16="http://schemas.microsoft.com/office/drawing/2014/main" id="{AEB65A5B-E317-4E45-9A99-4A935F1717D2}"/>
+                <a16:creationId xmlns:a16="http://schemas.microsoft.com/office/drawing/2014/main" id="{D4BA8905-86B3-4F64-B3E8-EBF837C27BC6}"/>
               </a:ext>
             </a:extLst>
           </p:cNvPr>
@@ -6707,7 +6707,7 @@
           <p:cNvPr id="24" name="card-accent">
             <a:extLst xmlns:a="http://schemas.openxmlformats.org/drawingml/2006/main">
               <a:ext uri="{FF2B5EF4-FFF2-40B4-BE49-F238E27FC236}">
-                <a16:creationId xmlns:a16="http://schemas.microsoft.com/office/drawing/2014/main" id="{80DA6E1B-5F5B-4C63-9113-1DB084CD6A21}"/>
+                <a16:creationId xmlns:a16="http://schemas.microsoft.com/office/drawing/2014/main" id="{C8D0E65D-71C7-496B-9CD9-2C969A8C1351}"/>
               </a:ext>
             </a:extLst>
           </p:cNvPr>
@@ -6742,7 +6742,7 @@
           <p:cNvPr id="25" name="card-eyebrow">
             <a:extLst xmlns:a="http://schemas.openxmlformats.org/drawingml/2006/main">
               <a:ext uri="{FF2B5EF4-FFF2-40B4-BE49-F238E27FC236}">
-                <a16:creationId xmlns:a16="http://schemas.microsoft.com/office/drawing/2014/main" id="{01B9DD71-3EB9-42B4-A2D6-6E0F5114991C}"/>
+                <a16:creationId xmlns:a16="http://schemas.microsoft.com/office/drawing/2014/main" id="{75BF4393-69D2-410B-B458-78D1410BA274}"/>
               </a:ext>
             </a:extLst>
           </p:cNvPr>
@@ -6806,7 +6806,7 @@
           <p:cNvPr id="26" name="card-title">
             <a:extLst xmlns:a="http://schemas.openxmlformats.org/drawingml/2006/main">
               <a:ext uri="{FF2B5EF4-FFF2-40B4-BE49-F238E27FC236}">
-                <a16:creationId xmlns:a16="http://schemas.microsoft.com/office/drawing/2014/main" id="{D95A7160-E1C9-43B5-9CAF-BC5F7C784227}"/>
+                <a16:creationId xmlns:a16="http://schemas.microsoft.com/office/drawing/2014/main" id="{7BB9FBE3-273D-451C-99DC-D553DBE4B3C5}"/>
               </a:ext>
             </a:extLst>
           </p:cNvPr>
@@ -6870,7 +6870,7 @@
           <p:cNvPr id="27" name="card-body">
             <a:extLst xmlns:a="http://schemas.openxmlformats.org/drawingml/2006/main">
               <a:ext uri="{FF2B5EF4-FFF2-40B4-BE49-F238E27FC236}">
-                <a16:creationId xmlns:a16="http://schemas.microsoft.com/office/drawing/2014/main" id="{FC1083FE-4A08-4BC7-B63A-B3FF9AEC7EB3}"/>
+                <a16:creationId xmlns:a16="http://schemas.microsoft.com/office/drawing/2014/main" id="{66FF416E-DC7B-4C42-B9D1-8D98CD0DD25C}"/>
               </a:ext>
             </a:extLst>
           </p:cNvPr>
@@ -6934,7 +6934,7 @@
           <p:cNvPr id="28" name="card">
             <a:extLst xmlns:a="http://schemas.openxmlformats.org/drawingml/2006/main">
               <a:ext uri="{FF2B5EF4-FFF2-40B4-BE49-F238E27FC236}">
-                <a16:creationId xmlns:a16="http://schemas.microsoft.com/office/drawing/2014/main" id="{C0784F68-4FCD-4953-8F6C-AF493BBCD390}"/>
+                <a16:creationId xmlns:a16="http://schemas.microsoft.com/office/drawing/2014/main" id="{91B6F3C4-DCB5-445A-B51A-27086BC2D2EB}"/>
               </a:ext>
             </a:extLst>
           </p:cNvPr>
@@ -6969,7 +6969,7 @@
           <p:cNvPr id="29" name="card-accent">
             <a:extLst xmlns:a="http://schemas.openxmlformats.org/drawingml/2006/main">
               <a:ext uri="{FF2B5EF4-FFF2-40B4-BE49-F238E27FC236}">
-                <a16:creationId xmlns:a16="http://schemas.microsoft.com/office/drawing/2014/main" id="{171953BC-35AC-45D7-ACA5-67D1FB4F9CDB}"/>
+                <a16:creationId xmlns:a16="http://schemas.microsoft.com/office/drawing/2014/main" id="{B105DCDA-C31B-4BC8-B439-5AC84F9E8F80}"/>
               </a:ext>
             </a:extLst>
           </p:cNvPr>
@@ -7004,7 +7004,7 @@
           <p:cNvPr id="30" name="card-eyebrow">
             <a:extLst xmlns:a="http://schemas.openxmlformats.org/drawingml/2006/main">
               <a:ext uri="{FF2B5EF4-FFF2-40B4-BE49-F238E27FC236}">
-                <a16:creationId xmlns:a16="http://schemas.microsoft.com/office/drawing/2014/main" id="{A4F53833-4D8B-4FCA-A060-12E4A89185D1}"/>
+                <a16:creationId xmlns:a16="http://schemas.microsoft.com/office/drawing/2014/main" id="{9642BD45-6F2C-423C-8306-365765EC4D09}"/>
               </a:ext>
             </a:extLst>
           </p:cNvPr>
@@ -7068,7 +7068,7 @@
           <p:cNvPr id="31" name="card-title">
             <a:extLst xmlns:a="http://schemas.openxmlformats.org/drawingml/2006/main">
               <a:ext uri="{FF2B5EF4-FFF2-40B4-BE49-F238E27FC236}">
-                <a16:creationId xmlns:a16="http://schemas.microsoft.com/office/drawing/2014/main" id="{110E5198-5BE3-461A-A5F6-25C50B072806}"/>
+                <a16:creationId xmlns:a16="http://schemas.microsoft.com/office/drawing/2014/main" id="{10FC973A-7706-4A7C-826B-9A814720AFBA}"/>
               </a:ext>
             </a:extLst>
           </p:cNvPr>
@@ -7132,7 +7132,7 @@
           <p:cNvPr id="32" name="card-body">
             <a:extLst xmlns:a="http://schemas.openxmlformats.org/drawingml/2006/main">
               <a:ext uri="{FF2B5EF4-FFF2-40B4-BE49-F238E27FC236}">
-                <a16:creationId xmlns:a16="http://schemas.microsoft.com/office/drawing/2014/main" id="{2F4BBA55-F87E-4D1D-815C-D85FD4F4351B}"/>
+                <a16:creationId xmlns:a16="http://schemas.microsoft.com/office/drawing/2014/main" id="{52A2A16F-240E-4C77-A140-AA9FD826FFDD}"/>
               </a:ext>
             </a:extLst>
           </p:cNvPr>
@@ -7200,7 +7200,7 @@
           <p:nvPr/>
         </p:nvPicPr>
         <p:blipFill>
-          <a:blip xmlns:r="http://schemas.openxmlformats.org/officeDocument/2006/relationships" xmlns:a="http://schemas.openxmlformats.org/drawingml/2006/main" r:embed="R62f66acf6b534cc7"/>
+          <a:blip xmlns:r="http://schemas.openxmlformats.org/officeDocument/2006/relationships" xmlns:a="http://schemas.openxmlformats.org/drawingml/2006/main" r:embed="Re74dbe2ca322488a"/>
           <a:stretch xmlns:a="http://schemas.openxmlformats.org/drawingml/2006/main"/>
         </p:blipFill>
         <p:spPr>
@@ -7554,7 +7554,7 @@
           <p:nvPr/>
         </p:nvPicPr>
         <p:blipFill>
-          <a:blip xmlns:r="http://schemas.openxmlformats.org/officeDocument/2006/relationships" xmlns:a="http://schemas.openxmlformats.org/drawingml/2006/main" r:embed="Ra8ced316a1904973"/>
+          <a:blip xmlns:r="http://schemas.openxmlformats.org/officeDocument/2006/relationships" xmlns:a="http://schemas.openxmlformats.org/drawingml/2006/main" r:embed="Ra4fed309921445e8"/>
           <a:stretch xmlns:a="http://schemas.openxmlformats.org/drawingml/2006/main"/>
         </p:blipFill>
         <p:spPr>
@@ -7572,7 +7572,7 @@
           <p:cNvPr id="15" name="timing-pill">
             <a:extLst xmlns:a="http://schemas.openxmlformats.org/drawingml/2006/main">
               <a:ext uri="{FF2B5EF4-FFF2-40B4-BE49-F238E27FC236}">
-                <a16:creationId xmlns:a16="http://schemas.microsoft.com/office/drawing/2014/main" id="{E0C3C552-4AE8-4209-A205-D27F6C36C1A6}"/>
+                <a16:creationId xmlns:a16="http://schemas.microsoft.com/office/drawing/2014/main" id="{4867DF08-1FC9-4D27-9169-CD0F3159C044}"/>
               </a:ext>
             </a:extLst>
           </p:cNvPr>
@@ -7607,7 +7607,7 @@
           <p:cNvPr id="16" name="timing-label">
             <a:extLst xmlns:a="http://schemas.openxmlformats.org/drawingml/2006/main">
               <a:ext uri="{FF2B5EF4-FFF2-40B4-BE49-F238E27FC236}">
-                <a16:creationId xmlns:a16="http://schemas.microsoft.com/office/drawing/2014/main" id="{DB28CFFD-7553-422C-8DE1-C1642E78EA4A}"/>
+                <a16:creationId xmlns:a16="http://schemas.microsoft.com/office/drawing/2014/main" id="{6D3592BE-BD84-4B1D-8E5E-1786F15C258D}"/>
               </a:ext>
             </a:extLst>
           </p:cNvPr>
@@ -7671,7 +7671,7 @@
           <p:cNvPr id="17" name="claim">
             <a:extLst xmlns:a="http://schemas.openxmlformats.org/drawingml/2006/main">
               <a:ext uri="{FF2B5EF4-FFF2-40B4-BE49-F238E27FC236}">
-                <a16:creationId xmlns:a16="http://schemas.microsoft.com/office/drawing/2014/main" id="{7217CEBF-5522-4BB3-8A8A-C7EF4D096D24}"/>
+                <a16:creationId xmlns:a16="http://schemas.microsoft.com/office/drawing/2014/main" id="{85D98165-14DD-49D3-B1B2-CB19B5E8A137}"/>
               </a:ext>
             </a:extLst>
           </p:cNvPr>
@@ -7735,7 +7735,7 @@
           <p:cNvPr id="18" name="">
             <a:extLst xmlns:a="http://schemas.openxmlformats.org/drawingml/2006/main">
               <a:ext uri="{FF2B5EF4-FFF2-40B4-BE49-F238E27FC236}">
-                <a16:creationId xmlns:a16="http://schemas.microsoft.com/office/drawing/2014/main" id="{E1860A82-977F-489B-8A09-40DAFE2E7D09}"/>
+                <a16:creationId xmlns:a16="http://schemas.microsoft.com/office/drawing/2014/main" id="{DD73F70D-A942-4B9A-9B6C-9240B31BB109}"/>
               </a:ext>
             </a:extLst>
           </p:cNvPr>
@@ -7770,7 +7770,7 @@
           <p:cNvPr id="19" name="">
             <a:extLst xmlns:a="http://schemas.openxmlformats.org/drawingml/2006/main">
               <a:ext uri="{FF2B5EF4-FFF2-40B4-BE49-F238E27FC236}">
-                <a16:creationId xmlns:a16="http://schemas.microsoft.com/office/drawing/2014/main" id="{F28DBBC7-FFCE-463E-AB64-D0624AD0C16F}"/>
+                <a16:creationId xmlns:a16="http://schemas.microsoft.com/office/drawing/2014/main" id="{744BC67F-AD43-4FDE-B73B-9D8C46FBC20C}"/>
               </a:ext>
             </a:extLst>
           </p:cNvPr>
@@ -7805,7 +7805,7 @@
           <p:cNvPr id="20" name="">
             <a:extLst xmlns:a="http://schemas.openxmlformats.org/drawingml/2006/main">
               <a:ext uri="{FF2B5EF4-FFF2-40B4-BE49-F238E27FC236}">
-                <a16:creationId xmlns:a16="http://schemas.microsoft.com/office/drawing/2014/main" id="{C6875385-857D-4B41-AE54-3B4D6E282F9A}"/>
+                <a16:creationId xmlns:a16="http://schemas.microsoft.com/office/drawing/2014/main" id="{B99F4151-18CA-459C-AE48-E0EC1EBA7128}"/>
               </a:ext>
             </a:extLst>
           </p:cNvPr>
@@ -7869,7 +7869,7 @@
           <p:cNvPr id="21" name="">
             <a:extLst xmlns:a="http://schemas.openxmlformats.org/drawingml/2006/main">
               <a:ext uri="{FF2B5EF4-FFF2-40B4-BE49-F238E27FC236}">
-                <a16:creationId xmlns:a16="http://schemas.microsoft.com/office/drawing/2014/main" id="{E58F7EDD-69F5-401C-A72A-E941A0B98025}"/>
+                <a16:creationId xmlns:a16="http://schemas.microsoft.com/office/drawing/2014/main" id="{3C95FF10-48E6-4174-AC54-1DA7373E34EB}"/>
               </a:ext>
             </a:extLst>
           </p:cNvPr>
@@ -7933,7 +7933,7 @@
           <p:cNvPr id="22" name="">
             <a:extLst xmlns:a="http://schemas.openxmlformats.org/drawingml/2006/main">
               <a:ext uri="{FF2B5EF4-FFF2-40B4-BE49-F238E27FC236}">
-                <a16:creationId xmlns:a16="http://schemas.microsoft.com/office/drawing/2014/main" id="{83BF5EC1-2650-41A2-ACDA-CDC3D9B16B35}"/>
+                <a16:creationId xmlns:a16="http://schemas.microsoft.com/office/drawing/2014/main" id="{1B1B6794-110D-4407-AD7F-66C804EEBF4D}"/>
               </a:ext>
             </a:extLst>
           </p:cNvPr>
@@ -7997,7 +7997,7 @@
           <p:cNvPr id="23" name="">
             <a:extLst xmlns:a="http://schemas.openxmlformats.org/drawingml/2006/main">
               <a:ext uri="{FF2B5EF4-FFF2-40B4-BE49-F238E27FC236}">
-                <a16:creationId xmlns:a16="http://schemas.microsoft.com/office/drawing/2014/main" id="{6E4377C4-75A9-4BEE-A75B-2D87F72AFC92}"/>
+                <a16:creationId xmlns:a16="http://schemas.microsoft.com/office/drawing/2014/main" id="{B072CE9B-4140-464B-864A-7156850EAB41}"/>
               </a:ext>
             </a:extLst>
           </p:cNvPr>
@@ -8061,7 +8061,7 @@
           <p:cNvPr id="24" name="">
             <a:extLst xmlns:a="http://schemas.openxmlformats.org/drawingml/2006/main">
               <a:ext uri="{FF2B5EF4-FFF2-40B4-BE49-F238E27FC236}">
-                <a16:creationId xmlns:a16="http://schemas.microsoft.com/office/drawing/2014/main" id="{84EF9241-4E15-4F33-AE8A-0C799B6624CB}"/>
+                <a16:creationId xmlns:a16="http://schemas.microsoft.com/office/drawing/2014/main" id="{5B60B597-6A12-425C-AA39-8AFCC36C58EB}"/>
               </a:ext>
             </a:extLst>
           </p:cNvPr>
@@ -8125,7 +8125,7 @@
           <p:cNvPr id="25" name="">
             <a:extLst xmlns:a="http://schemas.openxmlformats.org/drawingml/2006/main">
               <a:ext uri="{FF2B5EF4-FFF2-40B4-BE49-F238E27FC236}">
-                <a16:creationId xmlns:a16="http://schemas.microsoft.com/office/drawing/2014/main" id="{9D8609EB-0C28-4F43-9293-82615D408E5B}"/>
+                <a16:creationId xmlns:a16="http://schemas.microsoft.com/office/drawing/2014/main" id="{B6473824-19F1-433F-AF15-44796D631DB6}"/>
               </a:ext>
             </a:extLst>
           </p:cNvPr>
@@ -8189,7 +8189,7 @@
           <p:cNvPr id="26" name="">
             <a:extLst xmlns:a="http://schemas.openxmlformats.org/drawingml/2006/main">
               <a:ext uri="{FF2B5EF4-FFF2-40B4-BE49-F238E27FC236}">
-                <a16:creationId xmlns:a16="http://schemas.microsoft.com/office/drawing/2014/main" id="{EB8CE971-BE36-42F3-B3C3-0336AF7103D6}"/>
+                <a16:creationId xmlns:a16="http://schemas.microsoft.com/office/drawing/2014/main" id="{0C5CBFEC-2D98-496E-A77B-7FDB3E6F5B7F}"/>
               </a:ext>
             </a:extLst>
           </p:cNvPr>
@@ -8224,7 +8224,7 @@
           <p:cNvPr id="27" name="">
             <a:extLst xmlns:a="http://schemas.openxmlformats.org/drawingml/2006/main">
               <a:ext uri="{FF2B5EF4-FFF2-40B4-BE49-F238E27FC236}">
-                <a16:creationId xmlns:a16="http://schemas.microsoft.com/office/drawing/2014/main" id="{FBB53E28-AE77-4E1B-8CCB-CFEA5232FE80}"/>
+                <a16:creationId xmlns:a16="http://schemas.microsoft.com/office/drawing/2014/main" id="{350FD50E-047B-437D-BBAF-BAA500F0F3C5}"/>
               </a:ext>
             </a:extLst>
           </p:cNvPr>
@@ -8288,7 +8288,7 @@
           <p:cNvPr id="28" name="">
             <a:extLst xmlns:a="http://schemas.openxmlformats.org/drawingml/2006/main">
               <a:ext uri="{FF2B5EF4-FFF2-40B4-BE49-F238E27FC236}">
-                <a16:creationId xmlns:a16="http://schemas.microsoft.com/office/drawing/2014/main" id="{641EFA96-1AA7-4861-8B0C-8B7C7A481EEA}"/>
+                <a16:creationId xmlns:a16="http://schemas.microsoft.com/office/drawing/2014/main" id="{9FB74848-028F-4238-B30F-3F1097E2BEEA}"/>
               </a:ext>
             </a:extLst>
           </p:cNvPr>
@@ -8352,7 +8352,7 @@
           <p:cNvPr id="29" name="">
             <a:extLst xmlns:a="http://schemas.openxmlformats.org/drawingml/2006/main">
               <a:ext uri="{FF2B5EF4-FFF2-40B4-BE49-F238E27FC236}">
-                <a16:creationId xmlns:a16="http://schemas.microsoft.com/office/drawing/2014/main" id="{923B72CF-F53A-4435-9436-F002D9E81569}"/>
+                <a16:creationId xmlns:a16="http://schemas.microsoft.com/office/drawing/2014/main" id="{90032E64-9F3B-4C1B-9703-B6A6A67672AA}"/>
               </a:ext>
             </a:extLst>
           </p:cNvPr>
@@ -8416,7 +8416,7 @@
           <p:cNvPr id="30" name="">
             <a:extLst xmlns:a="http://schemas.openxmlformats.org/drawingml/2006/main">
               <a:ext uri="{FF2B5EF4-FFF2-40B4-BE49-F238E27FC236}">
-                <a16:creationId xmlns:a16="http://schemas.microsoft.com/office/drawing/2014/main" id="{00413E76-EE1A-4672-910A-15C440CCC705}"/>
+                <a16:creationId xmlns:a16="http://schemas.microsoft.com/office/drawing/2014/main" id="{F31CEE87-7E5E-4DDF-90DF-43A404854B50}"/>
               </a:ext>
             </a:extLst>
           </p:cNvPr>
@@ -8480,7 +8480,7 @@
           <p:cNvPr id="31" name="">
             <a:extLst xmlns:a="http://schemas.openxmlformats.org/drawingml/2006/main">
               <a:ext uri="{FF2B5EF4-FFF2-40B4-BE49-F238E27FC236}">
-                <a16:creationId xmlns:a16="http://schemas.microsoft.com/office/drawing/2014/main" id="{903E73DC-EB4C-4705-B7C6-647EE2954D5C}"/>
+                <a16:creationId xmlns:a16="http://schemas.microsoft.com/office/drawing/2014/main" id="{0EC08BF8-53B0-4156-A14A-1C93979984CB}"/>
               </a:ext>
             </a:extLst>
           </p:cNvPr>
@@ -8515,7 +8515,7 @@
           <p:cNvPr id="32" name="">
             <a:extLst xmlns:a="http://schemas.openxmlformats.org/drawingml/2006/main">
               <a:ext uri="{FF2B5EF4-FFF2-40B4-BE49-F238E27FC236}">
-                <a16:creationId xmlns:a16="http://schemas.microsoft.com/office/drawing/2014/main" id="{45D9FC23-EFA7-41FC-9096-31563A0CC55F}"/>
+                <a16:creationId xmlns:a16="http://schemas.microsoft.com/office/drawing/2014/main" id="{6B7AFDF2-230B-4A4F-A2CC-7A18608C9B2B}"/>
               </a:ext>
             </a:extLst>
           </p:cNvPr>
@@ -8579,7 +8579,7 @@
           <p:cNvPr id="33" name="">
             <a:extLst xmlns:a="http://schemas.openxmlformats.org/drawingml/2006/main">
               <a:ext uri="{FF2B5EF4-FFF2-40B4-BE49-F238E27FC236}">
-                <a16:creationId xmlns:a16="http://schemas.microsoft.com/office/drawing/2014/main" id="{ED7F3336-EDD5-428D-A406-13B7802181C3}"/>
+                <a16:creationId xmlns:a16="http://schemas.microsoft.com/office/drawing/2014/main" id="{7D964F32-C487-4301-ADE7-22267DF9430B}"/>
               </a:ext>
             </a:extLst>
           </p:cNvPr>
@@ -8643,7 +8643,7 @@
           <p:cNvPr id="34" name="">
             <a:extLst xmlns:a="http://schemas.openxmlformats.org/drawingml/2006/main">
               <a:ext uri="{FF2B5EF4-FFF2-40B4-BE49-F238E27FC236}">
-                <a16:creationId xmlns:a16="http://schemas.microsoft.com/office/drawing/2014/main" id="{46C70653-6F6F-4A37-8DC9-A6AD051E2805}"/>
+                <a16:creationId xmlns:a16="http://schemas.microsoft.com/office/drawing/2014/main" id="{6501ADEF-5194-421A-B6AC-C1A69489BE41}"/>
               </a:ext>
             </a:extLst>
           </p:cNvPr>
@@ -8707,7 +8707,7 @@
           <p:cNvPr id="35" name="">
             <a:extLst xmlns:a="http://schemas.openxmlformats.org/drawingml/2006/main">
               <a:ext uri="{FF2B5EF4-FFF2-40B4-BE49-F238E27FC236}">
-                <a16:creationId xmlns:a16="http://schemas.microsoft.com/office/drawing/2014/main" id="{BD1E687F-07F2-44D3-9CCC-5B0742877B79}"/>
+                <a16:creationId xmlns:a16="http://schemas.microsoft.com/office/drawing/2014/main" id="{515DA886-2005-4A3B-B9FD-A2EEC187C1CE}"/>
               </a:ext>
             </a:extLst>
           </p:cNvPr>
@@ -8771,7 +8771,7 @@
           <p:cNvPr id="36" name="">
             <a:extLst xmlns:a="http://schemas.openxmlformats.org/drawingml/2006/main">
               <a:ext uri="{FF2B5EF4-FFF2-40B4-BE49-F238E27FC236}">
-                <a16:creationId xmlns:a16="http://schemas.microsoft.com/office/drawing/2014/main" id="{44CD6F42-6D90-4919-ADCD-94D4DB63F397}"/>
+                <a16:creationId xmlns:a16="http://schemas.microsoft.com/office/drawing/2014/main" id="{29C3B191-DC40-4C67-87E7-91FCE463B5D8}"/>
               </a:ext>
             </a:extLst>
           </p:cNvPr>
@@ -8919,7 +8919,7 @@
           <p:nvPr/>
         </p:nvPicPr>
         <p:blipFill>
-          <a:blip xmlns:r="http://schemas.openxmlformats.org/officeDocument/2006/relationships" xmlns:a="http://schemas.openxmlformats.org/drawingml/2006/main" r:embed="R52e006911e2849e1"/>
+          <a:blip xmlns:r="http://schemas.openxmlformats.org/officeDocument/2006/relationships" xmlns:a="http://schemas.openxmlformats.org/drawingml/2006/main" r:embed="R98f08662a2e64235"/>
           <a:stretch xmlns:a="http://schemas.openxmlformats.org/drawingml/2006/main"/>
         </p:blipFill>
         <p:spPr>
@@ -9236,183 +9236,6 @@
       </p:sp>
       <p:sp>
         <p:nvSpPr>
-          <p:cNvPr id="12" name="Rectangle 11">
-            <a:extLst xmlns:a="http://schemas.openxmlformats.org/drawingml/2006/main">
-              <a:ext uri="{FF2B5EF4-FFF2-40B4-BE49-F238E27FC236}">
-                <a16:creationId xmlns:a16="http://schemas.microsoft.com/office/drawing/2014/main" id="{77B21C87-CAC4-4164-8C5C-6F7C3B65E608}"/>
-              </a:ext>
-            </a:extLst>
-          </p:cNvPr>
-          <p:cNvSpPr>
-            <a:spLocks xmlns:a="http://schemas.openxmlformats.org/drawingml/2006/main" noGrp="1"/>
-          </p:cNvSpPr>
-          <p:nvPr/>
-        </p:nvSpPr>
-        <p:spPr>
-          <a:xfrm xmlns:a="http://schemas.openxmlformats.org/drawingml/2006/main">
-            <a:off x="914400" y="2343150"/>
-            <a:ext cx="457200" cy="266700"/>
-          </a:xfrm>
-          <a:prstGeom xmlns:a="http://schemas.openxmlformats.org/drawingml/2006/main" prst="rect">
-            <a:avLst/>
-          </a:prstGeom>
-          <a:solidFill xmlns:a="http://schemas.openxmlformats.org/drawingml/2006/main">
-            <a:srgbClr val="000000">
-              <a:alpha val="0"/>
-            </a:srgbClr>
-          </a:solidFill>
-          <a:ln xmlns:a="http://schemas.openxmlformats.org/drawingml/2006/main" w="0">
-            <a:solidFill>
-              <a:srgbClr val="000000">
-                <a:alpha val="0"/>
-              </a:srgbClr>
-            </a:solidFill>
-            <a:prstDash val="solid"/>
-          </a:ln>
-        </p:spPr>
-        <p:txBody>
-          <a:bodyPr xmlns:a="http://schemas.openxmlformats.org/drawingml/2006/main" lIns="0" tIns="0" rIns="0" bIns="0" anchor="t"/>
-          <a:lstStyle xmlns:a="http://schemas.openxmlformats.org/drawingml/2006/main"/>
-          <a:p xmlns:a="http://schemas.openxmlformats.org/drawingml/2006/main">
-            <a:pPr algn="l">
-              <a:buNone/>
-              <a:defRPr sz="1800" b="1">
-                <a:solidFill>
-                  <a:srgbClr val="7A0019"/>
-                </a:solidFill>
-              </a:defRPr>
-            </a:pPr>
-            <a:r>
-              <a:rPr sz="1800" b="1">
-                <a:solidFill>
-                  <a:srgbClr val="7A0019"/>
-                </a:solidFill>
-              </a:rPr>
-              <a:t>01</a:t>
-            </a:r>
-          </a:p>
-        </p:txBody>
-      </p:sp>
-      <p:sp>
-        <p:nvSpPr>
-          <p:cNvPr id="13" name="Rectangle 12">
-            <a:extLst xmlns:a="http://schemas.openxmlformats.org/drawingml/2006/main">
-              <a:ext uri="{FF2B5EF4-FFF2-40B4-BE49-F238E27FC236}">
-                <a16:creationId xmlns:a16="http://schemas.microsoft.com/office/drawing/2014/main" id="{A0D196A9-B415-46E3-9361-F8B698493E69}"/>
-              </a:ext>
-            </a:extLst>
-          </p:cNvPr>
-          <p:cNvSpPr>
-            <a:spLocks xmlns:a="http://schemas.openxmlformats.org/drawingml/2006/main" noGrp="1"/>
-          </p:cNvSpPr>
-          <p:nvPr/>
-        </p:nvSpPr>
-        <p:spPr>
-          <a:xfrm xmlns:a="http://schemas.openxmlformats.org/drawingml/2006/main">
-            <a:off x="914400" y="2724150"/>
-            <a:ext cx="2133600" cy="285750"/>
-          </a:xfrm>
-          <a:prstGeom xmlns:a="http://schemas.openxmlformats.org/drawingml/2006/main" prst="rect">
-            <a:avLst/>
-          </a:prstGeom>
-          <a:solidFill xmlns:a="http://schemas.openxmlformats.org/drawingml/2006/main">
-            <a:srgbClr val="000000">
-              <a:alpha val="0"/>
-            </a:srgbClr>
-          </a:solidFill>
-          <a:ln xmlns:a="http://schemas.openxmlformats.org/drawingml/2006/main" w="0">
-            <a:solidFill>
-              <a:srgbClr val="000000">
-                <a:alpha val="0"/>
-              </a:srgbClr>
-            </a:solidFill>
-            <a:prstDash val="solid"/>
-          </a:ln>
-        </p:spPr>
-        <p:txBody>
-          <a:bodyPr xmlns:a="http://schemas.openxmlformats.org/drawingml/2006/main" lIns="0" tIns="0" rIns="0" bIns="0" anchor="t"/>
-          <a:lstStyle xmlns:a="http://schemas.openxmlformats.org/drawingml/2006/main"/>
-          <a:p xmlns:a="http://schemas.openxmlformats.org/drawingml/2006/main">
-            <a:pPr algn="l">
-              <a:buNone/>
-              <a:defRPr sz="1800" b="1">
-                <a:solidFill>
-                  <a:srgbClr val="231F20"/>
-                </a:solidFill>
-              </a:defRPr>
-            </a:pPr>
-            <a:r>
-              <a:rPr sz="1800" b="1">
-                <a:solidFill>
-                  <a:srgbClr val="231F20"/>
-                </a:solidFill>
-              </a:rPr>
-              <a:t>Data</a:t>
-            </a:r>
-          </a:p>
-        </p:txBody>
-      </p:sp>
-      <p:sp>
-        <p:nvSpPr>
-          <p:cNvPr id="14" name="Rectangle 13">
-            <a:extLst xmlns:a="http://schemas.openxmlformats.org/drawingml/2006/main">
-              <a:ext uri="{FF2B5EF4-FFF2-40B4-BE49-F238E27FC236}">
-                <a16:creationId xmlns:a16="http://schemas.microsoft.com/office/drawing/2014/main" id="{96539635-A17C-45AA-BA83-E3A89439BE06}"/>
-              </a:ext>
-            </a:extLst>
-          </p:cNvPr>
-          <p:cNvSpPr>
-            <a:spLocks xmlns:a="http://schemas.openxmlformats.org/drawingml/2006/main" noGrp="1"/>
-          </p:cNvSpPr>
-          <p:nvPr/>
-        </p:nvSpPr>
-        <p:spPr>
-          <a:xfrm xmlns:a="http://schemas.openxmlformats.org/drawingml/2006/main">
-            <a:off x="914400" y="3200400"/>
-            <a:ext cx="2133600" cy="1162050"/>
-          </a:xfrm>
-          <a:prstGeom xmlns:a="http://schemas.openxmlformats.org/drawingml/2006/main" prst="rect">
-            <a:avLst/>
-          </a:prstGeom>
-          <a:solidFill xmlns:a="http://schemas.openxmlformats.org/drawingml/2006/main">
-            <a:srgbClr val="000000">
-              <a:alpha val="0"/>
-            </a:srgbClr>
-          </a:solidFill>
-          <a:ln xmlns:a="http://schemas.openxmlformats.org/drawingml/2006/main" w="0">
-            <a:solidFill>
-              <a:srgbClr val="000000">
-                <a:alpha val="0"/>
-              </a:srgbClr>
-            </a:solidFill>
-            <a:prstDash val="solid"/>
-          </a:ln>
-        </p:spPr>
-        <p:txBody>
-          <a:bodyPr xmlns:a="http://schemas.openxmlformats.org/drawingml/2006/main" lIns="0" tIns="0" rIns="0" bIns="0" anchor="t"/>
-          <a:lstStyle xmlns:a="http://schemas.openxmlformats.org/drawingml/2006/main"/>
-          <a:p xmlns:a="http://schemas.openxmlformats.org/drawingml/2006/main">
-            <a:pPr algn="l">
-              <a:buNone/>
-              <a:defRPr sz="1350" b="0">
-                <a:solidFill>
-                  <a:srgbClr val="5E5A56"/>
-                </a:solidFill>
-              </a:defRPr>
-            </a:pPr>
-            <a:r>
-              <a:rPr sz="1350" b="0">
-                <a:solidFill>
-                  <a:srgbClr val="5E5A56"/>
-                </a:solidFill>
-              </a:rPr>
-              <a:t>Describe the cohort, records, devices, or multimodal sources.</a:t>
-            </a:r>
-          </a:p>
-        </p:txBody>
-      </p:sp>
-      <p:sp>
-        <p:nvSpPr>
           <p:cNvPr id="15" name="Right Arrow 14">
             <a:extLst xmlns:a="http://schemas.openxmlformats.org/drawingml/2006/main">
               <a:ext uri="{FF2B5EF4-FFF2-40B4-BE49-F238E27FC236}">
@@ -9533,183 +9356,6 @@
       </p:sp>
       <p:sp>
         <p:nvSpPr>
-          <p:cNvPr id="18" name="Rectangle 17">
-            <a:extLst xmlns:a="http://schemas.openxmlformats.org/drawingml/2006/main">
-              <a:ext uri="{FF2B5EF4-FFF2-40B4-BE49-F238E27FC236}">
-                <a16:creationId xmlns:a16="http://schemas.microsoft.com/office/drawing/2014/main" id="{2605098D-18A7-4AAA-AD1E-F7A3DC5AC116}"/>
-              </a:ext>
-            </a:extLst>
-          </p:cNvPr>
-          <p:cNvSpPr>
-            <a:spLocks xmlns:a="http://schemas.openxmlformats.org/drawingml/2006/main" noGrp="1"/>
-          </p:cNvSpPr>
-          <p:nvPr/>
-        </p:nvSpPr>
-        <p:spPr>
-          <a:xfrm xmlns:a="http://schemas.openxmlformats.org/drawingml/2006/main">
-            <a:off x="3733800" y="2343150"/>
-            <a:ext cx="457200" cy="266700"/>
-          </a:xfrm>
-          <a:prstGeom xmlns:a="http://schemas.openxmlformats.org/drawingml/2006/main" prst="rect">
-            <a:avLst/>
-          </a:prstGeom>
-          <a:solidFill xmlns:a="http://schemas.openxmlformats.org/drawingml/2006/main">
-            <a:srgbClr val="000000">
-              <a:alpha val="0"/>
-            </a:srgbClr>
-          </a:solidFill>
-          <a:ln xmlns:a="http://schemas.openxmlformats.org/drawingml/2006/main" w="0">
-            <a:solidFill>
-              <a:srgbClr val="000000">
-                <a:alpha val="0"/>
-              </a:srgbClr>
-            </a:solidFill>
-            <a:prstDash val="solid"/>
-          </a:ln>
-        </p:spPr>
-        <p:txBody>
-          <a:bodyPr xmlns:a="http://schemas.openxmlformats.org/drawingml/2006/main" lIns="0" tIns="0" rIns="0" bIns="0" anchor="t"/>
-          <a:lstStyle xmlns:a="http://schemas.openxmlformats.org/drawingml/2006/main"/>
-          <a:p xmlns:a="http://schemas.openxmlformats.org/drawingml/2006/main">
-            <a:pPr algn="l">
-              <a:buNone/>
-              <a:defRPr sz="1800" b="1">
-                <a:solidFill>
-                  <a:srgbClr val="7A0019"/>
-                </a:solidFill>
-              </a:defRPr>
-            </a:pPr>
-            <a:r>
-              <a:rPr sz="1800" b="1">
-                <a:solidFill>
-                  <a:srgbClr val="7A0019"/>
-                </a:solidFill>
-              </a:rPr>
-              <a:t>02</a:t>
-            </a:r>
-          </a:p>
-        </p:txBody>
-      </p:sp>
-      <p:sp>
-        <p:nvSpPr>
-          <p:cNvPr id="19" name="Rectangle 18">
-            <a:extLst xmlns:a="http://schemas.openxmlformats.org/drawingml/2006/main">
-              <a:ext uri="{FF2B5EF4-FFF2-40B4-BE49-F238E27FC236}">
-                <a16:creationId xmlns:a16="http://schemas.microsoft.com/office/drawing/2014/main" id="{7FF75E07-E430-4EA6-9D33-781F57013682}"/>
-              </a:ext>
-            </a:extLst>
-          </p:cNvPr>
-          <p:cNvSpPr>
-            <a:spLocks xmlns:a="http://schemas.openxmlformats.org/drawingml/2006/main" noGrp="1"/>
-          </p:cNvSpPr>
-          <p:nvPr/>
-        </p:nvSpPr>
-        <p:spPr>
-          <a:xfrm xmlns:a="http://schemas.openxmlformats.org/drawingml/2006/main">
-            <a:off x="3733800" y="2724150"/>
-            <a:ext cx="2133600" cy="285750"/>
-          </a:xfrm>
-          <a:prstGeom xmlns:a="http://schemas.openxmlformats.org/drawingml/2006/main" prst="rect">
-            <a:avLst/>
-          </a:prstGeom>
-          <a:solidFill xmlns:a="http://schemas.openxmlformats.org/drawingml/2006/main">
-            <a:srgbClr val="000000">
-              <a:alpha val="0"/>
-            </a:srgbClr>
-          </a:solidFill>
-          <a:ln xmlns:a="http://schemas.openxmlformats.org/drawingml/2006/main" w="0">
-            <a:solidFill>
-              <a:srgbClr val="000000">
-                <a:alpha val="0"/>
-              </a:srgbClr>
-            </a:solidFill>
-            <a:prstDash val="solid"/>
-          </a:ln>
-        </p:spPr>
-        <p:txBody>
-          <a:bodyPr xmlns:a="http://schemas.openxmlformats.org/drawingml/2006/main" lIns="0" tIns="0" rIns="0" bIns="0" anchor="t"/>
-          <a:lstStyle xmlns:a="http://schemas.openxmlformats.org/drawingml/2006/main"/>
-          <a:p xmlns:a="http://schemas.openxmlformats.org/drawingml/2006/main">
-            <a:pPr algn="l">
-              <a:buNone/>
-              <a:defRPr sz="1800" b="1">
-                <a:solidFill>
-                  <a:srgbClr val="231F20"/>
-                </a:solidFill>
-              </a:defRPr>
-            </a:pPr>
-            <a:r>
-              <a:rPr sz="1800" b="1">
-                <a:solidFill>
-                  <a:srgbClr val="231F20"/>
-                </a:solidFill>
-              </a:rPr>
-              <a:t>Method</a:t>
-            </a:r>
-          </a:p>
-        </p:txBody>
-      </p:sp>
-      <p:sp>
-        <p:nvSpPr>
-          <p:cNvPr id="20" name="Rectangle 19">
-            <a:extLst xmlns:a="http://schemas.openxmlformats.org/drawingml/2006/main">
-              <a:ext uri="{FF2B5EF4-FFF2-40B4-BE49-F238E27FC236}">
-                <a16:creationId xmlns:a16="http://schemas.microsoft.com/office/drawing/2014/main" id="{4470A79E-9A4F-4BB2-9D59-35D29E011DB2}"/>
-              </a:ext>
-            </a:extLst>
-          </p:cNvPr>
-          <p:cNvSpPr>
-            <a:spLocks xmlns:a="http://schemas.openxmlformats.org/drawingml/2006/main" noGrp="1"/>
-          </p:cNvSpPr>
-          <p:nvPr/>
-        </p:nvSpPr>
-        <p:spPr>
-          <a:xfrm xmlns:a="http://schemas.openxmlformats.org/drawingml/2006/main">
-            <a:off x="3733800" y="3200400"/>
-            <a:ext cx="2133600" cy="1162050"/>
-          </a:xfrm>
-          <a:prstGeom xmlns:a="http://schemas.openxmlformats.org/drawingml/2006/main" prst="rect">
-            <a:avLst/>
-          </a:prstGeom>
-          <a:solidFill xmlns:a="http://schemas.openxmlformats.org/drawingml/2006/main">
-            <a:srgbClr val="000000">
-              <a:alpha val="0"/>
-            </a:srgbClr>
-          </a:solidFill>
-          <a:ln xmlns:a="http://schemas.openxmlformats.org/drawingml/2006/main" w="0">
-            <a:solidFill>
-              <a:srgbClr val="000000">
-                <a:alpha val="0"/>
-              </a:srgbClr>
-            </a:solidFill>
-            <a:prstDash val="solid"/>
-          </a:ln>
-        </p:spPr>
-        <p:txBody>
-          <a:bodyPr xmlns:a="http://schemas.openxmlformats.org/drawingml/2006/main" lIns="0" tIns="0" rIns="0" bIns="0" anchor="t"/>
-          <a:lstStyle xmlns:a="http://schemas.openxmlformats.org/drawingml/2006/main"/>
-          <a:p xmlns:a="http://schemas.openxmlformats.org/drawingml/2006/main">
-            <a:pPr algn="l">
-              <a:buNone/>
-              <a:defRPr sz="1350" b="0">
-                <a:solidFill>
-                  <a:srgbClr val="5E5A56"/>
-                </a:solidFill>
-              </a:defRPr>
-            </a:pPr>
-            <a:r>
-              <a:rPr sz="1350" b="0">
-                <a:solidFill>
-                  <a:srgbClr val="5E5A56"/>
-                </a:solidFill>
-              </a:rPr>
-              <a:t>Summarize modeling, evaluation, or intervention design.</a:t>
-            </a:r>
-          </a:p>
-        </p:txBody>
-      </p:sp>
-      <p:sp>
-        <p:nvSpPr>
           <p:cNvPr id="21" name="Right Arrow 20">
             <a:extLst xmlns:a="http://schemas.openxmlformats.org/drawingml/2006/main">
               <a:ext uri="{FF2B5EF4-FFF2-40B4-BE49-F238E27FC236}">
@@ -9830,183 +9476,6 @@
       </p:sp>
       <p:sp>
         <p:nvSpPr>
-          <p:cNvPr id="24" name="Rectangle 23">
-            <a:extLst xmlns:a="http://schemas.openxmlformats.org/drawingml/2006/main">
-              <a:ext uri="{FF2B5EF4-FFF2-40B4-BE49-F238E27FC236}">
-                <a16:creationId xmlns:a16="http://schemas.microsoft.com/office/drawing/2014/main" id="{79532A85-6EC4-43BF-A133-306479302989}"/>
-              </a:ext>
-            </a:extLst>
-          </p:cNvPr>
-          <p:cNvSpPr>
-            <a:spLocks xmlns:a="http://schemas.openxmlformats.org/drawingml/2006/main" noGrp="1"/>
-          </p:cNvSpPr>
-          <p:nvPr/>
-        </p:nvSpPr>
-        <p:spPr>
-          <a:xfrm xmlns:a="http://schemas.openxmlformats.org/drawingml/2006/main">
-            <a:off x="6553200" y="2343150"/>
-            <a:ext cx="457200" cy="266700"/>
-          </a:xfrm>
-          <a:prstGeom xmlns:a="http://schemas.openxmlformats.org/drawingml/2006/main" prst="rect">
-            <a:avLst/>
-          </a:prstGeom>
-          <a:solidFill xmlns:a="http://schemas.openxmlformats.org/drawingml/2006/main">
-            <a:srgbClr val="000000">
-              <a:alpha val="0"/>
-            </a:srgbClr>
-          </a:solidFill>
-          <a:ln xmlns:a="http://schemas.openxmlformats.org/drawingml/2006/main" w="0">
-            <a:solidFill>
-              <a:srgbClr val="000000">
-                <a:alpha val="0"/>
-              </a:srgbClr>
-            </a:solidFill>
-            <a:prstDash val="solid"/>
-          </a:ln>
-        </p:spPr>
-        <p:txBody>
-          <a:bodyPr xmlns:a="http://schemas.openxmlformats.org/drawingml/2006/main" lIns="0" tIns="0" rIns="0" bIns="0" anchor="t"/>
-          <a:lstStyle xmlns:a="http://schemas.openxmlformats.org/drawingml/2006/main"/>
-          <a:p xmlns:a="http://schemas.openxmlformats.org/drawingml/2006/main">
-            <a:pPr algn="l">
-              <a:buNone/>
-              <a:defRPr sz="1800" b="1">
-                <a:solidFill>
-                  <a:srgbClr val="7A0019"/>
-                </a:solidFill>
-              </a:defRPr>
-            </a:pPr>
-            <a:r>
-              <a:rPr sz="1800" b="1">
-                <a:solidFill>
-                  <a:srgbClr val="7A0019"/>
-                </a:solidFill>
-              </a:rPr>
-              <a:t>03</a:t>
-            </a:r>
-          </a:p>
-        </p:txBody>
-      </p:sp>
-      <p:sp>
-        <p:nvSpPr>
-          <p:cNvPr id="25" name="Rectangle 24">
-            <a:extLst xmlns:a="http://schemas.openxmlformats.org/drawingml/2006/main">
-              <a:ext uri="{FF2B5EF4-FFF2-40B4-BE49-F238E27FC236}">
-                <a16:creationId xmlns:a16="http://schemas.microsoft.com/office/drawing/2014/main" id="{18C8BEEB-80C0-4D60-8AF1-B9D70A6D89F0}"/>
-              </a:ext>
-            </a:extLst>
-          </p:cNvPr>
-          <p:cNvSpPr>
-            <a:spLocks xmlns:a="http://schemas.openxmlformats.org/drawingml/2006/main" noGrp="1"/>
-          </p:cNvSpPr>
-          <p:nvPr/>
-        </p:nvSpPr>
-        <p:spPr>
-          <a:xfrm xmlns:a="http://schemas.openxmlformats.org/drawingml/2006/main">
-            <a:off x="6553200" y="2724150"/>
-            <a:ext cx="2133600" cy="285750"/>
-          </a:xfrm>
-          <a:prstGeom xmlns:a="http://schemas.openxmlformats.org/drawingml/2006/main" prst="rect">
-            <a:avLst/>
-          </a:prstGeom>
-          <a:solidFill xmlns:a="http://schemas.openxmlformats.org/drawingml/2006/main">
-            <a:srgbClr val="000000">
-              <a:alpha val="0"/>
-            </a:srgbClr>
-          </a:solidFill>
-          <a:ln xmlns:a="http://schemas.openxmlformats.org/drawingml/2006/main" w="0">
-            <a:solidFill>
-              <a:srgbClr val="000000">
-                <a:alpha val="0"/>
-              </a:srgbClr>
-            </a:solidFill>
-            <a:prstDash val="solid"/>
-          </a:ln>
-        </p:spPr>
-        <p:txBody>
-          <a:bodyPr xmlns:a="http://schemas.openxmlformats.org/drawingml/2006/main" lIns="0" tIns="0" rIns="0" bIns="0" anchor="t"/>
-          <a:lstStyle xmlns:a="http://schemas.openxmlformats.org/drawingml/2006/main"/>
-          <a:p xmlns:a="http://schemas.openxmlformats.org/drawingml/2006/main">
-            <a:pPr algn="l">
-              <a:buNone/>
-              <a:defRPr sz="1800" b="1">
-                <a:solidFill>
-                  <a:srgbClr val="231F20"/>
-                </a:solidFill>
-              </a:defRPr>
-            </a:pPr>
-            <a:r>
-              <a:rPr sz="1800" b="1">
-                <a:solidFill>
-                  <a:srgbClr val="231F20"/>
-                </a:solidFill>
-              </a:rPr>
-              <a:t>Validation</a:t>
-            </a:r>
-          </a:p>
-        </p:txBody>
-      </p:sp>
-      <p:sp>
-        <p:nvSpPr>
-          <p:cNvPr id="26" name="Rectangle 25">
-            <a:extLst xmlns:a="http://schemas.openxmlformats.org/drawingml/2006/main">
-              <a:ext uri="{FF2B5EF4-FFF2-40B4-BE49-F238E27FC236}">
-                <a16:creationId xmlns:a16="http://schemas.microsoft.com/office/drawing/2014/main" id="{CF859E99-E762-4417-9F81-4D148CB048A0}"/>
-              </a:ext>
-            </a:extLst>
-          </p:cNvPr>
-          <p:cNvSpPr>
-            <a:spLocks xmlns:a="http://schemas.openxmlformats.org/drawingml/2006/main" noGrp="1"/>
-          </p:cNvSpPr>
-          <p:nvPr/>
-        </p:nvSpPr>
-        <p:spPr>
-          <a:xfrm xmlns:a="http://schemas.openxmlformats.org/drawingml/2006/main">
-            <a:off x="6553200" y="3200400"/>
-            <a:ext cx="2133600" cy="1162050"/>
-          </a:xfrm>
-          <a:prstGeom xmlns:a="http://schemas.openxmlformats.org/drawingml/2006/main" prst="rect">
-            <a:avLst/>
-          </a:prstGeom>
-          <a:solidFill xmlns:a="http://schemas.openxmlformats.org/drawingml/2006/main">
-            <a:srgbClr val="000000">
-              <a:alpha val="0"/>
-            </a:srgbClr>
-          </a:solidFill>
-          <a:ln xmlns:a="http://schemas.openxmlformats.org/drawingml/2006/main" w="0">
-            <a:solidFill>
-              <a:srgbClr val="000000">
-                <a:alpha val="0"/>
-              </a:srgbClr>
-            </a:solidFill>
-            <a:prstDash val="solid"/>
-          </a:ln>
-        </p:spPr>
-        <p:txBody>
-          <a:bodyPr xmlns:a="http://schemas.openxmlformats.org/drawingml/2006/main" lIns="0" tIns="0" rIns="0" bIns="0" anchor="t"/>
-          <a:lstStyle xmlns:a="http://schemas.openxmlformats.org/drawingml/2006/main"/>
-          <a:p xmlns:a="http://schemas.openxmlformats.org/drawingml/2006/main">
-            <a:pPr algn="l">
-              <a:buNone/>
-              <a:defRPr sz="1350" b="0">
-                <a:solidFill>
-                  <a:srgbClr val="5E5A56"/>
-                </a:solidFill>
-              </a:defRPr>
-            </a:pPr>
-            <a:r>
-              <a:rPr sz="1350" b="0">
-                <a:solidFill>
-                  <a:srgbClr val="5E5A56"/>
-                </a:solidFill>
-              </a:rPr>
-              <a:t>Explain benchmarks, comparison groups, or review procedures.</a:t>
-            </a:r>
-          </a:p>
-        </p:txBody>
-      </p:sp>
-      <p:sp>
-        <p:nvSpPr>
           <p:cNvPr id="27" name="Right Arrow 26">
             <a:extLst xmlns:a="http://schemas.openxmlformats.org/drawingml/2006/main">
               <a:ext uri="{FF2B5EF4-FFF2-40B4-BE49-F238E27FC236}">
@@ -10127,187 +9596,10 @@
       </p:sp>
       <p:sp>
         <p:nvSpPr>
-          <p:cNvPr id="30" name="Rectangle 29">
-            <a:extLst xmlns:a="http://schemas.openxmlformats.org/drawingml/2006/main">
-              <a:ext uri="{FF2B5EF4-FFF2-40B4-BE49-F238E27FC236}">
-                <a16:creationId xmlns:a16="http://schemas.microsoft.com/office/drawing/2014/main" id="{FD8AC435-DCB9-4AA7-86AA-9DE317601C88}"/>
-              </a:ext>
-            </a:extLst>
-          </p:cNvPr>
-          <p:cNvSpPr>
-            <a:spLocks xmlns:a="http://schemas.openxmlformats.org/drawingml/2006/main" noGrp="1"/>
-          </p:cNvSpPr>
-          <p:nvPr/>
-        </p:nvSpPr>
-        <p:spPr>
-          <a:xfrm xmlns:a="http://schemas.openxmlformats.org/drawingml/2006/main">
-            <a:off x="9372600" y="2343150"/>
-            <a:ext cx="457200" cy="266700"/>
-          </a:xfrm>
-          <a:prstGeom xmlns:a="http://schemas.openxmlformats.org/drawingml/2006/main" prst="rect">
-            <a:avLst/>
-          </a:prstGeom>
-          <a:solidFill xmlns:a="http://schemas.openxmlformats.org/drawingml/2006/main">
-            <a:srgbClr val="000000">
-              <a:alpha val="0"/>
-            </a:srgbClr>
-          </a:solidFill>
-          <a:ln xmlns:a="http://schemas.openxmlformats.org/drawingml/2006/main" w="0">
-            <a:solidFill>
-              <a:srgbClr val="000000">
-                <a:alpha val="0"/>
-              </a:srgbClr>
-            </a:solidFill>
-            <a:prstDash val="solid"/>
-          </a:ln>
-        </p:spPr>
-        <p:txBody>
-          <a:bodyPr xmlns:a="http://schemas.openxmlformats.org/drawingml/2006/main" lIns="0" tIns="0" rIns="0" bIns="0" anchor="t"/>
-          <a:lstStyle xmlns:a="http://schemas.openxmlformats.org/drawingml/2006/main"/>
-          <a:p xmlns:a="http://schemas.openxmlformats.org/drawingml/2006/main">
-            <a:pPr algn="l">
-              <a:buNone/>
-              <a:defRPr sz="1800" b="1">
-                <a:solidFill>
-                  <a:srgbClr val="7A0019"/>
-                </a:solidFill>
-              </a:defRPr>
-            </a:pPr>
-            <a:r>
-              <a:rPr sz="1800" b="1">
-                <a:solidFill>
-                  <a:srgbClr val="7A0019"/>
-                </a:solidFill>
-              </a:rPr>
-              <a:t>04</a:t>
-            </a:r>
-          </a:p>
-        </p:txBody>
-      </p:sp>
-      <p:sp>
-        <p:nvSpPr>
-          <p:cNvPr id="31" name="Rectangle 30">
-            <a:extLst xmlns:a="http://schemas.openxmlformats.org/drawingml/2006/main">
-              <a:ext uri="{FF2B5EF4-FFF2-40B4-BE49-F238E27FC236}">
-                <a16:creationId xmlns:a16="http://schemas.microsoft.com/office/drawing/2014/main" id="{57347287-1C79-4654-AB74-9220487C8D58}"/>
-              </a:ext>
-            </a:extLst>
-          </p:cNvPr>
-          <p:cNvSpPr>
-            <a:spLocks xmlns:a="http://schemas.openxmlformats.org/drawingml/2006/main" noGrp="1"/>
-          </p:cNvSpPr>
-          <p:nvPr/>
-        </p:nvSpPr>
-        <p:spPr>
-          <a:xfrm xmlns:a="http://schemas.openxmlformats.org/drawingml/2006/main">
-            <a:off x="9372600" y="2724150"/>
-            <a:ext cx="2133600" cy="285750"/>
-          </a:xfrm>
-          <a:prstGeom xmlns:a="http://schemas.openxmlformats.org/drawingml/2006/main" prst="rect">
-            <a:avLst/>
-          </a:prstGeom>
-          <a:solidFill xmlns:a="http://schemas.openxmlformats.org/drawingml/2006/main">
-            <a:srgbClr val="000000">
-              <a:alpha val="0"/>
-            </a:srgbClr>
-          </a:solidFill>
-          <a:ln xmlns:a="http://schemas.openxmlformats.org/drawingml/2006/main" w="0">
-            <a:solidFill>
-              <a:srgbClr val="000000">
-                <a:alpha val="0"/>
-              </a:srgbClr>
-            </a:solidFill>
-            <a:prstDash val="solid"/>
-          </a:ln>
-        </p:spPr>
-        <p:txBody>
-          <a:bodyPr xmlns:a="http://schemas.openxmlformats.org/drawingml/2006/main" lIns="0" tIns="0" rIns="0" bIns="0" anchor="t"/>
-          <a:lstStyle xmlns:a="http://schemas.openxmlformats.org/drawingml/2006/main"/>
-          <a:p xmlns:a="http://schemas.openxmlformats.org/drawingml/2006/main">
-            <a:pPr algn="l">
-              <a:buNone/>
-              <a:defRPr sz="1800" b="1">
-                <a:solidFill>
-                  <a:srgbClr val="231F20"/>
-                </a:solidFill>
-              </a:defRPr>
-            </a:pPr>
-            <a:r>
-              <a:rPr sz="1800" b="1">
-                <a:solidFill>
-                  <a:srgbClr val="231F20"/>
-                </a:solidFill>
-              </a:rPr>
-              <a:t>Impact</a:t>
-            </a:r>
-          </a:p>
-        </p:txBody>
-      </p:sp>
-      <p:sp>
-        <p:nvSpPr>
-          <p:cNvPr id="32" name="Rectangle 31">
-            <a:extLst xmlns:a="http://schemas.openxmlformats.org/drawingml/2006/main">
-              <a:ext uri="{FF2B5EF4-FFF2-40B4-BE49-F238E27FC236}">
-                <a16:creationId xmlns:a16="http://schemas.microsoft.com/office/drawing/2014/main" id="{7877CA81-FD6B-4632-8B44-83095EFF9AE5}"/>
-              </a:ext>
-            </a:extLst>
-          </p:cNvPr>
-          <p:cNvSpPr>
-            <a:spLocks xmlns:a="http://schemas.openxmlformats.org/drawingml/2006/main" noGrp="1"/>
-          </p:cNvSpPr>
-          <p:nvPr/>
-        </p:nvSpPr>
-        <p:spPr>
-          <a:xfrm xmlns:a="http://schemas.openxmlformats.org/drawingml/2006/main">
-            <a:off x="9372600" y="3200400"/>
-            <a:ext cx="2133600" cy="1162050"/>
-          </a:xfrm>
-          <a:prstGeom xmlns:a="http://schemas.openxmlformats.org/drawingml/2006/main" prst="rect">
-            <a:avLst/>
-          </a:prstGeom>
-          <a:solidFill xmlns:a="http://schemas.openxmlformats.org/drawingml/2006/main">
-            <a:srgbClr val="000000">
-              <a:alpha val="0"/>
-            </a:srgbClr>
-          </a:solidFill>
-          <a:ln xmlns:a="http://schemas.openxmlformats.org/drawingml/2006/main" w="0">
-            <a:solidFill>
-              <a:srgbClr val="000000">
-                <a:alpha val="0"/>
-              </a:srgbClr>
-            </a:solidFill>
-            <a:prstDash val="solid"/>
-          </a:ln>
-        </p:spPr>
-        <p:txBody>
-          <a:bodyPr xmlns:a="http://schemas.openxmlformats.org/drawingml/2006/main" lIns="0" tIns="0" rIns="0" bIns="0" anchor="t"/>
-          <a:lstStyle xmlns:a="http://schemas.openxmlformats.org/drawingml/2006/main"/>
-          <a:p xmlns:a="http://schemas.openxmlformats.org/drawingml/2006/main">
-            <a:pPr algn="l">
-              <a:buNone/>
-              <a:defRPr sz="1350" b="0">
-                <a:solidFill>
-                  <a:srgbClr val="5E5A56"/>
-                </a:solidFill>
-              </a:defRPr>
-            </a:pPr>
-            <a:r>
-              <a:rPr sz="1350" b="0">
-                <a:solidFill>
-                  <a:srgbClr val="5E5A56"/>
-                </a:solidFill>
-              </a:rPr>
-              <a:t>Connect the workflow to outcomes, deployment, or next steps.</a:t>
-            </a:r>
-          </a:p>
-        </p:txBody>
-      </p:sp>
-      <p:sp>
-        <p:nvSpPr>
           <p:cNvPr id="34" name="timing-pill">
             <a:extLst xmlns:a="http://schemas.openxmlformats.org/drawingml/2006/main">
               <a:ext uri="{FF2B5EF4-FFF2-40B4-BE49-F238E27FC236}">
-                <a16:creationId xmlns:a16="http://schemas.microsoft.com/office/drawing/2014/main" id="{2F93C3C6-37D9-4E25-B7D6-D0AF1A63447D}"/>
+                <a16:creationId xmlns:a16="http://schemas.microsoft.com/office/drawing/2014/main" id="{A0F396DF-24E2-44E8-BDF0-12C29B8D35A9}"/>
               </a:ext>
             </a:extLst>
           </p:cNvPr>
@@ -10342,7 +9634,7 @@
           <p:cNvPr id="35" name="timing-label">
             <a:extLst xmlns:a="http://schemas.openxmlformats.org/drawingml/2006/main">
               <a:ext uri="{FF2B5EF4-FFF2-40B4-BE49-F238E27FC236}">
-                <a16:creationId xmlns:a16="http://schemas.microsoft.com/office/drawing/2014/main" id="{23E8E356-9B86-4D48-AFFB-3B36F1535F67}"/>
+                <a16:creationId xmlns:a16="http://schemas.microsoft.com/office/drawing/2014/main" id="{696887D4-CEE3-49F9-BC8F-A05E03AADCCF}"/>
               </a:ext>
             </a:extLst>
           </p:cNvPr>
@@ -10406,7 +9698,7 @@
           <p:cNvPr id="36" name="claim">
             <a:extLst xmlns:a="http://schemas.openxmlformats.org/drawingml/2006/main">
               <a:ext uri="{FF2B5EF4-FFF2-40B4-BE49-F238E27FC236}">
-                <a16:creationId xmlns:a16="http://schemas.microsoft.com/office/drawing/2014/main" id="{F4966C5C-0B4D-4A9D-959F-6F83FB871015}"/>
+                <a16:creationId xmlns:a16="http://schemas.microsoft.com/office/drawing/2014/main" id="{85488BF4-EB39-4F99-8046-8463BF9FCE40}"/>
               </a:ext>
             </a:extLst>
           </p:cNvPr>
@@ -10474,7 +9766,7 @@
           <p:nvPr/>
         </p:nvPicPr>
         <p:blipFill>
-          <a:blip xmlns:r="http://schemas.openxmlformats.org/officeDocument/2006/relationships" xmlns:a="http://schemas.openxmlformats.org/drawingml/2006/main" r:embed="Rab92e8a062c347ff"/>
+          <a:blip xmlns:r="http://schemas.openxmlformats.org/officeDocument/2006/relationships" xmlns:a="http://schemas.openxmlformats.org/drawingml/2006/main" r:embed="R9621bd709c424ff9"/>
           <a:stretch xmlns:a="http://schemas.openxmlformats.org/drawingml/2006/main"/>
         </p:blipFill>
         <p:spPr>
@@ -10608,7 +9900,7 @@
           <p:nvPr/>
         </p:nvPicPr>
         <p:blipFill>
-          <a:blip xmlns:r="http://schemas.openxmlformats.org/officeDocument/2006/relationships" xmlns:a="http://schemas.openxmlformats.org/drawingml/2006/main" r:embed="R016f62d1876644d7"/>
+          <a:blip xmlns:r="http://schemas.openxmlformats.org/officeDocument/2006/relationships" xmlns:a="http://schemas.openxmlformats.org/drawingml/2006/main" r:embed="Rbbc2e66b0e2e4964"/>
           <a:stretch xmlns:a="http://schemas.openxmlformats.org/drawingml/2006/main"/>
         </p:blipFill>
         <p:spPr>
@@ -11996,7 +11288,7 @@
           <p:cNvPr id="34" name="timing-pill">
             <a:extLst xmlns:a="http://schemas.openxmlformats.org/drawingml/2006/main">
               <a:ext uri="{FF2B5EF4-FFF2-40B4-BE49-F238E27FC236}">
-                <a16:creationId xmlns:a16="http://schemas.microsoft.com/office/drawing/2014/main" id="{22A9F6FB-E6CA-409B-9918-D3191E399035}"/>
+                <a16:creationId xmlns:a16="http://schemas.microsoft.com/office/drawing/2014/main" id="{30FEA41B-5D78-4B60-A51C-21E99C00F35E}"/>
               </a:ext>
             </a:extLst>
           </p:cNvPr>
@@ -12031,7 +11323,7 @@
           <p:cNvPr id="35" name="timing-label">
             <a:extLst xmlns:a="http://schemas.openxmlformats.org/drawingml/2006/main">
               <a:ext uri="{FF2B5EF4-FFF2-40B4-BE49-F238E27FC236}">
-                <a16:creationId xmlns:a16="http://schemas.microsoft.com/office/drawing/2014/main" id="{4F0A0DBD-7CFF-4C28-92C9-5DEA92A2E555}"/>
+                <a16:creationId xmlns:a16="http://schemas.microsoft.com/office/drawing/2014/main" id="{960CFA21-ECE5-4245-A4BA-6762D534618F}"/>
               </a:ext>
             </a:extLst>
           </p:cNvPr>
@@ -12090,28 +11382,6 @@
           </a:p>
         </p:txBody>
       </p:sp>
-      <p:pic>
-        <p:nvPicPr>
-          <p:cNvPr id="36" name=""/>
-          <p:cNvPicPr>
-            <a:picLocks xmlns:a="http://schemas.openxmlformats.org/drawingml/2006/main" noChangeAspect="1"/>
-          </p:cNvPicPr>
-          <p:nvPr/>
-        </p:nvPicPr>
-        <p:blipFill>
-          <a:blip xmlns:r="http://schemas.openxmlformats.org/officeDocument/2006/relationships" xmlns:a="http://schemas.openxmlformats.org/drawingml/2006/main" r:embed="R71068e4e1423462f"/>
-          <a:stretch xmlns:a="http://schemas.openxmlformats.org/drawingml/2006/main"/>
-        </p:blipFill>
-        <p:spPr>
-          <a:xfrm xmlns:a="http://schemas.openxmlformats.org/drawingml/2006/main">
-            <a:off x="685800" y="1927819"/>
-            <a:ext cx="10820400" cy="3573861"/>
-          </a:xfrm>
-          <a:prstGeom xmlns:a="http://schemas.openxmlformats.org/drawingml/2006/main" prst="rect">
-            <a:avLst/>
-          </a:prstGeom>
-        </p:spPr>
-      </p:pic>
     </p:spTree>
     <p:extLst>
       <p:ext uri="{BB962C8B-B14F-4D97-AF65-F5344CB8AC3E}">
@@ -12230,7 +11500,7 @@
           <p:nvPr/>
         </p:nvPicPr>
         <p:blipFill>
-          <a:blip xmlns:r="http://schemas.openxmlformats.org/officeDocument/2006/relationships" xmlns:a="http://schemas.openxmlformats.org/drawingml/2006/main" r:embed="R77e1475930f541e7"/>
+          <a:blip xmlns:r="http://schemas.openxmlformats.org/officeDocument/2006/relationships" xmlns:a="http://schemas.openxmlformats.org/drawingml/2006/main" r:embed="Ra1456efcf52d41b5"/>
           <a:stretch xmlns:a="http://schemas.openxmlformats.org/drawingml/2006/main"/>
         </p:blipFill>
         <p:spPr>
@@ -12999,7 +12269,7 @@
                   <a:srgbClr val="8A0020"/>
                 </a:solidFill>
               </a:rPr>
-              <a:t>What to say</a:t>
+              <a:t>Key distinction</a:t>
             </a:r>
           </a:p>
         </p:txBody>
@@ -13058,7 +12328,7 @@
                   <a:srgbClr val="65605C"/>
                 </a:solidFill>
               </a:rPr>
-              <a:t>The talk should separate what is identified from what is transported; that distinction is the methodological honesty.</a:t>
+              <a:t>Theorem 1 gives √n₀ guarantees on an identified estimand. Theorem 2 decomposes error into estimation + structural transport bias ε_τ. These are not interchangeable — label them separately.</a:t>
             </a:r>
           </a:p>
         </p:txBody>
@@ -13068,7 +12338,7 @@
           <p:cNvPr id="23" name="timing-pill">
             <a:extLst xmlns:a="http://schemas.openxmlformats.org/drawingml/2006/main">
               <a:ext uri="{FF2B5EF4-FFF2-40B4-BE49-F238E27FC236}">
-                <a16:creationId xmlns:a16="http://schemas.microsoft.com/office/drawing/2014/main" id="{B3B8DC18-FAC6-4B32-853A-34D5CA7605E6}"/>
+                <a16:creationId xmlns:a16="http://schemas.microsoft.com/office/drawing/2014/main" id="{A8845C68-F1A8-43B9-AFEC-06C3C8E424E2}"/>
               </a:ext>
             </a:extLst>
           </p:cNvPr>
@@ -13103,7 +12373,7 @@
           <p:cNvPr id="24" name="timing-label">
             <a:extLst xmlns:a="http://schemas.openxmlformats.org/drawingml/2006/main">
               <a:ext uri="{FF2B5EF4-FFF2-40B4-BE49-F238E27FC236}">
-                <a16:creationId xmlns:a16="http://schemas.microsoft.com/office/drawing/2014/main" id="{7FBA74B3-79CD-4B6E-B0C2-6F28E4304943}"/>
+                <a16:creationId xmlns:a16="http://schemas.microsoft.com/office/drawing/2014/main" id="{51FA1AEB-ABA9-48A6-9F5E-12A1F4AA8C9E}"/>
               </a:ext>
             </a:extLst>
           </p:cNvPr>
@@ -13283,7 +12553,7 @@
           <p:nvPr/>
         </p:nvPicPr>
         <p:blipFill>
-          <a:blip xmlns:r="http://schemas.openxmlformats.org/officeDocument/2006/relationships" xmlns:a="http://schemas.openxmlformats.org/drawingml/2006/main" r:embed="Re1e92347ff6e4ba8"/>
+          <a:blip xmlns:r="http://schemas.openxmlformats.org/officeDocument/2006/relationships" xmlns:a="http://schemas.openxmlformats.org/drawingml/2006/main" r:embed="R638b423bd1b54584"/>
           <a:stretch xmlns:a="http://schemas.openxmlformats.org/drawingml/2006/main"/>
         </p:blipFill>
         <p:spPr>
@@ -14671,7 +13941,7 @@
           <p:cNvPr id="34" name="timing-pill">
             <a:extLst xmlns:a="http://schemas.openxmlformats.org/drawingml/2006/main">
               <a:ext uri="{FF2B5EF4-FFF2-40B4-BE49-F238E27FC236}">
-                <a16:creationId xmlns:a16="http://schemas.microsoft.com/office/drawing/2014/main" id="{9883073A-94F6-4976-AB6B-B5332A3090B2}"/>
+                <a16:creationId xmlns:a16="http://schemas.microsoft.com/office/drawing/2014/main" id="{C6418001-78AB-4E19-BDE2-A6B6291B44A5}"/>
               </a:ext>
             </a:extLst>
           </p:cNvPr>
@@ -14706,7 +13976,7 @@
           <p:cNvPr id="35" name="timing-label">
             <a:extLst xmlns:a="http://schemas.openxmlformats.org/drawingml/2006/main">
               <a:ext uri="{FF2B5EF4-FFF2-40B4-BE49-F238E27FC236}">
-                <a16:creationId xmlns:a16="http://schemas.microsoft.com/office/drawing/2014/main" id="{818D5E4B-60BA-4D00-B91E-9B3E48CA8C5A}"/>
+                <a16:creationId xmlns:a16="http://schemas.microsoft.com/office/drawing/2014/main" id="{96EC154C-AFB7-4412-A9F5-8B17C2C97207}"/>
               </a:ext>
             </a:extLst>
           </p:cNvPr>
@@ -15106,7 +14376,7 @@
           <p:nvPr/>
         </p:nvPicPr>
         <p:blipFill>
-          <a:blip xmlns:r="http://schemas.openxmlformats.org/officeDocument/2006/relationships" xmlns:a="http://schemas.openxmlformats.org/drawingml/2006/main" r:embed="R9b3b66f9bc4c4f90"/>
+          <a:blip xmlns:r="http://schemas.openxmlformats.org/officeDocument/2006/relationships" xmlns:a="http://schemas.openxmlformats.org/drawingml/2006/main" r:embed="Rf5abe12c6aa94332"/>
           <a:stretch xmlns:a="http://schemas.openxmlformats.org/drawingml/2006/main"/>
         </p:blipFill>
         <p:spPr>
@@ -15124,7 +14394,7 @@
           <p:cNvPr id="15" name="timing-pill">
             <a:extLst xmlns:a="http://schemas.openxmlformats.org/drawingml/2006/main">
               <a:ext uri="{FF2B5EF4-FFF2-40B4-BE49-F238E27FC236}">
-                <a16:creationId xmlns:a16="http://schemas.microsoft.com/office/drawing/2014/main" id="{25F9C551-74E7-485E-8DF4-F43BB3D2061A}"/>
+                <a16:creationId xmlns:a16="http://schemas.microsoft.com/office/drawing/2014/main" id="{771CED07-0A7F-451D-A0C4-D5992D70B939}"/>
               </a:ext>
             </a:extLst>
           </p:cNvPr>
@@ -15159,7 +14429,7 @@
           <p:cNvPr id="16" name="timing-label">
             <a:extLst xmlns:a="http://schemas.openxmlformats.org/drawingml/2006/main">
               <a:ext uri="{FF2B5EF4-FFF2-40B4-BE49-F238E27FC236}">
-                <a16:creationId xmlns:a16="http://schemas.microsoft.com/office/drawing/2014/main" id="{3D01A90C-10E5-4898-8A71-AEC51A19A9F0}"/>
+                <a16:creationId xmlns:a16="http://schemas.microsoft.com/office/drawing/2014/main" id="{75298BDA-20CD-49D2-A228-C4B3119B9D41}"/>
               </a:ext>
             </a:extLst>
           </p:cNvPr>
@@ -15223,7 +14493,7 @@
           <p:cNvPr id="17" name="claim">
             <a:extLst xmlns:a="http://schemas.openxmlformats.org/drawingml/2006/main">
               <a:ext uri="{FF2B5EF4-FFF2-40B4-BE49-F238E27FC236}">
-                <a16:creationId xmlns:a16="http://schemas.microsoft.com/office/drawing/2014/main" id="{0B01B7D8-ED58-404F-95FC-BBFD9C340E56}"/>
+                <a16:creationId xmlns:a16="http://schemas.microsoft.com/office/drawing/2014/main" id="{9CAA462B-68A3-4FCF-92A6-ED38B7813893}"/>
               </a:ext>
             </a:extLst>
           </p:cNvPr>
@@ -15287,7 +14557,7 @@
           <p:cNvPr id="18" name="">
             <a:extLst xmlns:a="http://schemas.openxmlformats.org/drawingml/2006/main">
               <a:ext uri="{FF2B5EF4-FFF2-40B4-BE49-F238E27FC236}">
-                <a16:creationId xmlns:a16="http://schemas.microsoft.com/office/drawing/2014/main" id="{A5FB7AA6-8AA4-4D93-A10E-9EFE3DE38C09}"/>
+                <a16:creationId xmlns:a16="http://schemas.microsoft.com/office/drawing/2014/main" id="{D6BD7BCD-0888-47C9-B766-DFD53138BACE}"/>
               </a:ext>
             </a:extLst>
           </p:cNvPr>
@@ -15351,7 +14621,7 @@
           <p:cNvPr id="19" name="">
             <a:extLst xmlns:a="http://schemas.openxmlformats.org/drawingml/2006/main">
               <a:ext uri="{FF2B5EF4-FFF2-40B4-BE49-F238E27FC236}">
-                <a16:creationId xmlns:a16="http://schemas.microsoft.com/office/drawing/2014/main" id="{CCFE9A7B-9800-430C-86D7-BACC74CDF5EE}"/>
+                <a16:creationId xmlns:a16="http://schemas.microsoft.com/office/drawing/2014/main" id="{77D2B5EB-F7C0-4242-8E9B-E2F897BAFAD0}"/>
               </a:ext>
             </a:extLst>
           </p:cNvPr>
@@ -15415,7 +14685,7 @@
           <p:cNvPr id="20" name="">
             <a:extLst xmlns:a="http://schemas.openxmlformats.org/drawingml/2006/main">
               <a:ext uri="{FF2B5EF4-FFF2-40B4-BE49-F238E27FC236}">
-                <a16:creationId xmlns:a16="http://schemas.microsoft.com/office/drawing/2014/main" id="{A365CE2F-B78F-4EB8-8084-F4671CB24DAA}"/>
+                <a16:creationId xmlns:a16="http://schemas.microsoft.com/office/drawing/2014/main" id="{7DE16CEA-06F5-434F-8DC7-ED0569308B68}"/>
               </a:ext>
             </a:extLst>
           </p:cNvPr>
@@ -15452,7 +14722,7 @@
           <p:cNvPr id="21" name="">
             <a:extLst xmlns:a="http://schemas.openxmlformats.org/drawingml/2006/main">
               <a:ext uri="{FF2B5EF4-FFF2-40B4-BE49-F238E27FC236}">
-                <a16:creationId xmlns:a16="http://schemas.microsoft.com/office/drawing/2014/main" id="{5BDAE1E6-86DC-42D6-9544-234536B4F38A}"/>
+                <a16:creationId xmlns:a16="http://schemas.microsoft.com/office/drawing/2014/main" id="{36D970D1-5A22-49FE-9CDA-E72B46105726}"/>
               </a:ext>
             </a:extLst>
           </p:cNvPr>
@@ -15489,7 +14759,7 @@
           <p:cNvPr id="22" name="">
             <a:extLst xmlns:a="http://schemas.openxmlformats.org/drawingml/2006/main">
               <a:ext uri="{FF2B5EF4-FFF2-40B4-BE49-F238E27FC236}">
-                <a16:creationId xmlns:a16="http://schemas.microsoft.com/office/drawing/2014/main" id="{2D426669-D460-4E5F-8D41-B870E5636930}"/>
+                <a16:creationId xmlns:a16="http://schemas.microsoft.com/office/drawing/2014/main" id="{6E9D2D0B-6C56-49DB-B8A8-7EC0375935AF}"/>
               </a:ext>
             </a:extLst>
           </p:cNvPr>
@@ -15553,7 +14823,7 @@
           <p:cNvPr id="23" name="">
             <a:extLst xmlns:a="http://schemas.openxmlformats.org/drawingml/2006/main">
               <a:ext uri="{FF2B5EF4-FFF2-40B4-BE49-F238E27FC236}">
-                <a16:creationId xmlns:a16="http://schemas.microsoft.com/office/drawing/2014/main" id="{960CEDED-8BF6-4F41-BDFF-D9B4ED68DBD9}"/>
+                <a16:creationId xmlns:a16="http://schemas.microsoft.com/office/drawing/2014/main" id="{93DD636A-9296-455A-9FDF-CB04C4D157FC}"/>
               </a:ext>
             </a:extLst>
           </p:cNvPr>
@@ -15617,7 +14887,7 @@
           <p:cNvPr id="24" name="">
             <a:extLst xmlns:a="http://schemas.openxmlformats.org/drawingml/2006/main">
               <a:ext uri="{FF2B5EF4-FFF2-40B4-BE49-F238E27FC236}">
-                <a16:creationId xmlns:a16="http://schemas.microsoft.com/office/drawing/2014/main" id="{84D65975-100C-4B83-866E-F241F4145B4F}"/>
+                <a16:creationId xmlns:a16="http://schemas.microsoft.com/office/drawing/2014/main" id="{F33104CE-4CA4-4804-AF1D-D2CB0B1E85E2}"/>
               </a:ext>
             </a:extLst>
           </p:cNvPr>
@@ -15654,7 +14924,7 @@
           <p:cNvPr id="25" name="">
             <a:extLst xmlns:a="http://schemas.openxmlformats.org/drawingml/2006/main">
               <a:ext uri="{FF2B5EF4-FFF2-40B4-BE49-F238E27FC236}">
-                <a16:creationId xmlns:a16="http://schemas.microsoft.com/office/drawing/2014/main" id="{53FD6F7A-42B3-46F8-923F-38E853F3A1C5}"/>
+                <a16:creationId xmlns:a16="http://schemas.microsoft.com/office/drawing/2014/main" id="{B32BA284-5EA8-41F7-A717-223605FBC26D}"/>
               </a:ext>
             </a:extLst>
           </p:cNvPr>
@@ -15691,7 +14961,7 @@
           <p:cNvPr id="26" name="">
             <a:extLst xmlns:a="http://schemas.openxmlformats.org/drawingml/2006/main">
               <a:ext uri="{FF2B5EF4-FFF2-40B4-BE49-F238E27FC236}">
-                <a16:creationId xmlns:a16="http://schemas.microsoft.com/office/drawing/2014/main" id="{1C1D0F5E-69E9-46D3-AB8C-8D270ABDE954}"/>
+                <a16:creationId xmlns:a16="http://schemas.microsoft.com/office/drawing/2014/main" id="{A0F8470F-EDC7-485D-96D1-9C03F1848005}"/>
               </a:ext>
             </a:extLst>
           </p:cNvPr>
@@ -15755,7 +15025,7 @@
           <p:cNvPr id="27" name="">
             <a:extLst xmlns:a="http://schemas.openxmlformats.org/drawingml/2006/main">
               <a:ext uri="{FF2B5EF4-FFF2-40B4-BE49-F238E27FC236}">
-                <a16:creationId xmlns:a16="http://schemas.microsoft.com/office/drawing/2014/main" id="{B7B900B0-F778-49EF-B84F-AD2366D88BD9}"/>
+                <a16:creationId xmlns:a16="http://schemas.microsoft.com/office/drawing/2014/main" id="{FED66FD8-C3E2-40A6-990E-0E2B6E490AED}"/>
               </a:ext>
             </a:extLst>
           </p:cNvPr>
@@ -15819,7 +15089,7 @@
           <p:cNvPr id="28" name="">
             <a:extLst xmlns:a="http://schemas.openxmlformats.org/drawingml/2006/main">
               <a:ext uri="{FF2B5EF4-FFF2-40B4-BE49-F238E27FC236}">
-                <a16:creationId xmlns:a16="http://schemas.microsoft.com/office/drawing/2014/main" id="{32ED4D52-3EEA-41AD-906A-1E6369239B28}"/>
+                <a16:creationId xmlns:a16="http://schemas.microsoft.com/office/drawing/2014/main" id="{46300248-D0BF-46C7-8B25-C6D1651B3237}"/>
               </a:ext>
             </a:extLst>
           </p:cNvPr>
@@ -15856,7 +15126,7 @@
           <p:cNvPr id="29" name="">
             <a:extLst xmlns:a="http://schemas.openxmlformats.org/drawingml/2006/main">
               <a:ext uri="{FF2B5EF4-FFF2-40B4-BE49-F238E27FC236}">
-                <a16:creationId xmlns:a16="http://schemas.microsoft.com/office/drawing/2014/main" id="{C6144F7E-5CC8-4138-9CB6-982D6DF57A06}"/>
+                <a16:creationId xmlns:a16="http://schemas.microsoft.com/office/drawing/2014/main" id="{F5A61886-98B5-4F15-A736-E86C4EB4EF2C}"/>
               </a:ext>
             </a:extLst>
           </p:cNvPr>
@@ -15893,7 +15163,7 @@
           <p:cNvPr id="30" name="">
             <a:extLst xmlns:a="http://schemas.openxmlformats.org/drawingml/2006/main">
               <a:ext uri="{FF2B5EF4-FFF2-40B4-BE49-F238E27FC236}">
-                <a16:creationId xmlns:a16="http://schemas.microsoft.com/office/drawing/2014/main" id="{FD56F7F5-8CFC-4A35-BBC8-B674FDABA0AA}"/>
+                <a16:creationId xmlns:a16="http://schemas.microsoft.com/office/drawing/2014/main" id="{ADC4FA71-5BBD-4791-A48E-E14A25C440AF}"/>
               </a:ext>
             </a:extLst>
           </p:cNvPr>
@@ -15957,7 +15227,7 @@
           <p:cNvPr id="31" name="">
             <a:extLst xmlns:a="http://schemas.openxmlformats.org/drawingml/2006/main">
               <a:ext uri="{FF2B5EF4-FFF2-40B4-BE49-F238E27FC236}">
-                <a16:creationId xmlns:a16="http://schemas.microsoft.com/office/drawing/2014/main" id="{0587A1D1-2FD1-492D-B634-E9EB03D93966}"/>
+                <a16:creationId xmlns:a16="http://schemas.microsoft.com/office/drawing/2014/main" id="{ADD3BCB9-0B6B-4D8A-8F0E-2544954963CE}"/>
               </a:ext>
             </a:extLst>
           </p:cNvPr>
@@ -16021,7 +15291,7 @@
           <p:cNvPr id="32" name="">
             <a:extLst xmlns:a="http://schemas.openxmlformats.org/drawingml/2006/main">
               <a:ext uri="{FF2B5EF4-FFF2-40B4-BE49-F238E27FC236}">
-                <a16:creationId xmlns:a16="http://schemas.microsoft.com/office/drawing/2014/main" id="{31BF921D-0CDE-4F14-AF86-4E7109AAE096}"/>
+                <a16:creationId xmlns:a16="http://schemas.microsoft.com/office/drawing/2014/main" id="{0298E314-BE26-4D36-A687-0CC835165B75}"/>
               </a:ext>
             </a:extLst>
           </p:cNvPr>
@@ -16058,7 +15328,7 @@
           <p:cNvPr id="33" name="">
             <a:extLst xmlns:a="http://schemas.openxmlformats.org/drawingml/2006/main">
               <a:ext uri="{FF2B5EF4-FFF2-40B4-BE49-F238E27FC236}">
-                <a16:creationId xmlns:a16="http://schemas.microsoft.com/office/drawing/2014/main" id="{9B65B482-517B-4342-8DAD-89D52F6ED2C7}"/>
+                <a16:creationId xmlns:a16="http://schemas.microsoft.com/office/drawing/2014/main" id="{476C2F7A-C2A9-418F-864B-7F5128383954}"/>
               </a:ext>
             </a:extLst>
           </p:cNvPr>
@@ -16095,7 +15365,7 @@
           <p:cNvPr id="34" name="">
             <a:extLst xmlns:a="http://schemas.openxmlformats.org/drawingml/2006/main">
               <a:ext uri="{FF2B5EF4-FFF2-40B4-BE49-F238E27FC236}">
-                <a16:creationId xmlns:a16="http://schemas.microsoft.com/office/drawing/2014/main" id="{D64610B8-5D37-41B1-963E-2DCA88C603F4}"/>
+                <a16:creationId xmlns:a16="http://schemas.microsoft.com/office/drawing/2014/main" id="{A5D8957C-689C-4A51-9F26-709BE8A9709B}"/>
               </a:ext>
             </a:extLst>
           </p:cNvPr>
@@ -16159,7 +15429,7 @@
           <p:cNvPr id="35" name="">
             <a:extLst xmlns:a="http://schemas.openxmlformats.org/drawingml/2006/main">
               <a:ext uri="{FF2B5EF4-FFF2-40B4-BE49-F238E27FC236}">
-                <a16:creationId xmlns:a16="http://schemas.microsoft.com/office/drawing/2014/main" id="{6217F7E1-CAE2-476F-B32D-E54462A126FB}"/>
+                <a16:creationId xmlns:a16="http://schemas.microsoft.com/office/drawing/2014/main" id="{0DF72C76-E341-4F1F-8E21-B8E414DE8D5C}"/>
               </a:ext>
             </a:extLst>
           </p:cNvPr>
@@ -16223,7 +15493,7 @@
           <p:cNvPr id="36" name="">
             <a:extLst xmlns:a="http://schemas.openxmlformats.org/drawingml/2006/main">
               <a:ext uri="{FF2B5EF4-FFF2-40B4-BE49-F238E27FC236}">
-                <a16:creationId xmlns:a16="http://schemas.microsoft.com/office/drawing/2014/main" id="{A63E3887-D492-469F-B3CA-5D6A5E28960F}"/>
+                <a16:creationId xmlns:a16="http://schemas.microsoft.com/office/drawing/2014/main" id="{CA61FC43-E23E-4E65-8F8F-30F5D1052992}"/>
               </a:ext>
             </a:extLst>
           </p:cNvPr>
@@ -16260,7 +15530,7 @@
           <p:cNvPr id="37" name="">
             <a:extLst xmlns:a="http://schemas.openxmlformats.org/drawingml/2006/main">
               <a:ext uri="{FF2B5EF4-FFF2-40B4-BE49-F238E27FC236}">
-                <a16:creationId xmlns:a16="http://schemas.microsoft.com/office/drawing/2014/main" id="{0FBE7A8E-9540-44A0-8710-DD66720E97DA}"/>
+                <a16:creationId xmlns:a16="http://schemas.microsoft.com/office/drawing/2014/main" id="{809049C0-9428-416D-9A7C-5C93E577712F}"/>
               </a:ext>
             </a:extLst>
           </p:cNvPr>
@@ -16297,7 +15567,7 @@
           <p:cNvPr id="38" name="">
             <a:extLst xmlns:a="http://schemas.openxmlformats.org/drawingml/2006/main">
               <a:ext uri="{FF2B5EF4-FFF2-40B4-BE49-F238E27FC236}">
-                <a16:creationId xmlns:a16="http://schemas.microsoft.com/office/drawing/2014/main" id="{9915402F-F4A1-47C8-B936-08D6CE4797CE}"/>
+                <a16:creationId xmlns:a16="http://schemas.microsoft.com/office/drawing/2014/main" id="{5C13D723-E9CA-4B78-AF14-A600DF2C9DC4}"/>
               </a:ext>
             </a:extLst>
           </p:cNvPr>
@@ -16361,7 +15631,7 @@
           <p:cNvPr id="39" name="">
             <a:extLst xmlns:a="http://schemas.openxmlformats.org/drawingml/2006/main">
               <a:ext uri="{FF2B5EF4-FFF2-40B4-BE49-F238E27FC236}">
-                <a16:creationId xmlns:a16="http://schemas.microsoft.com/office/drawing/2014/main" id="{7AC609E4-83FE-494C-BF5A-416F9B07B94F}"/>
+                <a16:creationId xmlns:a16="http://schemas.microsoft.com/office/drawing/2014/main" id="{B4FACCC1-4F62-4310-99D0-9AC0CFC34E2B}"/>
               </a:ext>
             </a:extLst>
           </p:cNvPr>
@@ -16425,7 +15695,7 @@
           <p:cNvPr id="40" name="">
             <a:extLst xmlns:a="http://schemas.openxmlformats.org/drawingml/2006/main">
               <a:ext uri="{FF2B5EF4-FFF2-40B4-BE49-F238E27FC236}">
-                <a16:creationId xmlns:a16="http://schemas.microsoft.com/office/drawing/2014/main" id="{9E944024-0072-4A74-ACF2-88129FE93AD2}"/>
+                <a16:creationId xmlns:a16="http://schemas.microsoft.com/office/drawing/2014/main" id="{8578F618-A843-4DCF-AC05-BA8C56C24D00}"/>
               </a:ext>
             </a:extLst>
           </p:cNvPr>
@@ -16462,7 +15732,7 @@
           <p:cNvPr id="41" name="">
             <a:extLst xmlns:a="http://schemas.openxmlformats.org/drawingml/2006/main">
               <a:ext uri="{FF2B5EF4-FFF2-40B4-BE49-F238E27FC236}">
-                <a16:creationId xmlns:a16="http://schemas.microsoft.com/office/drawing/2014/main" id="{ECD79062-C7D4-4228-A688-B06837D2FD5B}"/>
+                <a16:creationId xmlns:a16="http://schemas.microsoft.com/office/drawing/2014/main" id="{A16A47E5-1D10-4AA3-BEB9-1D1CFBFDA239}"/>
               </a:ext>
             </a:extLst>
           </p:cNvPr>
@@ -16499,7 +15769,7 @@
           <p:cNvPr id="42" name="">
             <a:extLst xmlns:a="http://schemas.openxmlformats.org/drawingml/2006/main">
               <a:ext uri="{FF2B5EF4-FFF2-40B4-BE49-F238E27FC236}">
-                <a16:creationId xmlns:a16="http://schemas.microsoft.com/office/drawing/2014/main" id="{F3215AD0-7BF3-416D-BF6C-25ACCEDB5DE3}"/>
+                <a16:creationId xmlns:a16="http://schemas.microsoft.com/office/drawing/2014/main" id="{F5D806A6-F305-438E-A42F-92205A552936}"/>
               </a:ext>
             </a:extLst>
           </p:cNvPr>
@@ -16563,7 +15833,7 @@
           <p:cNvPr id="43" name="">
             <a:extLst xmlns:a="http://schemas.openxmlformats.org/drawingml/2006/main">
               <a:ext uri="{FF2B5EF4-FFF2-40B4-BE49-F238E27FC236}">
-                <a16:creationId xmlns:a16="http://schemas.microsoft.com/office/drawing/2014/main" id="{0E8BE5E7-73F8-4ACA-97FA-F6147C1C469F}"/>
+                <a16:creationId xmlns:a16="http://schemas.microsoft.com/office/drawing/2014/main" id="{B633ED4C-8E74-4635-8FDC-FE2046707200}"/>
               </a:ext>
             </a:extLst>
           </p:cNvPr>
@@ -16627,7 +15897,7 @@
           <p:cNvPr id="44" name="">
             <a:extLst xmlns:a="http://schemas.openxmlformats.org/drawingml/2006/main">
               <a:ext uri="{FF2B5EF4-FFF2-40B4-BE49-F238E27FC236}">
-                <a16:creationId xmlns:a16="http://schemas.microsoft.com/office/drawing/2014/main" id="{03DB775D-6432-4E5F-B009-35AEBFB6C099}"/>
+                <a16:creationId xmlns:a16="http://schemas.microsoft.com/office/drawing/2014/main" id="{25620DCF-860F-4295-807B-DA4D7E50C961}"/>
               </a:ext>
             </a:extLst>
           </p:cNvPr>
@@ -16664,7 +15934,7 @@
           <p:cNvPr id="45" name="">
             <a:extLst xmlns:a="http://schemas.openxmlformats.org/drawingml/2006/main">
               <a:ext uri="{FF2B5EF4-FFF2-40B4-BE49-F238E27FC236}">
-                <a16:creationId xmlns:a16="http://schemas.microsoft.com/office/drawing/2014/main" id="{C95AB9D8-58FE-46D7-82CD-FD086552DEB1}"/>
+                <a16:creationId xmlns:a16="http://schemas.microsoft.com/office/drawing/2014/main" id="{93BFDFDA-5D65-4152-B1EE-2FAFB06F057F}"/>
               </a:ext>
             </a:extLst>
           </p:cNvPr>
@@ -16701,7 +15971,7 @@
           <p:cNvPr id="46" name="">
             <a:extLst xmlns:a="http://schemas.openxmlformats.org/drawingml/2006/main">
               <a:ext uri="{FF2B5EF4-FFF2-40B4-BE49-F238E27FC236}">
-                <a16:creationId xmlns:a16="http://schemas.microsoft.com/office/drawing/2014/main" id="{4408F0ED-BD1A-4EAD-959B-A76FFDDDC828}"/>
+                <a16:creationId xmlns:a16="http://schemas.microsoft.com/office/drawing/2014/main" id="{48A8EBD7-BD75-4A2A-9144-52400A1464D5}"/>
               </a:ext>
             </a:extLst>
           </p:cNvPr>
@@ -16765,7 +16035,7 @@
           <p:cNvPr id="47" name="">
             <a:extLst xmlns:a="http://schemas.openxmlformats.org/drawingml/2006/main">
               <a:ext uri="{FF2B5EF4-FFF2-40B4-BE49-F238E27FC236}">
-                <a16:creationId xmlns:a16="http://schemas.microsoft.com/office/drawing/2014/main" id="{5337DE54-D797-40AE-9E13-349444E23341}"/>
+                <a16:creationId xmlns:a16="http://schemas.microsoft.com/office/drawing/2014/main" id="{BFDBC9D0-758E-4FDE-89AD-8A018F303497}"/>
               </a:ext>
             </a:extLst>
           </p:cNvPr>
@@ -16800,7 +16070,7 @@
           <p:cNvPr id="48" name="">
             <a:extLst xmlns:a="http://schemas.openxmlformats.org/drawingml/2006/main">
               <a:ext uri="{FF2B5EF4-FFF2-40B4-BE49-F238E27FC236}">
-                <a16:creationId xmlns:a16="http://schemas.microsoft.com/office/drawing/2014/main" id="{E0B2CC73-1145-4F90-BA7C-31A80B28C5F3}"/>
+                <a16:creationId xmlns:a16="http://schemas.microsoft.com/office/drawing/2014/main" id="{9FF13B9B-A041-430E-BC42-78FCD367DBF6}"/>
               </a:ext>
             </a:extLst>
           </p:cNvPr>
@@ -16864,7 +16134,7 @@
           <p:cNvPr id="49" name="">
             <a:extLst xmlns:a="http://schemas.openxmlformats.org/drawingml/2006/main">
               <a:ext uri="{FF2B5EF4-FFF2-40B4-BE49-F238E27FC236}">
-                <a16:creationId xmlns:a16="http://schemas.microsoft.com/office/drawing/2014/main" id="{B69279E6-2CE7-44A6-9939-E6678C37A840}"/>
+                <a16:creationId xmlns:a16="http://schemas.microsoft.com/office/drawing/2014/main" id="{C8EDA81B-9D05-4C9E-804F-1803DF75B96D}"/>
               </a:ext>
             </a:extLst>
           </p:cNvPr>
@@ -16928,7 +16198,7 @@
           <p:cNvPr id="50" name="">
             <a:extLst xmlns:a="http://schemas.openxmlformats.org/drawingml/2006/main">
               <a:ext uri="{FF2B5EF4-FFF2-40B4-BE49-F238E27FC236}">
-                <a16:creationId xmlns:a16="http://schemas.microsoft.com/office/drawing/2014/main" id="{BA62F486-EE72-47C4-AFCE-F6D68B306BBC}"/>
+                <a16:creationId xmlns:a16="http://schemas.microsoft.com/office/drawing/2014/main" id="{70D871E6-DFF5-477F-91BC-12E3F081831A}"/>
               </a:ext>
             </a:extLst>
           </p:cNvPr>
@@ -16992,7 +16262,7 @@
           <p:cNvPr id="51" name="">
             <a:extLst xmlns:a="http://schemas.openxmlformats.org/drawingml/2006/main">
               <a:ext uri="{FF2B5EF4-FFF2-40B4-BE49-F238E27FC236}">
-                <a16:creationId xmlns:a16="http://schemas.microsoft.com/office/drawing/2014/main" id="{A7D6ACF6-A8F9-4DFE-884C-4AD6D7705AFB}"/>
+                <a16:creationId xmlns:a16="http://schemas.microsoft.com/office/drawing/2014/main" id="{37026350-0C3A-43EF-8100-45A30A08BD52}"/>
               </a:ext>
             </a:extLst>
           </p:cNvPr>
@@ -17027,7 +16297,7 @@
           <p:cNvPr id="52" name="">
             <a:extLst xmlns:a="http://schemas.openxmlformats.org/drawingml/2006/main">
               <a:ext uri="{FF2B5EF4-FFF2-40B4-BE49-F238E27FC236}">
-                <a16:creationId xmlns:a16="http://schemas.microsoft.com/office/drawing/2014/main" id="{7EE281A8-BCAC-4A42-BDB0-561EC39CD6BD}"/>
+                <a16:creationId xmlns:a16="http://schemas.microsoft.com/office/drawing/2014/main" id="{C0EF9FDC-B064-4424-A858-475CED0554BF}"/>
               </a:ext>
             </a:extLst>
           </p:cNvPr>
@@ -17091,7 +16361,7 @@
           <p:cNvPr id="53" name="">
             <a:extLst xmlns:a="http://schemas.openxmlformats.org/drawingml/2006/main">
               <a:ext uri="{FF2B5EF4-FFF2-40B4-BE49-F238E27FC236}">
-                <a16:creationId xmlns:a16="http://schemas.microsoft.com/office/drawing/2014/main" id="{8EC14BC3-6246-40BD-A1DE-8FF84F628A37}"/>
+                <a16:creationId xmlns:a16="http://schemas.microsoft.com/office/drawing/2014/main" id="{2D55EA1A-A755-4221-B008-65F2170E1FA5}"/>
               </a:ext>
             </a:extLst>
           </p:cNvPr>
@@ -17155,7 +16425,7 @@
           <p:cNvPr id="54" name="">
             <a:extLst xmlns:a="http://schemas.openxmlformats.org/drawingml/2006/main">
               <a:ext uri="{FF2B5EF4-FFF2-40B4-BE49-F238E27FC236}">
-                <a16:creationId xmlns:a16="http://schemas.microsoft.com/office/drawing/2014/main" id="{2EC82DCA-46AE-4F26-9C44-7DD5DD02B011}"/>
+                <a16:creationId xmlns:a16="http://schemas.microsoft.com/office/drawing/2014/main" id="{F19FC09F-3C85-42F3-9473-525B6718A2CE}"/>
               </a:ext>
             </a:extLst>
           </p:cNvPr>
@@ -17219,7 +16489,7 @@
           <p:cNvPr id="55" name="">
             <a:extLst xmlns:a="http://schemas.openxmlformats.org/drawingml/2006/main">
               <a:ext uri="{FF2B5EF4-FFF2-40B4-BE49-F238E27FC236}">
-                <a16:creationId xmlns:a16="http://schemas.microsoft.com/office/drawing/2014/main" id="{C39D73F6-2920-4183-8D2C-A078EB7DBDB8}"/>
+                <a16:creationId xmlns:a16="http://schemas.microsoft.com/office/drawing/2014/main" id="{0AA9B807-D2A2-49CF-88C7-F57D1D528D2E}"/>
               </a:ext>
             </a:extLst>
           </p:cNvPr>
@@ -17616,7 +16886,7 @@
           <p:nvPr/>
         </p:nvPicPr>
         <p:blipFill>
-          <a:blip xmlns:r="http://schemas.openxmlformats.org/officeDocument/2006/relationships" xmlns:a="http://schemas.openxmlformats.org/drawingml/2006/main" r:embed="R6b16ad06ef5f418e"/>
+          <a:blip xmlns:r="http://schemas.openxmlformats.org/officeDocument/2006/relationships" xmlns:a="http://schemas.openxmlformats.org/drawingml/2006/main" r:embed="R04ebb73565d24a60"/>
           <a:stretch xmlns:a="http://schemas.openxmlformats.org/drawingml/2006/main"/>
         </p:blipFill>
         <p:spPr>
@@ -17634,7 +16904,7 @@
           <p:cNvPr id="15" name="timing-pill">
             <a:extLst xmlns:a="http://schemas.openxmlformats.org/drawingml/2006/main">
               <a:ext uri="{FF2B5EF4-FFF2-40B4-BE49-F238E27FC236}">
-                <a16:creationId xmlns:a16="http://schemas.microsoft.com/office/drawing/2014/main" id="{3302C7FC-775C-4445-AC9F-CE3AD50C2C4C}"/>
+                <a16:creationId xmlns:a16="http://schemas.microsoft.com/office/drawing/2014/main" id="{AB151CA8-8B9A-4153-AD55-9CAAE44A6574}"/>
               </a:ext>
             </a:extLst>
           </p:cNvPr>
@@ -17669,7 +16939,7 @@
           <p:cNvPr id="16" name="timing-label">
             <a:extLst xmlns:a="http://schemas.openxmlformats.org/drawingml/2006/main">
               <a:ext uri="{FF2B5EF4-FFF2-40B4-BE49-F238E27FC236}">
-                <a16:creationId xmlns:a16="http://schemas.microsoft.com/office/drawing/2014/main" id="{11C70E33-38DE-41A7-B1BE-119729E448D8}"/>
+                <a16:creationId xmlns:a16="http://schemas.microsoft.com/office/drawing/2014/main" id="{EA2EEF6F-BBAD-4443-B8E5-8DDB3E8E2782}"/>
               </a:ext>
             </a:extLst>
           </p:cNvPr>
@@ -17733,7 +17003,7 @@
           <p:cNvPr id="17" name="claim">
             <a:extLst xmlns:a="http://schemas.openxmlformats.org/drawingml/2006/main">
               <a:ext uri="{FF2B5EF4-FFF2-40B4-BE49-F238E27FC236}">
-                <a16:creationId xmlns:a16="http://schemas.microsoft.com/office/drawing/2014/main" id="{237A9046-8028-413B-99B2-7F74F238588E}"/>
+                <a16:creationId xmlns:a16="http://schemas.microsoft.com/office/drawing/2014/main" id="{B006D244-0F9D-4CC4-B63C-954E8FD89529}"/>
               </a:ext>
             </a:extLst>
           </p:cNvPr>
@@ -17797,7 +17067,7 @@
           <p:cNvPr id="18" name="">
             <a:extLst xmlns:a="http://schemas.openxmlformats.org/drawingml/2006/main">
               <a:ext uri="{FF2B5EF4-FFF2-40B4-BE49-F238E27FC236}">
-                <a16:creationId xmlns:a16="http://schemas.microsoft.com/office/drawing/2014/main" id="{03FB0BF1-3526-43C7-B5AA-D36450872D83}"/>
+                <a16:creationId xmlns:a16="http://schemas.microsoft.com/office/drawing/2014/main" id="{A7B6344E-30EB-4730-B286-FC30F82CA5F8}"/>
               </a:ext>
             </a:extLst>
           </p:cNvPr>
@@ -17832,7 +17102,7 @@
           <p:cNvPr id="19" name="">
             <a:extLst xmlns:a="http://schemas.openxmlformats.org/drawingml/2006/main">
               <a:ext uri="{FF2B5EF4-FFF2-40B4-BE49-F238E27FC236}">
-                <a16:creationId xmlns:a16="http://schemas.microsoft.com/office/drawing/2014/main" id="{56DB0651-A74B-4024-910E-DE443BDEFF5C}"/>
+                <a16:creationId xmlns:a16="http://schemas.microsoft.com/office/drawing/2014/main" id="{8DA5C2C5-6635-48C9-9FE6-AB7C984EB384}"/>
               </a:ext>
             </a:extLst>
           </p:cNvPr>
@@ -17896,7 +17166,7 @@
           <p:cNvPr id="20" name="">
             <a:extLst xmlns:a="http://schemas.openxmlformats.org/drawingml/2006/main">
               <a:ext uri="{FF2B5EF4-FFF2-40B4-BE49-F238E27FC236}">
-                <a16:creationId xmlns:a16="http://schemas.microsoft.com/office/drawing/2014/main" id="{030693E8-4707-440C-8538-472FAFAAC04F}"/>
+                <a16:creationId xmlns:a16="http://schemas.microsoft.com/office/drawing/2014/main" id="{3ABCE1CD-BA56-4B8C-91EC-ADB3637DC13E}"/>
               </a:ext>
             </a:extLst>
           </p:cNvPr>
@@ -17960,7 +17230,7 @@
           <p:cNvPr id="21" name="">
             <a:extLst xmlns:a="http://schemas.openxmlformats.org/drawingml/2006/main">
               <a:ext uri="{FF2B5EF4-FFF2-40B4-BE49-F238E27FC236}">
-                <a16:creationId xmlns:a16="http://schemas.microsoft.com/office/drawing/2014/main" id="{C64CDD2C-2CC3-4DA0-99E0-9AB25D3F544E}"/>
+                <a16:creationId xmlns:a16="http://schemas.microsoft.com/office/drawing/2014/main" id="{6846C5E9-1F68-4678-9579-61F9D2835CE7}"/>
               </a:ext>
             </a:extLst>
           </p:cNvPr>
@@ -18024,7 +17294,7 @@
           <p:cNvPr id="22" name="">
             <a:extLst xmlns:a="http://schemas.openxmlformats.org/drawingml/2006/main">
               <a:ext uri="{FF2B5EF4-FFF2-40B4-BE49-F238E27FC236}">
-                <a16:creationId xmlns:a16="http://schemas.microsoft.com/office/drawing/2014/main" id="{BEE25001-2C29-42DA-81AB-84491E42708F}"/>
+                <a16:creationId xmlns:a16="http://schemas.microsoft.com/office/drawing/2014/main" id="{85A1A704-6971-4017-97B9-4B113558931B}"/>
               </a:ext>
             </a:extLst>
           </p:cNvPr>
@@ -18059,7 +17329,7 @@
           <p:cNvPr id="23" name="">
             <a:extLst xmlns:a="http://schemas.openxmlformats.org/drawingml/2006/main">
               <a:ext uri="{FF2B5EF4-FFF2-40B4-BE49-F238E27FC236}">
-                <a16:creationId xmlns:a16="http://schemas.microsoft.com/office/drawing/2014/main" id="{814B213F-595D-4B47-88EE-44F0E9EF6531}"/>
+                <a16:creationId xmlns:a16="http://schemas.microsoft.com/office/drawing/2014/main" id="{947FDF85-E192-4281-A281-8594E8CE2923}"/>
               </a:ext>
             </a:extLst>
           </p:cNvPr>
@@ -18123,7 +17393,7 @@
           <p:cNvPr id="24" name="">
             <a:extLst xmlns:a="http://schemas.openxmlformats.org/drawingml/2006/main">
               <a:ext uri="{FF2B5EF4-FFF2-40B4-BE49-F238E27FC236}">
-                <a16:creationId xmlns:a16="http://schemas.microsoft.com/office/drawing/2014/main" id="{922C8582-0F86-4170-86EC-B3732B050CFC}"/>
+                <a16:creationId xmlns:a16="http://schemas.microsoft.com/office/drawing/2014/main" id="{6BB1AC31-0209-4B22-BE38-2B4D84AEDAD6}"/>
               </a:ext>
             </a:extLst>
           </p:cNvPr>
@@ -18187,7 +17457,7 @@
           <p:cNvPr id="25" name="">
             <a:extLst xmlns:a="http://schemas.openxmlformats.org/drawingml/2006/main">
               <a:ext uri="{FF2B5EF4-FFF2-40B4-BE49-F238E27FC236}">
-                <a16:creationId xmlns:a16="http://schemas.microsoft.com/office/drawing/2014/main" id="{2C0D992A-7FAD-44B3-9E1B-61892027B2B1}"/>
+                <a16:creationId xmlns:a16="http://schemas.microsoft.com/office/drawing/2014/main" id="{9CCD9989-DB8E-4816-A2D6-A8BA4B5F7065}"/>
               </a:ext>
             </a:extLst>
           </p:cNvPr>
@@ -18251,7 +17521,7 @@
           <p:cNvPr id="26" name="">
             <a:extLst xmlns:a="http://schemas.openxmlformats.org/drawingml/2006/main">
               <a:ext uri="{FF2B5EF4-FFF2-40B4-BE49-F238E27FC236}">
-                <a16:creationId xmlns:a16="http://schemas.microsoft.com/office/drawing/2014/main" id="{2B0783A2-D603-43EF-B84F-8B3CCC4388E1}"/>
+                <a16:creationId xmlns:a16="http://schemas.microsoft.com/office/drawing/2014/main" id="{4D8E7DAD-28C9-4B42-AA95-C5E7D1C4CB67}"/>
               </a:ext>
             </a:extLst>
           </p:cNvPr>
@@ -18286,7 +17556,7 @@
           <p:cNvPr id="27" name="">
             <a:extLst xmlns:a="http://schemas.openxmlformats.org/drawingml/2006/main">
               <a:ext uri="{FF2B5EF4-FFF2-40B4-BE49-F238E27FC236}">
-                <a16:creationId xmlns:a16="http://schemas.microsoft.com/office/drawing/2014/main" id="{EE4CD315-D37A-40CF-82C6-9741669BBB2E}"/>
+                <a16:creationId xmlns:a16="http://schemas.microsoft.com/office/drawing/2014/main" id="{E5AE095C-462A-4821-BF0E-C27AFE79A2EA}"/>
               </a:ext>
             </a:extLst>
           </p:cNvPr>
@@ -18350,7 +17620,7 @@
           <p:cNvPr id="28" name="">
             <a:extLst xmlns:a="http://schemas.openxmlformats.org/drawingml/2006/main">
               <a:ext uri="{FF2B5EF4-FFF2-40B4-BE49-F238E27FC236}">
-                <a16:creationId xmlns:a16="http://schemas.microsoft.com/office/drawing/2014/main" id="{89DC5675-EB57-4AF5-BA02-89534A45BAB2}"/>
+                <a16:creationId xmlns:a16="http://schemas.microsoft.com/office/drawing/2014/main" id="{B07AC5CB-1995-44B9-8AF5-9BE1E9EE8C8F}"/>
               </a:ext>
             </a:extLst>
           </p:cNvPr>
@@ -18414,7 +17684,7 @@
           <p:cNvPr id="29" name="">
             <a:extLst xmlns:a="http://schemas.openxmlformats.org/drawingml/2006/main">
               <a:ext uri="{FF2B5EF4-FFF2-40B4-BE49-F238E27FC236}">
-                <a16:creationId xmlns:a16="http://schemas.microsoft.com/office/drawing/2014/main" id="{0AB699C8-9EDD-4C15-A1E1-2FB3A7142804}"/>
+                <a16:creationId xmlns:a16="http://schemas.microsoft.com/office/drawing/2014/main" id="{DF9FB1CB-02DC-4C2F-A514-79ED6AEE15A7}"/>
               </a:ext>
             </a:extLst>
           </p:cNvPr>
@@ -18469,105 +17739,6 @@
                 <a:cs typeface="Aptos"/>
               </a:rPr>
               <a:t>TargetOnly PEHE to Proposed-CF</a:t>
-            </a:r>
-          </a:p>
-        </p:txBody>
-      </p:sp>
-      <p:sp>
-        <p:nvSpPr>
-          <p:cNvPr id="30" name="">
-            <a:extLst xmlns:a="http://schemas.openxmlformats.org/drawingml/2006/main">
-              <a:ext uri="{FF2B5EF4-FFF2-40B4-BE49-F238E27FC236}">
-                <a16:creationId xmlns:a16="http://schemas.microsoft.com/office/drawing/2014/main" id="{ECADCFA7-495C-4856-B7E8-11932A43B9D5}"/>
-              </a:ext>
-            </a:extLst>
-          </p:cNvPr>
-          <p:cNvSpPr>
-            <a:spLocks xmlns:a="http://schemas.openxmlformats.org/drawingml/2006/main" noGrp="1"/>
-          </p:cNvSpPr>
-          <p:nvPr/>
-        </p:nvSpPr>
-        <p:spPr>
-          <a:xfrm xmlns:a="http://schemas.openxmlformats.org/drawingml/2006/main">
-            <a:off x="781050" y="3790950"/>
-            <a:ext cx="9582150" cy="1066800"/>
-          </a:xfrm>
-          <a:prstGeom xmlns:a="http://schemas.openxmlformats.org/drawingml/2006/main" prst="roundRect">
-            <a:avLst>
-              <a:gd name="adj" fmla="val 7143"/>
-            </a:avLst>
-          </a:prstGeom>
-          <a:solidFill xmlns:a="http://schemas.openxmlformats.org/drawingml/2006/main">
-            <a:srgbClr val="F7F5F2"/>
-          </a:solidFill>
-          <a:ln xmlns:a="http://schemas.openxmlformats.org/drawingml/2006/main" w="9525">
-            <a:solidFill>
-              <a:srgbClr val="DED8D1"/>
-            </a:solidFill>
-            <a:prstDash val="solid"/>
-          </a:ln>
-        </p:spPr>
-      </p:sp>
-      <p:sp>
-        <p:nvSpPr>
-          <p:cNvPr id="31" name="">
-            <a:extLst xmlns:a="http://schemas.openxmlformats.org/drawingml/2006/main">
-              <a:ext uri="{FF2B5EF4-FFF2-40B4-BE49-F238E27FC236}">
-                <a16:creationId xmlns:a16="http://schemas.microsoft.com/office/drawing/2014/main" id="{93C6EC43-4FE8-4F0E-A6FA-2E0342998E5E}"/>
-              </a:ext>
-            </a:extLst>
-          </p:cNvPr>
-          <p:cNvSpPr>
-            <a:spLocks xmlns:a="http://schemas.openxmlformats.org/drawingml/2006/main" noGrp="1"/>
-          </p:cNvSpPr>
-          <p:nvPr/>
-        </p:nvSpPr>
-        <p:spPr>
-          <a:xfrm xmlns:a="http://schemas.openxmlformats.org/drawingml/2006/main">
-            <a:off x="1066800" y="4038600"/>
-            <a:ext cx="9010650" cy="552450"/>
-          </a:xfrm>
-          <a:prstGeom xmlns:a="http://schemas.openxmlformats.org/drawingml/2006/main" prst="rect">
-            <a:avLst/>
-          </a:prstGeom>
-          <a:solidFill xmlns:a="http://schemas.openxmlformats.org/drawingml/2006/main">
-            <a:srgbClr val="000000">
-              <a:alpha val="0"/>
-            </a:srgbClr>
-          </a:solidFill>
-          <a:ln xmlns:a="http://schemas.openxmlformats.org/drawingml/2006/main" w="0">
-            <a:solidFill>
-              <a:srgbClr val="000000">
-                <a:alpha val="0"/>
-              </a:srgbClr>
-            </a:solidFill>
-            <a:prstDash val="solid"/>
-          </a:ln>
-        </p:spPr>
-        <p:txBody>
-          <a:bodyPr xmlns:a="http://schemas.openxmlformats.org/drawingml/2006/main" lIns="0" tIns="0" rIns="0" bIns="0" anchor="t"/>
-          <a:lstStyle xmlns:a="http://schemas.openxmlformats.org/drawingml/2006/main"/>
-          <a:p xmlns:a="http://schemas.openxmlformats.org/drawingml/2006/main">
-            <a:pPr algn="l">
-              <a:defRPr sz="1575" b="1">
-                <a:solidFill>
-                  <a:srgbClr val="2B2B2B"/>
-                </a:solidFill>
-                <a:latin typeface="Aptos"/>
-                <a:ea typeface="Aptos"/>
-                <a:cs typeface="Aptos"/>
-              </a:defRPr>
-            </a:pPr>
-            <a:r>
-              <a:rPr sz="1575" b="1">
-                <a:solidFill>
-                  <a:srgbClr val="2B2B2B"/>
-                </a:solidFill>
-                <a:latin typeface="Aptos"/>
-                <a:ea typeface="Aptos"/>
-                <a:cs typeface="Aptos"/>
-              </a:rPr>
-              <a:t>Talk move: show this slide as the finite-sample reason for the method. The estimator is not just theoretically neat; it is strongest where target IPD is most expensive.</a:t>
             </a:r>
           </a:p>
         </p:txBody>

</xml_diff>